<commit_message>
PPT: replace website appearance text with full-page screenshots
Co-authored-by: kelompok8ai <kelompok8ai@users.noreply.github.com>
</commit_message>
<xml_diff>
--- a/CorpSec-Bank-Sumut-Presentasi.pptx
+++ b/CorpSec-Bank-Sumut-Presentasi.pptx
@@ -18,6 +18,7 @@
     <p:sldId id="266" r:id="rId17"/>
     <p:sldId id="267" r:id="rId18"/>
     <p:sldId id="268" r:id="rId19"/>
+    <p:sldId id="269" r:id="rId20"/>
   </p:sldIdLst>
   <p:sldSz cx="12191695" cy="6858000" type="screen4x3"/>
   <p:notesSz cx="6858000" cy="9144000"/>
@@ -3480,7 +3481,7 @@
               </a:defRPr>
             </a:pPr>
             <a:r>
-              <a:t>Perbaikan Aspek User Experience</a:t>
+              <a:t>Alur Kerja Memorandum</a:t>
             </a:r>
           </a:p>
           <a:p>
@@ -3495,144 +3496,21 @@
               </a:defRPr>
             </a:pPr>
             <a:r>
-              <a:t>Yang sudah diterapkan dan rencana perbaikan</a:t>
-            </a:r>
-          </a:p>
-        </p:txBody>
-      </p:sp>
-      <p:sp>
-        <p:nvSpPr>
-          <p:cNvPr id="4" name="Rounded Rectangle 3"/>
-          <p:cNvSpPr/>
-          <p:nvPr/>
-        </p:nvSpPr>
-        <p:spPr>
-          <a:xfrm>
-            <a:off x="411480" y="1325880"/>
-            <a:ext cx="5394960" cy="4572000"/>
-          </a:xfrm>
-          <a:prstGeom prst="roundRect">
-            <a:avLst/>
-          </a:prstGeom>
-          <a:solidFill>
-            <a:srgbClr val="FFFFFF"/>
-          </a:solidFill>
-          <a:ln>
-            <a:solidFill>
-              <a:srgbClr val="E2E8F0"/>
-            </a:solidFill>
-          </a:ln>
-        </p:spPr>
-        <p:style>
-          <a:lnRef idx="1">
-            <a:schemeClr val="accent1"/>
-          </a:lnRef>
-          <a:fillRef idx="3">
-            <a:schemeClr val="accent1"/>
-          </a:fillRef>
-          <a:effectRef idx="2">
-            <a:schemeClr val="accent1"/>
-          </a:effectRef>
-          <a:fontRef idx="minor">
-            <a:schemeClr val="lt1"/>
-          </a:fontRef>
-        </p:style>
-        <p:txBody>
-          <a:bodyPr rtlCol="0" anchor="ctr"/>
-          <a:lstStyle/>
-          <a:p>
-            <a:pPr algn="ctr"/>
-          </a:p>
-        </p:txBody>
-      </p:sp>
-      <p:sp>
-        <p:nvSpPr>
-          <p:cNvPr id="5" name="Rectangle 4"/>
-          <p:cNvSpPr/>
-          <p:nvPr/>
-        </p:nvSpPr>
-        <p:spPr>
-          <a:xfrm>
-            <a:off x="411480" y="1325880"/>
-            <a:ext cx="5394960" cy="475488"/>
-          </a:xfrm>
-          <a:prstGeom prst="rect">
-            <a:avLst/>
-          </a:prstGeom>
-          <a:solidFill>
-            <a:srgbClr val="059669"/>
-          </a:solidFill>
-          <a:ln>
-            <a:noFill/>
-          </a:ln>
-        </p:spPr>
-        <p:style>
-          <a:lnRef idx="1">
-            <a:schemeClr val="accent1"/>
-          </a:lnRef>
-          <a:fillRef idx="3">
-            <a:schemeClr val="accent1"/>
-          </a:fillRef>
-          <a:effectRef idx="2">
-            <a:schemeClr val="accent1"/>
-          </a:effectRef>
-          <a:fontRef idx="minor">
-            <a:schemeClr val="lt1"/>
-          </a:fontRef>
-        </p:style>
-        <p:txBody>
-          <a:bodyPr rtlCol="0" anchor="ctr"/>
-          <a:lstStyle/>
-          <a:p>
-            <a:pPr algn="ctr"/>
-          </a:p>
-        </p:txBody>
-      </p:sp>
-      <p:sp>
-        <p:nvSpPr>
-          <p:cNvPr id="6" name="TextBox 5"/>
+              <a:t>7 tahap persetujuan sesuai PRD</a:t>
+            </a:r>
+          </a:p>
+        </p:txBody>
+      </p:sp>
+      <p:sp>
+        <p:nvSpPr>
+          <p:cNvPr id="4" name="TextBox 3"/>
           <p:cNvSpPr txBox="1"/>
           <p:nvPr/>
         </p:nvSpPr>
         <p:spPr>
           <a:xfrm>
-            <a:off x="594360" y="1399032"/>
-            <a:ext cx="5029200" cy="365760"/>
-          </a:xfrm>
-          <a:prstGeom prst="rect">
-            <a:avLst/>
-          </a:prstGeom>
-          <a:noFill/>
-        </p:spPr>
-        <p:txBody>
-          <a:bodyPr wrap="none">
-            <a:spAutoFit/>
-          </a:bodyPr>
-          <a:lstStyle/>
-          <a:p>
-            <a:pPr>
-              <a:defRPr sz="1600" b="1">
-                <a:solidFill>
-                  <a:srgbClr val="FFFFFF"/>
-                </a:solidFill>
-              </a:defRPr>
-            </a:pPr>
-            <a:r>
-              <a:t>Sudah Diterapkan</a:t>
-            </a:r>
-          </a:p>
-        </p:txBody>
-      </p:sp>
-      <p:sp>
-        <p:nvSpPr>
-          <p:cNvPr id="7" name="TextBox 6"/>
-          <p:cNvSpPr txBox="1"/>
-          <p:nvPr/>
-        </p:nvSpPr>
-        <p:spPr>
-          <a:xfrm>
-            <a:off x="594360" y="1920240"/>
-            <a:ext cx="5029200" cy="3886200"/>
+            <a:off x="502920" y="1371600"/>
+            <a:ext cx="11155680" cy="4846320"/>
           </a:xfrm>
           <a:prstGeom prst="rect">
             <a:avLst/>
@@ -3646,395 +3524,135 @@
           <a:lstStyle/>
           <a:p>
             <a:pPr>
+              <a:lnSpc>
+                <a:spcPct val="120000"/>
+              </a:lnSpc>
               <a:spcAft>
-                <a:spcPts val="600"/>
+                <a:spcPts val="1200"/>
               </a:spcAft>
-              <a:defRPr sz="1400">
+              <a:defRPr sz="2000">
                 <a:solidFill>
                   <a:srgbClr val="1E293B"/>
                 </a:solidFill>
               </a:defRPr>
             </a:pPr>
             <a:r>
-              <a:t>Desain UI mengikuti identitas Bank Sumut (navy &amp; oranye)</a:t>
-            </a:r>
-          </a:p>
-          <a:p>
-            <a:pPr>
+              <a:t>1. Divisi Pengusul — kirim memorandum PDF</a:t>
+            </a:r>
+          </a:p>
+          <a:p>
+            <a:pPr>
+              <a:lnSpc>
+                <a:spcPct val="120000"/>
+              </a:lnSpc>
               <a:spcAft>
-                <a:spcPts val="600"/>
+                <a:spcPts val="1200"/>
               </a:spcAft>
-              <a:defRPr sz="1400">
+              <a:defRPr sz="2000">
                 <a:solidFill>
                   <a:srgbClr val="1E293B"/>
                 </a:solidFill>
               </a:defRPr>
             </a:pPr>
             <a:r>
-              <a:t>Login page dengan hero image &amp; akun demo cepat</a:t>
-            </a:r>
-          </a:p>
-          <a:p>
-            <a:pPr>
+              <a:t>2. Corporate Secretary — terima, rangkum, &amp; tinjau kelengkapan</a:t>
+            </a:r>
+          </a:p>
+          <a:p>
+            <a:pPr>
+              <a:lnSpc>
+                <a:spcPct val="120000"/>
+              </a:lnSpc>
               <a:spcAft>
-                <a:spcPts val="600"/>
+                <a:spcPts val="1200"/>
               </a:spcAft>
-              <a:defRPr sz="1400">
+              <a:defRPr sz="2000">
                 <a:solidFill>
                   <a:srgbClr val="1E293B"/>
                 </a:solidFill>
               </a:defRPr>
             </a:pPr>
             <a:r>
-              <a:t>Navigasi sidebar per role — tidak membingungkan</a:t>
-            </a:r>
-          </a:p>
-          <a:p>
-            <a:pPr>
+              <a:t>3. Pemimpin Bidang — setujui atau tolak + tanda tangan</a:t>
+            </a:r>
+          </a:p>
+          <a:p>
+            <a:pPr>
+              <a:lnSpc>
+                <a:spcPct val="120000"/>
+              </a:lnSpc>
               <a:spcAft>
-                <a:spcPts val="600"/>
+                <a:spcPts val="1200"/>
               </a:spcAft>
-              <a:defRPr sz="1400">
+              <a:defRPr sz="2000">
                 <a:solidFill>
                   <a:srgbClr val="1E293B"/>
                 </a:solidFill>
               </a:defRPr>
             </a:pPr>
             <a:r>
-              <a:t>Workflow stepper visual di detail memorandum</a:t>
-            </a:r>
-          </a:p>
-          <a:p>
-            <a:pPr>
+              <a:t>4. Sekretaris Direksi/Komisaris — teruskan ke pimpinan</a:t>
+            </a:r>
+          </a:p>
+          <a:p>
+            <a:pPr>
+              <a:lnSpc>
+                <a:spcPct val="120000"/>
+              </a:lnSpc>
               <a:spcAft>
-                <a:spcPts val="600"/>
+                <a:spcPts val="1200"/>
               </a:spcAft>
-              <a:defRPr sz="1400">
+              <a:defRPr sz="2000">
                 <a:solidFill>
                   <a:srgbClr val="1E293B"/>
                 </a:solidFill>
               </a:defRPr>
             </a:pPr>
             <a:r>
-              <a:t>Indikator baca (belum/sudah dibaca) pada daftar memo</a:t>
-            </a:r>
-          </a:p>
-          <a:p>
-            <a:pPr>
+              <a:t>5. Direksi / Komisaris — beri keputusan</a:t>
+            </a:r>
+          </a:p>
+          <a:p>
+            <a:pPr>
+              <a:lnSpc>
+                <a:spcPct val="120000"/>
+              </a:lnSpc>
               <a:spcAft>
-                <a:spcPts val="600"/>
+                <a:spcPts val="1200"/>
               </a:spcAft>
-              <a:defRPr sz="1400">
+              <a:defRPr sz="2000">
                 <a:solidFill>
                   <a:srgbClr val="1E293B"/>
                 </a:solidFill>
               </a:defRPr>
             </a:pPr>
             <a:r>
-              <a:t>Dashboard hero banner &amp; stat cards informatif</a:t>
-            </a:r>
-          </a:p>
-          <a:p>
-            <a:pPr>
+              <a:t>6. CorpSec — finalisasi sesuai keputusan board</a:t>
+            </a:r>
+          </a:p>
+          <a:p>
+            <a:pPr>
+              <a:lnSpc>
+                <a:spcPct val="120000"/>
+              </a:lnSpc>
               <a:spcAft>
-                <a:spcPts val="600"/>
+                <a:spcPts val="1200"/>
               </a:spcAft>
-              <a:defRPr sz="1400">
+              <a:defRPr sz="2000">
                 <a:solidFill>
                   <a:srgbClr val="1E293B"/>
                 </a:solidFill>
               </a:defRPr>
             </a:pPr>
             <a:r>
-              <a:t>Redirect otomatis ke halaman sesuai role setelah login</a:t>
-            </a:r>
-          </a:p>
-          <a:p>
-            <a:pPr>
-              <a:spcAft>
-                <a:spcPts val="600"/>
-              </a:spcAft>
-              <a:defRPr sz="1400">
-                <a:solidFill>
-                  <a:srgbClr val="1E293B"/>
-                </a:solidFill>
-              </a:defRPr>
-            </a:pPr>
-            <a:r>
-              <a:t>Sidebar mobile dengan menu hamburger</a:t>
-            </a:r>
-          </a:p>
-        </p:txBody>
-      </p:sp>
-      <p:sp>
-        <p:nvSpPr>
-          <p:cNvPr id="8" name="Rounded Rectangle 7"/>
-          <p:cNvSpPr/>
-          <p:nvPr/>
-        </p:nvSpPr>
-        <p:spPr>
-          <a:xfrm>
-            <a:off x="6263640" y="1325880"/>
-            <a:ext cx="5394960" cy="4572000"/>
-          </a:xfrm>
-          <a:prstGeom prst="roundRect">
-            <a:avLst/>
-          </a:prstGeom>
-          <a:solidFill>
-            <a:srgbClr val="FFFFFF"/>
-          </a:solidFill>
-          <a:ln>
-            <a:solidFill>
-              <a:srgbClr val="E2E8F0"/>
-            </a:solidFill>
-          </a:ln>
-        </p:spPr>
-        <p:style>
-          <a:lnRef idx="1">
-            <a:schemeClr val="accent1"/>
-          </a:lnRef>
-          <a:fillRef idx="3">
-            <a:schemeClr val="accent1"/>
-          </a:fillRef>
-          <a:effectRef idx="2">
-            <a:schemeClr val="accent1"/>
-          </a:effectRef>
-          <a:fontRef idx="minor">
-            <a:schemeClr val="lt1"/>
-          </a:fontRef>
-        </p:style>
-        <p:txBody>
-          <a:bodyPr rtlCol="0" anchor="ctr"/>
-          <a:lstStyle/>
-          <a:p>
-            <a:pPr algn="ctr"/>
-          </a:p>
-        </p:txBody>
-      </p:sp>
-      <p:sp>
-        <p:nvSpPr>
-          <p:cNvPr id="9" name="Rectangle 8"/>
-          <p:cNvSpPr/>
-          <p:nvPr/>
-        </p:nvSpPr>
-        <p:spPr>
-          <a:xfrm>
-            <a:off x="6263640" y="1325880"/>
-            <a:ext cx="5394960" cy="475488"/>
-          </a:xfrm>
-          <a:prstGeom prst="rect">
-            <a:avLst/>
-          </a:prstGeom>
-          <a:solidFill>
-            <a:srgbClr val="F58220"/>
-          </a:solidFill>
-          <a:ln>
-            <a:noFill/>
-          </a:ln>
-        </p:spPr>
-        <p:style>
-          <a:lnRef idx="1">
-            <a:schemeClr val="accent1"/>
-          </a:lnRef>
-          <a:fillRef idx="3">
-            <a:schemeClr val="accent1"/>
-          </a:fillRef>
-          <a:effectRef idx="2">
-            <a:schemeClr val="accent1"/>
-          </a:effectRef>
-          <a:fontRef idx="minor">
-            <a:schemeClr val="lt1"/>
-          </a:fontRef>
-        </p:style>
-        <p:txBody>
-          <a:bodyPr rtlCol="0" anchor="ctr"/>
-          <a:lstStyle/>
-          <a:p>
-            <a:pPr algn="ctr"/>
-          </a:p>
-        </p:txBody>
-      </p:sp>
-      <p:sp>
-        <p:nvSpPr>
-          <p:cNvPr id="10" name="TextBox 9"/>
-          <p:cNvSpPr txBox="1"/>
-          <p:nvPr/>
-        </p:nvSpPr>
-        <p:spPr>
-          <a:xfrm>
-            <a:off x="6446520" y="1399032"/>
-            <a:ext cx="5029200" cy="365760"/>
-          </a:xfrm>
-          <a:prstGeom prst="rect">
-            <a:avLst/>
-          </a:prstGeom>
-          <a:noFill/>
-        </p:spPr>
-        <p:txBody>
-          <a:bodyPr wrap="none">
-            <a:spAutoFit/>
-          </a:bodyPr>
-          <a:lstStyle/>
-          <a:p>
-            <a:pPr>
-              <a:defRPr sz="1600" b="1">
-                <a:solidFill>
-                  <a:srgbClr val="FFFFFF"/>
-                </a:solidFill>
-              </a:defRPr>
-            </a:pPr>
-            <a:r>
-              <a:t>Rencana Perbaikan UX</a:t>
-            </a:r>
-          </a:p>
-        </p:txBody>
-      </p:sp>
-      <p:sp>
-        <p:nvSpPr>
-          <p:cNvPr id="11" name="TextBox 10"/>
-          <p:cNvSpPr txBox="1"/>
-          <p:nvPr/>
-        </p:nvSpPr>
-        <p:spPr>
-          <a:xfrm>
-            <a:off x="6446520" y="1920240"/>
-            <a:ext cx="5029200" cy="3886200"/>
-          </a:xfrm>
-          <a:prstGeom prst="rect">
-            <a:avLst/>
-          </a:prstGeom>
-          <a:noFill/>
-        </p:spPr>
-        <p:txBody>
-          <a:bodyPr wrap="square">
-            <a:spAutoFit/>
-          </a:bodyPr>
-          <a:lstStyle/>
-          <a:p>
-            <a:pPr>
-              <a:spcAft>
-                <a:spcPts val="600"/>
-              </a:spcAft>
-              <a:defRPr sz="1400">
-                <a:solidFill>
-                  <a:srgbClr val="1E293B"/>
-                </a:solidFill>
-              </a:defRPr>
-            </a:pPr>
-            <a:r>
-              <a:t>Notifikasi real-time (toast &amp; badge) saat ada dokumen baru</a:t>
-            </a:r>
-          </a:p>
-          <a:p>
-            <a:pPr>
-              <a:spcAft>
-                <a:spcPts val="600"/>
-              </a:spcAft>
-              <a:defRPr sz="1400">
-                <a:solidFill>
-                  <a:srgbClr val="1E293B"/>
-                </a:solidFill>
-              </a:defRPr>
-            </a:pPr>
-            <a:r>
-              <a:t>Loading state &amp; feedback saat upload PDF</a:t>
-            </a:r>
-          </a:p>
-          <a:p>
-            <a:pPr>
-              <a:spcAft>
-                <a:spcPts val="600"/>
-              </a:spcAft>
-              <a:defRPr sz="1400">
-                <a:solidFill>
-                  <a:srgbClr val="1E293B"/>
-                </a:solidFill>
-              </a:defRPr>
-            </a:pPr>
-            <a:r>
-              <a:t>Halaman error yang lebih informatif</a:t>
-            </a:r>
-          </a:p>
-          <a:p>
-            <a:pPr>
-              <a:spcAft>
-                <a:spcPts val="600"/>
-              </a:spcAft>
-              <a:defRPr sz="1400">
-                <a:solidFill>
-                  <a:srgbClr val="1E293B"/>
-                </a:solidFill>
-              </a:defRPr>
-            </a:pPr>
-            <a:r>
-              <a:t>Pencarian &amp; filter di daftar memorandum</a:t>
-            </a:r>
-          </a:p>
-          <a:p>
-            <a:pPr>
-              <a:spcAft>
-                <a:spcPts val="600"/>
-              </a:spcAft>
-              <a:defRPr sz="1400">
-                <a:solidFill>
-                  <a:srgbClr val="1E293B"/>
-                </a:solidFill>
-              </a:defRPr>
-            </a:pPr>
-            <a:r>
-              <a:t>Mode gelap (dark mode) opsional</a:t>
-            </a:r>
-          </a:p>
-          <a:p>
-            <a:pPr>
-              <a:spcAft>
-                <a:spcPts val="600"/>
-              </a:spcAft>
-              <a:defRPr sz="1400">
-                <a:solidFill>
-                  <a:srgbClr val="1E293B"/>
-                </a:solidFill>
-              </a:defRPr>
-            </a:pPr>
-            <a:r>
-              <a:t>Panduan singkat (onboarding) untuk user baru</a:t>
-            </a:r>
-          </a:p>
-          <a:p>
-            <a:pPr>
-              <a:spcAft>
-                <a:spcPts val="600"/>
-              </a:spcAft>
-              <a:defRPr sz="1400">
-                <a:solidFill>
-                  <a:srgbClr val="1E293B"/>
-                </a:solidFill>
-              </a:defRPr>
-            </a:pPr>
-            <a:r>
-              <a:t>Optimasi tampilan tablet &amp; HP</a:t>
-            </a:r>
-          </a:p>
-          <a:p>
-            <a:pPr>
-              <a:spcAft>
-                <a:spcPts val="600"/>
-              </a:spcAft>
-              <a:defRPr sz="1400">
-                <a:solidFill>
-                  <a:srgbClr val="1E293B"/>
-                </a:solidFill>
-              </a:defRPr>
-            </a:pPr>
-            <a:r>
-              <a:t>Akses cepat ke rapat &amp; media dari sidebar CorpSec</a:t>
-            </a:r>
-          </a:p>
-        </p:txBody>
-      </p:sp>
-      <p:sp>
-        <p:nvSpPr>
-          <p:cNvPr id="12" name="Rectangle 11"/>
+              <a:t>7. Kembali ke Pengusul — pemberitahuan hasil akhir</a:t>
+            </a:r>
+          </a:p>
+        </p:txBody>
+      </p:sp>
+      <p:sp>
+        <p:nvSpPr>
+          <p:cNvPr id="5" name="Rectangle 4"/>
           <p:cNvSpPr/>
           <p:nvPr/>
         </p:nvSpPr>
@@ -4077,7 +3695,7 @@
       </p:sp>
       <p:sp>
         <p:nvSpPr>
-          <p:cNvPr id="13" name="TextBox 12"/>
+          <p:cNvPr id="6" name="TextBox 5"/>
           <p:cNvSpPr txBox="1"/>
           <p:nvPr/>
         </p:nvSpPr>
@@ -4112,7 +3730,7 @@
       </p:sp>
       <p:sp>
         <p:nvSpPr>
-          <p:cNvPr id="14" name="TextBox 13"/>
+          <p:cNvPr id="7" name="TextBox 6"/>
           <p:cNvSpPr txBox="1"/>
           <p:nvPr/>
         </p:nvSpPr>
@@ -4244,7 +3862,7 @@
               </a:defRPr>
             </a:pPr>
             <a:r>
-              <a:t>Perbaikan Aspek Keamanan</a:t>
+              <a:t>Perbaikan Aspek User Experience</a:t>
             </a:r>
           </a:p>
           <a:p>
@@ -4259,7 +3877,7 @@
               </a:defRPr>
             </a:pPr>
             <a:r>
-              <a:t>Kondisi saat ini dan langkah penguatan</a:t>
+              <a:t>Yang sudah diterapkan dan rencana perbaikan</a:t>
             </a:r>
           </a:p>
         </p:txBody>
@@ -4420,7 +4038,7 @@
               </a:defRPr>
             </a:pPr>
             <a:r>
-              <a:t>Login wajib — halaman dilindungi middleware</a:t>
+              <a:t>Desain UI mengikuti identitas Bank Sumut (navy &amp; oranye)</a:t>
             </a:r>
           </a:p>
           <a:p>
@@ -4435,7 +4053,7 @@
               </a:defRPr>
             </a:pPr>
             <a:r>
-              <a:t>Pembagian akses per role (RBAC 7 level)</a:t>
+              <a:t>Login page dengan hero image &amp; akun demo cepat</a:t>
             </a:r>
           </a:p>
           <a:p>
@@ -4450,7 +4068,7 @@
               </a:defRPr>
             </a:pPr>
             <a:r>
-              <a:t>Cookie session httpOnly &amp; sameSite=lax</a:t>
+              <a:t>Navigasi sidebar per role — tidak membingungkan</a:t>
             </a:r>
           </a:p>
           <a:p>
@@ -4465,7 +4083,7 @@
               </a:defRPr>
             </a:pPr>
             <a:r>
-              <a:t>API memorandum dicek role sebelum aksi (requireApiRole)</a:t>
+              <a:t>Workflow stepper visual di detail memorandum</a:t>
             </a:r>
           </a:p>
           <a:p>
@@ -4480,7 +4098,7 @@
               </a:defRPr>
             </a:pPr>
             <a:r>
-              <a:t>Redirect otomatis jika akses halaman tidak sesuai role</a:t>
+              <a:t>Indikator baca (belum/sudah dibaca) pada daftar memo</a:t>
             </a:r>
           </a:p>
           <a:p>
@@ -4495,7 +4113,37 @@
               </a:defRPr>
             </a:pPr>
             <a:r>
-              <a:t>Validasi file upload (format PDF, batas ukuran)</a:t>
+              <a:t>Dashboard hero banner &amp; stat cards informatif</a:t>
+            </a:r>
+          </a:p>
+          <a:p>
+            <a:pPr>
+              <a:spcAft>
+                <a:spcPts val="600"/>
+              </a:spcAft>
+              <a:defRPr sz="1400">
+                <a:solidFill>
+                  <a:srgbClr val="1E293B"/>
+                </a:solidFill>
+              </a:defRPr>
+            </a:pPr>
+            <a:r>
+              <a:t>Redirect otomatis ke halaman sesuai role setelah login</a:t>
+            </a:r>
+          </a:p>
+          <a:p>
+            <a:pPr>
+              <a:spcAft>
+                <a:spcPts val="600"/>
+              </a:spcAft>
+              <a:defRPr sz="1400">
+                <a:solidFill>
+                  <a:srgbClr val="1E293B"/>
+                </a:solidFill>
+              </a:defRPr>
+            </a:pPr>
+            <a:r>
+              <a:t>Sidebar mobile dengan menu hamburger</a:t>
             </a:r>
           </a:p>
         </p:txBody>
@@ -4560,7 +4208,7 @@
             <a:avLst/>
           </a:prstGeom>
           <a:solidFill>
-            <a:srgbClr val="DC2626"/>
+            <a:srgbClr val="F58220"/>
           </a:solidFill>
           <a:ln>
             <a:noFill/>
@@ -4618,7 +4266,7 @@
               </a:defRPr>
             </a:pPr>
             <a:r>
-              <a:t>Perlu Ditingkatkan</a:t>
+              <a:t>Rencana Perbaikan UX</a:t>
             </a:r>
           </a:p>
         </p:txBody>
@@ -4656,7 +4304,7 @@
               </a:defRPr>
             </a:pPr>
             <a:r>
-              <a:t>Session cookie perlu ditandatangani (JWT/signed cookie)</a:t>
+              <a:t>Notifikasi real-time (toast &amp; badge) saat ada dokumen baru</a:t>
             </a:r>
           </a:p>
           <a:p>
@@ -4671,7 +4319,7 @@
               </a:defRPr>
             </a:pPr>
             <a:r>
-              <a:t>Password disimpan plaintext — perlu bcrypt/hash</a:t>
+              <a:t>Loading state &amp; feedback saat upload PDF</a:t>
             </a:r>
           </a:p>
           <a:p>
@@ -4686,7 +4334,7 @@
               </a:defRPr>
             </a:pPr>
             <a:r>
-              <a:t>Belum ada rate limiting pada login</a:t>
+              <a:t>Halaman error yang lebih informatif</a:t>
             </a:r>
           </a:p>
           <a:p>
@@ -4701,7 +4349,7 @@
               </a:defRPr>
             </a:pPr>
             <a:r>
-              <a:t>Belum ada security headers (CSP, HSTS, X-Frame)</a:t>
+              <a:t>Pencarian &amp; filter di daftar memorandum</a:t>
             </a:r>
           </a:p>
           <a:p>
@@ -4716,7 +4364,7 @@
               </a:defRPr>
             </a:pPr>
             <a:r>
-              <a:t>Belum ada audit log aktivitas user</a:t>
+              <a:t>Mode gelap (dark mode) opsional</a:t>
             </a:r>
           </a:p>
           <a:p>
@@ -4731,7 +4379,7 @@
               </a:defRPr>
             </a:pPr>
             <a:r>
-              <a:t>Perlu validasi input lebih ketat di semua API</a:t>
+              <a:t>Panduan singkat (onboarding) untuk user baru</a:t>
             </a:r>
           </a:p>
           <a:p>
@@ -4746,7 +4394,7 @@
               </a:defRPr>
             </a:pPr>
             <a:r>
-              <a:t>Enkripsi file PDF di storage server</a:t>
+              <a:t>Optimasi tampilan tablet &amp; HP</a:t>
             </a:r>
           </a:p>
           <a:p>
@@ -4761,7 +4409,7 @@
               </a:defRPr>
             </a:pPr>
             <a:r>
-              <a:t>Integrasi SSO Active Directory Bank Sumut</a:t>
+              <a:t>Akses cepat ke rapat &amp; media dari sidebar CorpSec</a:t>
             </a:r>
           </a:p>
         </p:txBody>
@@ -4978,7 +4626,7 @@
               </a:defRPr>
             </a:pPr>
             <a:r>
-              <a:t>Rencana Langkah Selanjutnya</a:t>
+              <a:t>Perbaikan Aspek Keamanan</a:t>
             </a:r>
           </a:p>
           <a:p>
@@ -4993,7 +4641,7 @@
               </a:defRPr>
             </a:pPr>
             <a:r>
-              <a:t>Prioritas pengembangan ke depan</a:t>
+              <a:t>Kondisi saat ini dan langkah penguatan</a:t>
             </a:r>
           </a:p>
         </p:txBody>
@@ -5006,8 +4654,8 @@
         </p:nvSpPr>
         <p:spPr>
           <a:xfrm>
-            <a:off x="411480" y="1417320"/>
-            <a:ext cx="3657600" cy="4434840"/>
+            <a:off x="411480" y="1325880"/>
+            <a:ext cx="5394960" cy="4572000"/>
           </a:xfrm>
           <a:prstGeom prst="roundRect">
             <a:avLst/>
@@ -5051,14 +4699,14 @@
         </p:nvSpPr>
         <p:spPr>
           <a:xfrm>
-            <a:off x="411480" y="1417320"/>
-            <a:ext cx="3657600" cy="475488"/>
+            <a:off x="411480" y="1325880"/>
+            <a:ext cx="5394960" cy="475488"/>
           </a:xfrm>
           <a:prstGeom prst="rect">
             <a:avLst/>
           </a:prstGeom>
           <a:solidFill>
-            <a:srgbClr val="0C2340"/>
+            <a:srgbClr val="059669"/>
           </a:solidFill>
           <a:ln>
             <a:noFill/>
@@ -5094,8 +4742,8 @@
         </p:nvSpPr>
         <p:spPr>
           <a:xfrm>
-            <a:off x="594360" y="1490472"/>
-            <a:ext cx="3291840" cy="365760"/>
+            <a:off x="594360" y="1399032"/>
+            <a:ext cx="5029200" cy="365760"/>
           </a:xfrm>
           <a:prstGeom prst="rect">
             <a:avLst/>
@@ -5116,7 +4764,7 @@
               </a:defRPr>
             </a:pPr>
             <a:r>
-              <a:t>Fase 1 — Stabilisasi</a:t>
+              <a:t>Sudah Diterapkan</a:t>
             </a:r>
           </a:p>
         </p:txBody>
@@ -5129,8 +4777,8 @@
         </p:nvSpPr>
         <p:spPr>
           <a:xfrm>
-            <a:off x="594360" y="2011680"/>
-            <a:ext cx="3291840" cy="3749039"/>
+            <a:off x="594360" y="1920240"/>
+            <a:ext cx="5029200" cy="3886200"/>
           </a:xfrm>
           <a:prstGeom prst="rect">
             <a:avLst/>
@@ -5154,7 +4802,7 @@
               </a:defRPr>
             </a:pPr>
             <a:r>
-              <a:t>Perbaiki keamanan: hash password, signed session</a:t>
+              <a:t>Login wajib — halaman dilindungi middleware</a:t>
             </a:r>
           </a:p>
           <a:p>
@@ -5169,7 +4817,7 @@
               </a:defRPr>
             </a:pPr>
             <a:r>
-              <a:t>Tambah rate limiting &amp; security headers</a:t>
+              <a:t>Pembagian akses per role (RBAC 7 level)</a:t>
             </a:r>
           </a:p>
           <a:p>
@@ -5184,7 +4832,7 @@
               </a:defRPr>
             </a:pPr>
             <a:r>
-              <a:t>Lengkapi audit log aktivitas</a:t>
+              <a:t>Cookie session httpOnly &amp; sameSite=lax</a:t>
             </a:r>
           </a:p>
           <a:p>
@@ -5199,7 +4847,37 @@
               </a:defRPr>
             </a:pPr>
             <a:r>
-              <a:t>Uji coba internal dengan user CorpSec</a:t>
+              <a:t>API memorandum dicek role sebelum aksi (requireApiRole)</a:t>
+            </a:r>
+          </a:p>
+          <a:p>
+            <a:pPr>
+              <a:spcAft>
+                <a:spcPts val="600"/>
+              </a:spcAft>
+              <a:defRPr sz="1400">
+                <a:solidFill>
+                  <a:srgbClr val="1E293B"/>
+                </a:solidFill>
+              </a:defRPr>
+            </a:pPr>
+            <a:r>
+              <a:t>Redirect otomatis jika akses halaman tidak sesuai role</a:t>
+            </a:r>
+          </a:p>
+          <a:p>
+            <a:pPr>
+              <a:spcAft>
+                <a:spcPts val="600"/>
+              </a:spcAft>
+              <a:defRPr sz="1400">
+                <a:solidFill>
+                  <a:srgbClr val="1E293B"/>
+                </a:solidFill>
+              </a:defRPr>
+            </a:pPr>
+            <a:r>
+              <a:t>Validasi file upload (format PDF, batas ukuran)</a:t>
             </a:r>
           </a:p>
         </p:txBody>
@@ -5212,8 +4890,8 @@
         </p:nvSpPr>
         <p:spPr>
           <a:xfrm>
-            <a:off x="4297680" y="1417320"/>
-            <a:ext cx="3657600" cy="4434840"/>
+            <a:off x="6263640" y="1325880"/>
+            <a:ext cx="5394960" cy="4572000"/>
           </a:xfrm>
           <a:prstGeom prst="roundRect">
             <a:avLst/>
@@ -5257,14 +4935,14 @@
         </p:nvSpPr>
         <p:spPr>
           <a:xfrm>
-            <a:off x="4297680" y="1417320"/>
-            <a:ext cx="3657600" cy="475488"/>
+            <a:off x="6263640" y="1325880"/>
+            <a:ext cx="5394960" cy="475488"/>
           </a:xfrm>
           <a:prstGeom prst="rect">
             <a:avLst/>
           </a:prstGeom>
           <a:solidFill>
-            <a:srgbClr val="F58220"/>
+            <a:srgbClr val="DC2626"/>
           </a:solidFill>
           <a:ln>
             <a:noFill/>
@@ -5300,8 +4978,8 @@
         </p:nvSpPr>
         <p:spPr>
           <a:xfrm>
-            <a:off x="4480560" y="1490472"/>
-            <a:ext cx="3291840" cy="365760"/>
+            <a:off x="6446520" y="1399032"/>
+            <a:ext cx="5029200" cy="365760"/>
           </a:xfrm>
           <a:prstGeom prst="rect">
             <a:avLst/>
@@ -5322,7 +5000,7 @@
               </a:defRPr>
             </a:pPr>
             <a:r>
-              <a:t>Fase 2 — Peningkatan Fitur</a:t>
+              <a:t>Perlu Ditingkatkan</a:t>
             </a:r>
           </a:p>
         </p:txBody>
@@ -5335,8 +5013,8 @@
         </p:nvSpPr>
         <p:spPr>
           <a:xfrm>
-            <a:off x="4480560" y="2011680"/>
-            <a:ext cx="3291840" cy="3749039"/>
+            <a:off x="6446520" y="1920240"/>
+            <a:ext cx="5029200" cy="3886200"/>
           </a:xfrm>
           <a:prstGeom prst="rect">
             <a:avLst/>
@@ -5360,7 +5038,7 @@
               </a:defRPr>
             </a:pPr>
             <a:r>
-              <a:t>Integrasi LLM nyata untuk tinjauan memorandum</a:t>
+              <a:t>Session cookie perlu ditandatangani (JWT/signed cookie)</a:t>
             </a:r>
           </a:p>
           <a:p>
@@ -5375,7 +5053,7 @@
               </a:defRPr>
             </a:pPr>
             <a:r>
-              <a:t>Notifikasi email/SMS saat approval &amp; SLA breach</a:t>
+              <a:t>Password disimpan plaintext — perlu bcrypt/hash</a:t>
             </a:r>
           </a:p>
           <a:p>
@@ -5390,7 +5068,7 @@
               </a:defRPr>
             </a:pPr>
             <a:r>
-              <a:t>Export laporan PDF/Excel</a:t>
+              <a:t>Belum ada rate limiting pada login</a:t>
             </a:r>
           </a:p>
           <a:p>
@@ -5405,155 +5083,9 @@
               </a:defRPr>
             </a:pPr>
             <a:r>
-              <a:t>Koneksi ke SMD Bank Sumut</a:t>
-            </a:r>
-          </a:p>
-        </p:txBody>
-      </p:sp>
-      <p:sp>
-        <p:nvSpPr>
-          <p:cNvPr id="12" name="Rounded Rectangle 11"/>
-          <p:cNvSpPr/>
-          <p:nvPr/>
-        </p:nvSpPr>
-        <p:spPr>
-          <a:xfrm>
-            <a:off x="8183879" y="1417320"/>
-            <a:ext cx="3657600" cy="4434840"/>
-          </a:xfrm>
-          <a:prstGeom prst="roundRect">
-            <a:avLst/>
-          </a:prstGeom>
-          <a:solidFill>
-            <a:srgbClr val="FFFFFF"/>
-          </a:solidFill>
-          <a:ln>
-            <a:solidFill>
-              <a:srgbClr val="E2E8F0"/>
-            </a:solidFill>
-          </a:ln>
-        </p:spPr>
-        <p:style>
-          <a:lnRef idx="1">
-            <a:schemeClr val="accent1"/>
-          </a:lnRef>
-          <a:fillRef idx="3">
-            <a:schemeClr val="accent1"/>
-          </a:fillRef>
-          <a:effectRef idx="2">
-            <a:schemeClr val="accent1"/>
-          </a:effectRef>
-          <a:fontRef idx="minor">
-            <a:schemeClr val="lt1"/>
-          </a:fontRef>
-        </p:style>
-        <p:txBody>
-          <a:bodyPr rtlCol="0" anchor="ctr"/>
-          <a:lstStyle/>
-          <a:p>
-            <a:pPr algn="ctr"/>
-          </a:p>
-        </p:txBody>
-      </p:sp>
-      <p:sp>
-        <p:nvSpPr>
-          <p:cNvPr id="13" name="Rectangle 12"/>
-          <p:cNvSpPr/>
-          <p:nvPr/>
-        </p:nvSpPr>
-        <p:spPr>
-          <a:xfrm>
-            <a:off x="8183879" y="1417320"/>
-            <a:ext cx="3657600" cy="475488"/>
-          </a:xfrm>
-          <a:prstGeom prst="rect">
-            <a:avLst/>
-          </a:prstGeom>
-          <a:solidFill>
-            <a:srgbClr val="059669"/>
-          </a:solidFill>
-          <a:ln>
-            <a:noFill/>
-          </a:ln>
-        </p:spPr>
-        <p:style>
-          <a:lnRef idx="1">
-            <a:schemeClr val="accent1"/>
-          </a:lnRef>
-          <a:fillRef idx="3">
-            <a:schemeClr val="accent1"/>
-          </a:fillRef>
-          <a:effectRef idx="2">
-            <a:schemeClr val="accent1"/>
-          </a:effectRef>
-          <a:fontRef idx="minor">
-            <a:schemeClr val="lt1"/>
-          </a:fontRef>
-        </p:style>
-        <p:txBody>
-          <a:bodyPr rtlCol="0" anchor="ctr"/>
-          <a:lstStyle/>
-          <a:p>
-            <a:pPr algn="ctr"/>
-          </a:p>
-        </p:txBody>
-      </p:sp>
-      <p:sp>
-        <p:nvSpPr>
-          <p:cNvPr id="14" name="TextBox 13"/>
-          <p:cNvSpPr txBox="1"/>
-          <p:nvPr/>
-        </p:nvSpPr>
-        <p:spPr>
-          <a:xfrm>
-            <a:off x="8366759" y="1490472"/>
-            <a:ext cx="3291840" cy="365760"/>
-          </a:xfrm>
-          <a:prstGeom prst="rect">
-            <a:avLst/>
-          </a:prstGeom>
-          <a:noFill/>
-        </p:spPr>
-        <p:txBody>
-          <a:bodyPr wrap="none">
-            <a:spAutoFit/>
-          </a:bodyPr>
-          <a:lstStyle/>
-          <a:p>
-            <a:pPr>
-              <a:defRPr sz="1600" b="1">
-                <a:solidFill>
-                  <a:srgbClr val="FFFFFF"/>
-                </a:solidFill>
-              </a:defRPr>
-            </a:pPr>
-            <a:r>
-              <a:t>Fase 3 — Go Live</a:t>
-            </a:r>
-          </a:p>
-        </p:txBody>
-      </p:sp>
-      <p:sp>
-        <p:nvSpPr>
-          <p:cNvPr id="15" name="TextBox 14"/>
-          <p:cNvSpPr txBox="1"/>
-          <p:nvPr/>
-        </p:nvSpPr>
-        <p:spPr>
-          <a:xfrm>
-            <a:off x="8366759" y="2011680"/>
-            <a:ext cx="3291840" cy="3749039"/>
-          </a:xfrm>
-          <a:prstGeom prst="rect">
-            <a:avLst/>
-          </a:prstGeom>
-          <a:noFill/>
-        </p:spPr>
-        <p:txBody>
-          <a:bodyPr wrap="square">
-            <a:spAutoFit/>
-          </a:bodyPr>
-          <a:lstStyle/>
+              <a:t>Belum ada security headers (CSP, HSTS, X-Frame)</a:t>
+            </a:r>
+          </a:p>
           <a:p>
             <a:pPr>
               <a:spcAft>
@@ -5566,7 +5098,7 @@
               </a:defRPr>
             </a:pPr>
             <a:r>
-              <a:t>Integrasi SSO Active Directory</a:t>
+              <a:t>Belum ada audit log aktivitas user</a:t>
             </a:r>
           </a:p>
           <a:p>
@@ -5581,7 +5113,7 @@
               </a:defRPr>
             </a:pPr>
             <a:r>
-              <a:t>Migrasi database ke PostgreSQL production</a:t>
+              <a:t>Perlu validasi input lebih ketat di semua API</a:t>
             </a:r>
           </a:p>
           <a:p>
@@ -5596,7 +5128,7 @@
               </a:defRPr>
             </a:pPr>
             <a:r>
-              <a:t>Penetration testing &amp; UAT formal</a:t>
+              <a:t>Enkripsi file PDF di storage server</a:t>
             </a:r>
           </a:p>
           <a:p>
@@ -5611,14 +5143,14 @@
               </a:defRPr>
             </a:pPr>
             <a:r>
-              <a:t>Pelatihan user &amp; rollout ke seluruh divisi</a:t>
-            </a:r>
-          </a:p>
-        </p:txBody>
-      </p:sp>
-      <p:sp>
-        <p:nvSpPr>
-          <p:cNvPr id="16" name="Rectangle 15"/>
+              <a:t>Integrasi SSO Active Directory Bank Sumut</a:t>
+            </a:r>
+          </a:p>
+        </p:txBody>
+      </p:sp>
+      <p:sp>
+        <p:nvSpPr>
+          <p:cNvPr id="12" name="Rectangle 11"/>
           <p:cNvSpPr/>
           <p:nvPr/>
         </p:nvSpPr>
@@ -5661,7 +5193,7 @@
       </p:sp>
       <p:sp>
         <p:nvSpPr>
-          <p:cNvPr id="17" name="TextBox 16"/>
+          <p:cNvPr id="13" name="TextBox 12"/>
           <p:cNvSpPr txBox="1"/>
           <p:nvPr/>
         </p:nvSpPr>
@@ -5696,7 +5228,7 @@
       </p:sp>
       <p:sp>
         <p:nvSpPr>
-          <p:cNvPr id="18" name="TextBox 17"/>
+          <p:cNvPr id="14" name="TextBox 13"/>
           <p:cNvSpPr txBox="1"/>
           <p:nvPr/>
         </p:nvSpPr>
@@ -5738,6 +5270,856 @@
 </file>
 
 <file path=ppt/slides/slide13.xml><?xml version="1.0" encoding="utf-8"?>
+<p:sld xmlns:a="http://schemas.openxmlformats.org/drawingml/2006/main" xmlns:p="http://schemas.openxmlformats.org/presentationml/2006/main" xmlns:r="http://schemas.openxmlformats.org/officeDocument/2006/relationships">
+  <p:cSld>
+    <p:bg>
+      <p:bgPr>
+        <a:solidFill>
+          <a:srgbClr val="F8FAFC"/>
+        </a:solidFill>
+        <a:effectLst/>
+      </p:bgPr>
+    </p:bg>
+    <p:spTree>
+      <p:nvGrpSpPr>
+        <p:cNvPr id="1" name=""/>
+        <p:cNvGrpSpPr/>
+        <p:nvPr/>
+      </p:nvGrpSpPr>
+      <p:grpSpPr/>
+      <p:sp>
+        <p:nvSpPr>
+          <p:cNvPr id="2" name="Rectangle 1"/>
+          <p:cNvSpPr/>
+          <p:nvPr/>
+        </p:nvSpPr>
+        <p:spPr>
+          <a:xfrm>
+            <a:off x="0" y="0"/>
+            <a:ext cx="164592" cy="6446520"/>
+          </a:xfrm>
+          <a:prstGeom prst="rect">
+            <a:avLst/>
+          </a:prstGeom>
+          <a:solidFill>
+            <a:srgbClr val="F58220"/>
+          </a:solidFill>
+          <a:ln>
+            <a:noFill/>
+          </a:ln>
+        </p:spPr>
+        <p:style>
+          <a:lnRef idx="1">
+            <a:schemeClr val="accent1"/>
+          </a:lnRef>
+          <a:fillRef idx="3">
+            <a:schemeClr val="accent1"/>
+          </a:fillRef>
+          <a:effectRef idx="2">
+            <a:schemeClr val="accent1"/>
+          </a:effectRef>
+          <a:fontRef idx="minor">
+            <a:schemeClr val="lt1"/>
+          </a:fontRef>
+        </p:style>
+        <p:txBody>
+          <a:bodyPr rtlCol="0" anchor="ctr"/>
+          <a:lstStyle/>
+          <a:p>
+            <a:pPr algn="ctr"/>
+          </a:p>
+        </p:txBody>
+      </p:sp>
+      <p:sp>
+        <p:nvSpPr>
+          <p:cNvPr id="3" name="TextBox 2"/>
+          <p:cNvSpPr txBox="1"/>
+          <p:nvPr/>
+        </p:nvSpPr>
+        <p:spPr>
+          <a:xfrm>
+            <a:off x="502920" y="320040"/>
+            <a:ext cx="11155680" cy="914400"/>
+          </a:xfrm>
+          <a:prstGeom prst="rect">
+            <a:avLst/>
+          </a:prstGeom>
+          <a:noFill/>
+        </p:spPr>
+        <p:txBody>
+          <a:bodyPr wrap="none">
+            <a:spAutoFit/>
+          </a:bodyPr>
+          <a:lstStyle/>
+          <a:p>
+            <a:pPr>
+              <a:defRPr sz="3200" b="1">
+                <a:solidFill>
+                  <a:srgbClr val="0C2340"/>
+                </a:solidFill>
+              </a:defRPr>
+            </a:pPr>
+            <a:r>
+              <a:t>Rencana Langkah Selanjutnya</a:t>
+            </a:r>
+          </a:p>
+          <a:p>
+            <a:pPr>
+              <a:spcBef>
+                <a:spcPts val="600"/>
+              </a:spcBef>
+              <a:defRPr sz="1700">
+                <a:solidFill>
+                  <a:srgbClr val="64748B"/>
+                </a:solidFill>
+              </a:defRPr>
+            </a:pPr>
+            <a:r>
+              <a:t>Prioritas pengembangan ke depan</a:t>
+            </a:r>
+          </a:p>
+        </p:txBody>
+      </p:sp>
+      <p:sp>
+        <p:nvSpPr>
+          <p:cNvPr id="4" name="Rounded Rectangle 3"/>
+          <p:cNvSpPr/>
+          <p:nvPr/>
+        </p:nvSpPr>
+        <p:spPr>
+          <a:xfrm>
+            <a:off x="411480" y="1417320"/>
+            <a:ext cx="3657600" cy="4434840"/>
+          </a:xfrm>
+          <a:prstGeom prst="roundRect">
+            <a:avLst/>
+          </a:prstGeom>
+          <a:solidFill>
+            <a:srgbClr val="FFFFFF"/>
+          </a:solidFill>
+          <a:ln>
+            <a:solidFill>
+              <a:srgbClr val="E2E8F0"/>
+            </a:solidFill>
+          </a:ln>
+        </p:spPr>
+        <p:style>
+          <a:lnRef idx="1">
+            <a:schemeClr val="accent1"/>
+          </a:lnRef>
+          <a:fillRef idx="3">
+            <a:schemeClr val="accent1"/>
+          </a:fillRef>
+          <a:effectRef idx="2">
+            <a:schemeClr val="accent1"/>
+          </a:effectRef>
+          <a:fontRef idx="minor">
+            <a:schemeClr val="lt1"/>
+          </a:fontRef>
+        </p:style>
+        <p:txBody>
+          <a:bodyPr rtlCol="0" anchor="ctr"/>
+          <a:lstStyle/>
+          <a:p>
+            <a:pPr algn="ctr"/>
+          </a:p>
+        </p:txBody>
+      </p:sp>
+      <p:sp>
+        <p:nvSpPr>
+          <p:cNvPr id="5" name="Rectangle 4"/>
+          <p:cNvSpPr/>
+          <p:nvPr/>
+        </p:nvSpPr>
+        <p:spPr>
+          <a:xfrm>
+            <a:off x="411480" y="1417320"/>
+            <a:ext cx="3657600" cy="475488"/>
+          </a:xfrm>
+          <a:prstGeom prst="rect">
+            <a:avLst/>
+          </a:prstGeom>
+          <a:solidFill>
+            <a:srgbClr val="0C2340"/>
+          </a:solidFill>
+          <a:ln>
+            <a:noFill/>
+          </a:ln>
+        </p:spPr>
+        <p:style>
+          <a:lnRef idx="1">
+            <a:schemeClr val="accent1"/>
+          </a:lnRef>
+          <a:fillRef idx="3">
+            <a:schemeClr val="accent1"/>
+          </a:fillRef>
+          <a:effectRef idx="2">
+            <a:schemeClr val="accent1"/>
+          </a:effectRef>
+          <a:fontRef idx="minor">
+            <a:schemeClr val="lt1"/>
+          </a:fontRef>
+        </p:style>
+        <p:txBody>
+          <a:bodyPr rtlCol="0" anchor="ctr"/>
+          <a:lstStyle/>
+          <a:p>
+            <a:pPr algn="ctr"/>
+          </a:p>
+        </p:txBody>
+      </p:sp>
+      <p:sp>
+        <p:nvSpPr>
+          <p:cNvPr id="6" name="TextBox 5"/>
+          <p:cNvSpPr txBox="1"/>
+          <p:nvPr/>
+        </p:nvSpPr>
+        <p:spPr>
+          <a:xfrm>
+            <a:off x="594360" y="1490472"/>
+            <a:ext cx="3291840" cy="365760"/>
+          </a:xfrm>
+          <a:prstGeom prst="rect">
+            <a:avLst/>
+          </a:prstGeom>
+          <a:noFill/>
+        </p:spPr>
+        <p:txBody>
+          <a:bodyPr wrap="none">
+            <a:spAutoFit/>
+          </a:bodyPr>
+          <a:lstStyle/>
+          <a:p>
+            <a:pPr>
+              <a:defRPr sz="1600" b="1">
+                <a:solidFill>
+                  <a:srgbClr val="FFFFFF"/>
+                </a:solidFill>
+              </a:defRPr>
+            </a:pPr>
+            <a:r>
+              <a:t>Fase 1 — Stabilisasi</a:t>
+            </a:r>
+          </a:p>
+        </p:txBody>
+      </p:sp>
+      <p:sp>
+        <p:nvSpPr>
+          <p:cNvPr id="7" name="TextBox 6"/>
+          <p:cNvSpPr txBox="1"/>
+          <p:nvPr/>
+        </p:nvSpPr>
+        <p:spPr>
+          <a:xfrm>
+            <a:off x="594360" y="2011680"/>
+            <a:ext cx="3291840" cy="3749039"/>
+          </a:xfrm>
+          <a:prstGeom prst="rect">
+            <a:avLst/>
+          </a:prstGeom>
+          <a:noFill/>
+        </p:spPr>
+        <p:txBody>
+          <a:bodyPr wrap="square">
+            <a:spAutoFit/>
+          </a:bodyPr>
+          <a:lstStyle/>
+          <a:p>
+            <a:pPr>
+              <a:spcAft>
+                <a:spcPts val="600"/>
+              </a:spcAft>
+              <a:defRPr sz="1400">
+                <a:solidFill>
+                  <a:srgbClr val="1E293B"/>
+                </a:solidFill>
+              </a:defRPr>
+            </a:pPr>
+            <a:r>
+              <a:t>Perbaiki keamanan: hash password, signed session</a:t>
+            </a:r>
+          </a:p>
+          <a:p>
+            <a:pPr>
+              <a:spcAft>
+                <a:spcPts val="600"/>
+              </a:spcAft>
+              <a:defRPr sz="1400">
+                <a:solidFill>
+                  <a:srgbClr val="1E293B"/>
+                </a:solidFill>
+              </a:defRPr>
+            </a:pPr>
+            <a:r>
+              <a:t>Tambah rate limiting &amp; security headers</a:t>
+            </a:r>
+          </a:p>
+          <a:p>
+            <a:pPr>
+              <a:spcAft>
+                <a:spcPts val="600"/>
+              </a:spcAft>
+              <a:defRPr sz="1400">
+                <a:solidFill>
+                  <a:srgbClr val="1E293B"/>
+                </a:solidFill>
+              </a:defRPr>
+            </a:pPr>
+            <a:r>
+              <a:t>Lengkapi audit log aktivitas</a:t>
+            </a:r>
+          </a:p>
+          <a:p>
+            <a:pPr>
+              <a:spcAft>
+                <a:spcPts val="600"/>
+              </a:spcAft>
+              <a:defRPr sz="1400">
+                <a:solidFill>
+                  <a:srgbClr val="1E293B"/>
+                </a:solidFill>
+              </a:defRPr>
+            </a:pPr>
+            <a:r>
+              <a:t>Uji coba internal dengan user CorpSec</a:t>
+            </a:r>
+          </a:p>
+        </p:txBody>
+      </p:sp>
+      <p:sp>
+        <p:nvSpPr>
+          <p:cNvPr id="8" name="Rounded Rectangle 7"/>
+          <p:cNvSpPr/>
+          <p:nvPr/>
+        </p:nvSpPr>
+        <p:spPr>
+          <a:xfrm>
+            <a:off x="4297680" y="1417320"/>
+            <a:ext cx="3657600" cy="4434840"/>
+          </a:xfrm>
+          <a:prstGeom prst="roundRect">
+            <a:avLst/>
+          </a:prstGeom>
+          <a:solidFill>
+            <a:srgbClr val="FFFFFF"/>
+          </a:solidFill>
+          <a:ln>
+            <a:solidFill>
+              <a:srgbClr val="E2E8F0"/>
+            </a:solidFill>
+          </a:ln>
+        </p:spPr>
+        <p:style>
+          <a:lnRef idx="1">
+            <a:schemeClr val="accent1"/>
+          </a:lnRef>
+          <a:fillRef idx="3">
+            <a:schemeClr val="accent1"/>
+          </a:fillRef>
+          <a:effectRef idx="2">
+            <a:schemeClr val="accent1"/>
+          </a:effectRef>
+          <a:fontRef idx="minor">
+            <a:schemeClr val="lt1"/>
+          </a:fontRef>
+        </p:style>
+        <p:txBody>
+          <a:bodyPr rtlCol="0" anchor="ctr"/>
+          <a:lstStyle/>
+          <a:p>
+            <a:pPr algn="ctr"/>
+          </a:p>
+        </p:txBody>
+      </p:sp>
+      <p:sp>
+        <p:nvSpPr>
+          <p:cNvPr id="9" name="Rectangle 8"/>
+          <p:cNvSpPr/>
+          <p:nvPr/>
+        </p:nvSpPr>
+        <p:spPr>
+          <a:xfrm>
+            <a:off x="4297680" y="1417320"/>
+            <a:ext cx="3657600" cy="475488"/>
+          </a:xfrm>
+          <a:prstGeom prst="rect">
+            <a:avLst/>
+          </a:prstGeom>
+          <a:solidFill>
+            <a:srgbClr val="F58220"/>
+          </a:solidFill>
+          <a:ln>
+            <a:noFill/>
+          </a:ln>
+        </p:spPr>
+        <p:style>
+          <a:lnRef idx="1">
+            <a:schemeClr val="accent1"/>
+          </a:lnRef>
+          <a:fillRef idx="3">
+            <a:schemeClr val="accent1"/>
+          </a:fillRef>
+          <a:effectRef idx="2">
+            <a:schemeClr val="accent1"/>
+          </a:effectRef>
+          <a:fontRef idx="minor">
+            <a:schemeClr val="lt1"/>
+          </a:fontRef>
+        </p:style>
+        <p:txBody>
+          <a:bodyPr rtlCol="0" anchor="ctr"/>
+          <a:lstStyle/>
+          <a:p>
+            <a:pPr algn="ctr"/>
+          </a:p>
+        </p:txBody>
+      </p:sp>
+      <p:sp>
+        <p:nvSpPr>
+          <p:cNvPr id="10" name="TextBox 9"/>
+          <p:cNvSpPr txBox="1"/>
+          <p:nvPr/>
+        </p:nvSpPr>
+        <p:spPr>
+          <a:xfrm>
+            <a:off x="4480560" y="1490472"/>
+            <a:ext cx="3291840" cy="365760"/>
+          </a:xfrm>
+          <a:prstGeom prst="rect">
+            <a:avLst/>
+          </a:prstGeom>
+          <a:noFill/>
+        </p:spPr>
+        <p:txBody>
+          <a:bodyPr wrap="none">
+            <a:spAutoFit/>
+          </a:bodyPr>
+          <a:lstStyle/>
+          <a:p>
+            <a:pPr>
+              <a:defRPr sz="1600" b="1">
+                <a:solidFill>
+                  <a:srgbClr val="FFFFFF"/>
+                </a:solidFill>
+              </a:defRPr>
+            </a:pPr>
+            <a:r>
+              <a:t>Fase 2 — Peningkatan Fitur</a:t>
+            </a:r>
+          </a:p>
+        </p:txBody>
+      </p:sp>
+      <p:sp>
+        <p:nvSpPr>
+          <p:cNvPr id="11" name="TextBox 10"/>
+          <p:cNvSpPr txBox="1"/>
+          <p:nvPr/>
+        </p:nvSpPr>
+        <p:spPr>
+          <a:xfrm>
+            <a:off x="4480560" y="2011680"/>
+            <a:ext cx="3291840" cy="3749039"/>
+          </a:xfrm>
+          <a:prstGeom prst="rect">
+            <a:avLst/>
+          </a:prstGeom>
+          <a:noFill/>
+        </p:spPr>
+        <p:txBody>
+          <a:bodyPr wrap="square">
+            <a:spAutoFit/>
+          </a:bodyPr>
+          <a:lstStyle/>
+          <a:p>
+            <a:pPr>
+              <a:spcAft>
+                <a:spcPts val="600"/>
+              </a:spcAft>
+              <a:defRPr sz="1400">
+                <a:solidFill>
+                  <a:srgbClr val="1E293B"/>
+                </a:solidFill>
+              </a:defRPr>
+            </a:pPr>
+            <a:r>
+              <a:t>Integrasi LLM nyata untuk tinjauan memorandum</a:t>
+            </a:r>
+          </a:p>
+          <a:p>
+            <a:pPr>
+              <a:spcAft>
+                <a:spcPts val="600"/>
+              </a:spcAft>
+              <a:defRPr sz="1400">
+                <a:solidFill>
+                  <a:srgbClr val="1E293B"/>
+                </a:solidFill>
+              </a:defRPr>
+            </a:pPr>
+            <a:r>
+              <a:t>Notifikasi email/SMS saat approval &amp; SLA breach</a:t>
+            </a:r>
+          </a:p>
+          <a:p>
+            <a:pPr>
+              <a:spcAft>
+                <a:spcPts val="600"/>
+              </a:spcAft>
+              <a:defRPr sz="1400">
+                <a:solidFill>
+                  <a:srgbClr val="1E293B"/>
+                </a:solidFill>
+              </a:defRPr>
+            </a:pPr>
+            <a:r>
+              <a:t>Export laporan PDF/Excel</a:t>
+            </a:r>
+          </a:p>
+          <a:p>
+            <a:pPr>
+              <a:spcAft>
+                <a:spcPts val="600"/>
+              </a:spcAft>
+              <a:defRPr sz="1400">
+                <a:solidFill>
+                  <a:srgbClr val="1E293B"/>
+                </a:solidFill>
+              </a:defRPr>
+            </a:pPr>
+            <a:r>
+              <a:t>Koneksi ke SMD Bank Sumut</a:t>
+            </a:r>
+          </a:p>
+        </p:txBody>
+      </p:sp>
+      <p:sp>
+        <p:nvSpPr>
+          <p:cNvPr id="12" name="Rounded Rectangle 11"/>
+          <p:cNvSpPr/>
+          <p:nvPr/>
+        </p:nvSpPr>
+        <p:spPr>
+          <a:xfrm>
+            <a:off x="8183879" y="1417320"/>
+            <a:ext cx="3657600" cy="4434840"/>
+          </a:xfrm>
+          <a:prstGeom prst="roundRect">
+            <a:avLst/>
+          </a:prstGeom>
+          <a:solidFill>
+            <a:srgbClr val="FFFFFF"/>
+          </a:solidFill>
+          <a:ln>
+            <a:solidFill>
+              <a:srgbClr val="E2E8F0"/>
+            </a:solidFill>
+          </a:ln>
+        </p:spPr>
+        <p:style>
+          <a:lnRef idx="1">
+            <a:schemeClr val="accent1"/>
+          </a:lnRef>
+          <a:fillRef idx="3">
+            <a:schemeClr val="accent1"/>
+          </a:fillRef>
+          <a:effectRef idx="2">
+            <a:schemeClr val="accent1"/>
+          </a:effectRef>
+          <a:fontRef idx="minor">
+            <a:schemeClr val="lt1"/>
+          </a:fontRef>
+        </p:style>
+        <p:txBody>
+          <a:bodyPr rtlCol="0" anchor="ctr"/>
+          <a:lstStyle/>
+          <a:p>
+            <a:pPr algn="ctr"/>
+          </a:p>
+        </p:txBody>
+      </p:sp>
+      <p:sp>
+        <p:nvSpPr>
+          <p:cNvPr id="13" name="Rectangle 12"/>
+          <p:cNvSpPr/>
+          <p:nvPr/>
+        </p:nvSpPr>
+        <p:spPr>
+          <a:xfrm>
+            <a:off x="8183879" y="1417320"/>
+            <a:ext cx="3657600" cy="475488"/>
+          </a:xfrm>
+          <a:prstGeom prst="rect">
+            <a:avLst/>
+          </a:prstGeom>
+          <a:solidFill>
+            <a:srgbClr val="059669"/>
+          </a:solidFill>
+          <a:ln>
+            <a:noFill/>
+          </a:ln>
+        </p:spPr>
+        <p:style>
+          <a:lnRef idx="1">
+            <a:schemeClr val="accent1"/>
+          </a:lnRef>
+          <a:fillRef idx="3">
+            <a:schemeClr val="accent1"/>
+          </a:fillRef>
+          <a:effectRef idx="2">
+            <a:schemeClr val="accent1"/>
+          </a:effectRef>
+          <a:fontRef idx="minor">
+            <a:schemeClr val="lt1"/>
+          </a:fontRef>
+        </p:style>
+        <p:txBody>
+          <a:bodyPr rtlCol="0" anchor="ctr"/>
+          <a:lstStyle/>
+          <a:p>
+            <a:pPr algn="ctr"/>
+          </a:p>
+        </p:txBody>
+      </p:sp>
+      <p:sp>
+        <p:nvSpPr>
+          <p:cNvPr id="14" name="TextBox 13"/>
+          <p:cNvSpPr txBox="1"/>
+          <p:nvPr/>
+        </p:nvSpPr>
+        <p:spPr>
+          <a:xfrm>
+            <a:off x="8366759" y="1490472"/>
+            <a:ext cx="3291840" cy="365760"/>
+          </a:xfrm>
+          <a:prstGeom prst="rect">
+            <a:avLst/>
+          </a:prstGeom>
+          <a:noFill/>
+        </p:spPr>
+        <p:txBody>
+          <a:bodyPr wrap="none">
+            <a:spAutoFit/>
+          </a:bodyPr>
+          <a:lstStyle/>
+          <a:p>
+            <a:pPr>
+              <a:defRPr sz="1600" b="1">
+                <a:solidFill>
+                  <a:srgbClr val="FFFFFF"/>
+                </a:solidFill>
+              </a:defRPr>
+            </a:pPr>
+            <a:r>
+              <a:t>Fase 3 — Go Live</a:t>
+            </a:r>
+          </a:p>
+        </p:txBody>
+      </p:sp>
+      <p:sp>
+        <p:nvSpPr>
+          <p:cNvPr id="15" name="TextBox 14"/>
+          <p:cNvSpPr txBox="1"/>
+          <p:nvPr/>
+        </p:nvSpPr>
+        <p:spPr>
+          <a:xfrm>
+            <a:off x="8366759" y="2011680"/>
+            <a:ext cx="3291840" cy="3749039"/>
+          </a:xfrm>
+          <a:prstGeom prst="rect">
+            <a:avLst/>
+          </a:prstGeom>
+          <a:noFill/>
+        </p:spPr>
+        <p:txBody>
+          <a:bodyPr wrap="square">
+            <a:spAutoFit/>
+          </a:bodyPr>
+          <a:lstStyle/>
+          <a:p>
+            <a:pPr>
+              <a:spcAft>
+                <a:spcPts val="600"/>
+              </a:spcAft>
+              <a:defRPr sz="1400">
+                <a:solidFill>
+                  <a:srgbClr val="1E293B"/>
+                </a:solidFill>
+              </a:defRPr>
+            </a:pPr>
+            <a:r>
+              <a:t>Integrasi SSO Active Directory</a:t>
+            </a:r>
+          </a:p>
+          <a:p>
+            <a:pPr>
+              <a:spcAft>
+                <a:spcPts val="600"/>
+              </a:spcAft>
+              <a:defRPr sz="1400">
+                <a:solidFill>
+                  <a:srgbClr val="1E293B"/>
+                </a:solidFill>
+              </a:defRPr>
+            </a:pPr>
+            <a:r>
+              <a:t>Migrasi database ke PostgreSQL production</a:t>
+            </a:r>
+          </a:p>
+          <a:p>
+            <a:pPr>
+              <a:spcAft>
+                <a:spcPts val="600"/>
+              </a:spcAft>
+              <a:defRPr sz="1400">
+                <a:solidFill>
+                  <a:srgbClr val="1E293B"/>
+                </a:solidFill>
+              </a:defRPr>
+            </a:pPr>
+            <a:r>
+              <a:t>Penetration testing &amp; UAT formal</a:t>
+            </a:r>
+          </a:p>
+          <a:p>
+            <a:pPr>
+              <a:spcAft>
+                <a:spcPts val="600"/>
+              </a:spcAft>
+              <a:defRPr sz="1400">
+                <a:solidFill>
+                  <a:srgbClr val="1E293B"/>
+                </a:solidFill>
+              </a:defRPr>
+            </a:pPr>
+            <a:r>
+              <a:t>Pelatihan user &amp; rollout ke seluruh divisi</a:t>
+            </a:r>
+          </a:p>
+        </p:txBody>
+      </p:sp>
+      <p:sp>
+        <p:nvSpPr>
+          <p:cNvPr id="16" name="Rectangle 15"/>
+          <p:cNvSpPr/>
+          <p:nvPr/>
+        </p:nvSpPr>
+        <p:spPr>
+          <a:xfrm>
+            <a:off x="0" y="6446520"/>
+            <a:ext cx="12191695" cy="411480"/>
+          </a:xfrm>
+          <a:prstGeom prst="rect">
+            <a:avLst/>
+          </a:prstGeom>
+          <a:solidFill>
+            <a:srgbClr val="0C2340"/>
+          </a:solidFill>
+          <a:ln>
+            <a:noFill/>
+          </a:ln>
+        </p:spPr>
+        <p:style>
+          <a:lnRef idx="1">
+            <a:schemeClr val="accent1"/>
+          </a:lnRef>
+          <a:fillRef idx="3">
+            <a:schemeClr val="accent1"/>
+          </a:fillRef>
+          <a:effectRef idx="2">
+            <a:schemeClr val="accent1"/>
+          </a:effectRef>
+          <a:fontRef idx="minor">
+            <a:schemeClr val="lt1"/>
+          </a:fontRef>
+        </p:style>
+        <p:txBody>
+          <a:bodyPr rtlCol="0" anchor="ctr"/>
+          <a:lstStyle/>
+          <a:p>
+            <a:pPr algn="ctr"/>
+          </a:p>
+        </p:txBody>
+      </p:sp>
+      <p:sp>
+        <p:nvSpPr>
+          <p:cNvPr id="17" name="TextBox 16"/>
+          <p:cNvSpPr txBox="1"/>
+          <p:nvPr/>
+        </p:nvSpPr>
+        <p:spPr>
+          <a:xfrm>
+            <a:off x="457200" y="6492240"/>
+            <a:ext cx="5486400" cy="320040"/>
+          </a:xfrm>
+          <a:prstGeom prst="rect">
+            <a:avLst/>
+          </a:prstGeom>
+          <a:noFill/>
+        </p:spPr>
+        <p:txBody>
+          <a:bodyPr wrap="none">
+            <a:spAutoFit/>
+          </a:bodyPr>
+          <a:lstStyle/>
+          <a:p>
+            <a:pPr>
+              <a:defRPr sz="1100" b="1">
+                <a:solidFill>
+                  <a:srgbClr val="F58220"/>
+                </a:solidFill>
+              </a:defRPr>
+            </a:pPr>
+            <a:r>
+              <a:t>CorpSec Bank Sumut — Business Problem Canvas</a:t>
+            </a:r>
+          </a:p>
+        </p:txBody>
+      </p:sp>
+      <p:sp>
+        <p:nvSpPr>
+          <p:cNvPr id="18" name="TextBox 17"/>
+          <p:cNvSpPr txBox="1"/>
+          <p:nvPr/>
+        </p:nvSpPr>
+        <p:spPr>
+          <a:xfrm>
+            <a:off x="10515600" y="6492240"/>
+            <a:ext cx="1371600" cy="320040"/>
+          </a:xfrm>
+          <a:prstGeom prst="rect">
+            <a:avLst/>
+          </a:prstGeom>
+          <a:noFill/>
+        </p:spPr>
+        <p:txBody>
+          <a:bodyPr wrap="none">
+            <a:spAutoFit/>
+          </a:bodyPr>
+          <a:lstStyle/>
+          <a:p>
+            <a:pPr algn="r">
+              <a:defRPr sz="1100">
+                <a:solidFill>
+                  <a:srgbClr val="FFFFFF"/>
+                </a:solidFill>
+              </a:defRPr>
+            </a:pPr>
+            <a:r>
+              <a:t>13</a:t>
+            </a:r>
+          </a:p>
+        </p:txBody>
+      </p:sp>
+    </p:spTree>
+  </p:cSld>
+  <p:clrMapOvr>
+    <a:masterClrMapping/>
+  </p:clrMapOvr>
+</p:sld>
+</file>
+
+<file path=ppt/slides/slide14.xml><?xml version="1.0" encoding="utf-8"?>
 <p:sld xmlns:a="http://schemas.openxmlformats.org/drawingml/2006/main" xmlns:p="http://schemas.openxmlformats.org/presentationml/2006/main" xmlns:r="http://schemas.openxmlformats.org/officeDocument/2006/relationships">
   <p:cSld>
     <p:bg>
@@ -6011,7 +6393,7 @@
               </a:defRPr>
             </a:pPr>
             <a:r>
-              <a:t>13</a:t>
+              <a:t>14</a:t>
             </a:r>
           </a:p>
         </p:txBody>
@@ -8579,7 +8961,7 @@
               </a:defRPr>
             </a:pPr>
             <a:r>
-              <a:t>Aplikasi yang Dibuat</a:t>
+              <a:t>Tampilan Website</a:t>
             </a:r>
           </a:p>
           <a:p>
@@ -8594,7 +8976,7 @@
               </a:defRPr>
             </a:pPr>
             <a:r>
-              <a:t>Platform web CorpSec Bank Sumut — ringkasan singkat</a:t>
+              <a:t>Halaman Login — pintu masuk aplikasi CorpSec Bank Sumut</a:t>
             </a:r>
           </a:p>
         </p:txBody>
@@ -8607,8 +8989,8 @@
         </p:nvSpPr>
         <p:spPr>
           <a:xfrm>
-            <a:off x="411480" y="1325880"/>
-            <a:ext cx="3520440" cy="4480560"/>
+            <a:off x="1042415" y="1179576"/>
+            <a:ext cx="10076688" cy="4544568"/>
           </a:xfrm>
           <a:prstGeom prst="roundRect">
             <a:avLst/>
@@ -8644,16 +9026,75 @@
           </a:p>
         </p:txBody>
       </p:sp>
-      <p:sp>
-        <p:nvSpPr>
-          <p:cNvPr id="5" name="Rectangle 4"/>
+      <p:pic>
+        <p:nvPicPr>
+          <p:cNvPr id="5" name="Picture 4" descr="01-login.png"/>
+          <p:cNvPicPr>
+            <a:picLocks noChangeAspect="1"/>
+          </p:cNvPicPr>
+          <p:nvPr/>
+        </p:nvPicPr>
+        <p:blipFill>
+          <a:blip r:embed="rId2"/>
+          <a:stretch>
+            <a:fillRect/>
+          </a:stretch>
+        </p:blipFill>
+        <p:spPr>
+          <a:xfrm>
+            <a:off x="1097280" y="1234440"/>
+            <a:ext cx="9966960" cy="4160520"/>
+          </a:xfrm>
+          <a:prstGeom prst="rect">
+            <a:avLst/>
+          </a:prstGeom>
+        </p:spPr>
+      </p:pic>
+      <p:sp>
+        <p:nvSpPr>
+          <p:cNvPr id="6" name="TextBox 5"/>
+          <p:cNvSpPr txBox="1"/>
+          <p:nvPr/>
+        </p:nvSpPr>
+        <p:spPr>
+          <a:xfrm>
+            <a:off x="1097280" y="5431536"/>
+            <a:ext cx="9966960" cy="292608"/>
+          </a:xfrm>
+          <a:prstGeom prst="rect">
+            <a:avLst/>
+          </a:prstGeom>
+          <a:noFill/>
+        </p:spPr>
+        <p:txBody>
+          <a:bodyPr wrap="none">
+            <a:spAutoFit/>
+          </a:bodyPr>
+          <a:lstStyle/>
+          <a:p>
+            <a:pPr algn="ctr">
+              <a:defRPr sz="1300" b="1">
+                <a:solidFill>
+                  <a:srgbClr val="0C2340"/>
+                </a:solidFill>
+              </a:defRPr>
+            </a:pPr>
+            <a:r>
+              <a:t>Halaman Login</a:t>
+            </a:r>
+          </a:p>
+        </p:txBody>
+      </p:sp>
+      <p:sp>
+        <p:nvSpPr>
+          <p:cNvPr id="7" name="Rectangle 6"/>
           <p:cNvSpPr/>
           <p:nvPr/>
         </p:nvSpPr>
         <p:spPr>
           <a:xfrm>
-            <a:off x="411480" y="1325880"/>
-            <a:ext cx="3520440" cy="475488"/>
+            <a:off x="0" y="6446520"/>
+            <a:ext cx="12191695" cy="411480"/>
           </a:xfrm>
           <a:prstGeom prst="rect">
             <a:avLst/>
@@ -8689,14 +9130,14 @@
       </p:sp>
       <p:sp>
         <p:nvSpPr>
-          <p:cNvPr id="6" name="TextBox 5"/>
+          <p:cNvPr id="8" name="TextBox 7"/>
           <p:cNvSpPr txBox="1"/>
           <p:nvPr/>
         </p:nvSpPr>
         <p:spPr>
           <a:xfrm>
-            <a:off x="594360" y="1399032"/>
-            <a:ext cx="3154680" cy="365760"/>
+            <a:off x="457200" y="6492240"/>
+            <a:ext cx="5486400" cy="320040"/>
           </a:xfrm>
           <a:prstGeom prst="rect">
             <a:avLst/>
@@ -8710,654 +9151,6 @@
           <a:lstStyle/>
           <a:p>
             <a:pPr>
-              <a:defRPr sz="1600" b="1">
-                <a:solidFill>
-                  <a:srgbClr val="FFFFFF"/>
-                </a:solidFill>
-              </a:defRPr>
-            </a:pPr>
-            <a:r>
-              <a:t>Tampilan Depan</a:t>
-            </a:r>
-          </a:p>
-        </p:txBody>
-      </p:sp>
-      <p:sp>
-        <p:nvSpPr>
-          <p:cNvPr id="7" name="TextBox 6"/>
-          <p:cNvSpPr txBox="1"/>
-          <p:nvPr/>
-        </p:nvSpPr>
-        <p:spPr>
-          <a:xfrm>
-            <a:off x="594360" y="1920240"/>
-            <a:ext cx="3154680" cy="3794760"/>
-          </a:xfrm>
-          <a:prstGeom prst="rect">
-            <a:avLst/>
-          </a:prstGeom>
-          <a:noFill/>
-        </p:spPr>
-        <p:txBody>
-          <a:bodyPr wrap="square">
-            <a:spAutoFit/>
-          </a:bodyPr>
-          <a:lstStyle/>
-          <a:p>
-            <a:pPr>
-              <a:spcAft>
-                <a:spcPts val="600"/>
-              </a:spcAft>
-              <a:defRPr sz="1400">
-                <a:solidFill>
-                  <a:srgbClr val="1E293B"/>
-                </a:solidFill>
-              </a:defRPr>
-            </a:pPr>
-            <a:r>
-              <a:t>Halaman login dengan gambar gedung Bank Sumut</a:t>
-            </a:r>
-          </a:p>
-          <a:p>
-            <a:pPr>
-              <a:spcAft>
-                <a:spcPts val="600"/>
-              </a:spcAft>
-              <a:defRPr sz="1400">
-                <a:solidFill>
-                  <a:srgbClr val="1E293B"/>
-                </a:solidFill>
-              </a:defRPr>
-            </a:pPr>
-            <a:r>
-              <a:t>Warna navy &amp; oranye sesuai branding bank</a:t>
-            </a:r>
-          </a:p>
-          <a:p>
-            <a:pPr>
-              <a:spcAft>
-                <a:spcPts val="600"/>
-              </a:spcAft>
-              <a:defRPr sz="1400">
-                <a:solidFill>
-                  <a:srgbClr val="1E293B"/>
-                </a:solidFill>
-              </a:defRPr>
-            </a:pPr>
-            <a:r>
-              <a:t>Sidebar per role — menu sesuai tugas masing-masing</a:t>
-            </a:r>
-          </a:p>
-          <a:p>
-            <a:pPr>
-              <a:spcAft>
-                <a:spcPts val="600"/>
-              </a:spcAft>
-              <a:defRPr sz="1400">
-                <a:solidFill>
-                  <a:srgbClr val="1E293B"/>
-                </a:solidFill>
-              </a:defRPr>
-            </a:pPr>
-            <a:r>
-              <a:t>Dashboard dengan banner, statistik, &amp; grafik</a:t>
-            </a:r>
-          </a:p>
-          <a:p>
-            <a:pPr>
-              <a:spcAft>
-                <a:spcPts val="600"/>
-              </a:spcAft>
-              <a:defRPr sz="1400">
-                <a:solidFill>
-                  <a:srgbClr val="1E293B"/>
-                </a:solidFill>
-              </a:defRPr>
-            </a:pPr>
-            <a:r>
-              <a:t>Tampilan bersih, mudah dibaca, responsif</a:t>
-            </a:r>
-          </a:p>
-        </p:txBody>
-      </p:sp>
-      <p:sp>
-        <p:nvSpPr>
-          <p:cNvPr id="8" name="Rounded Rectangle 7"/>
-          <p:cNvSpPr/>
-          <p:nvPr/>
-        </p:nvSpPr>
-        <p:spPr>
-          <a:xfrm>
-            <a:off x="4160520" y="1325880"/>
-            <a:ext cx="3520440" cy="4480560"/>
-          </a:xfrm>
-          <a:prstGeom prst="roundRect">
-            <a:avLst/>
-          </a:prstGeom>
-          <a:solidFill>
-            <a:srgbClr val="FFFFFF"/>
-          </a:solidFill>
-          <a:ln>
-            <a:solidFill>
-              <a:srgbClr val="E2E8F0"/>
-            </a:solidFill>
-          </a:ln>
-        </p:spPr>
-        <p:style>
-          <a:lnRef idx="1">
-            <a:schemeClr val="accent1"/>
-          </a:lnRef>
-          <a:fillRef idx="3">
-            <a:schemeClr val="accent1"/>
-          </a:fillRef>
-          <a:effectRef idx="2">
-            <a:schemeClr val="accent1"/>
-          </a:effectRef>
-          <a:fontRef idx="minor">
-            <a:schemeClr val="lt1"/>
-          </a:fontRef>
-        </p:style>
-        <p:txBody>
-          <a:bodyPr rtlCol="0" anchor="ctr"/>
-          <a:lstStyle/>
-          <a:p>
-            <a:pPr algn="ctr"/>
-          </a:p>
-        </p:txBody>
-      </p:sp>
-      <p:sp>
-        <p:nvSpPr>
-          <p:cNvPr id="9" name="Rectangle 8"/>
-          <p:cNvSpPr/>
-          <p:nvPr/>
-        </p:nvSpPr>
-        <p:spPr>
-          <a:xfrm>
-            <a:off x="4160520" y="1325880"/>
-            <a:ext cx="3520440" cy="475488"/>
-          </a:xfrm>
-          <a:prstGeom prst="rect">
-            <a:avLst/>
-          </a:prstGeom>
-          <a:solidFill>
-            <a:srgbClr val="0C2340"/>
-          </a:solidFill>
-          <a:ln>
-            <a:noFill/>
-          </a:ln>
-        </p:spPr>
-        <p:style>
-          <a:lnRef idx="1">
-            <a:schemeClr val="accent1"/>
-          </a:lnRef>
-          <a:fillRef idx="3">
-            <a:schemeClr val="accent1"/>
-          </a:fillRef>
-          <a:effectRef idx="2">
-            <a:schemeClr val="accent1"/>
-          </a:effectRef>
-          <a:fontRef idx="minor">
-            <a:schemeClr val="lt1"/>
-          </a:fontRef>
-        </p:style>
-        <p:txBody>
-          <a:bodyPr rtlCol="0" anchor="ctr"/>
-          <a:lstStyle/>
-          <a:p>
-            <a:pPr algn="ctr"/>
-          </a:p>
-        </p:txBody>
-      </p:sp>
-      <p:sp>
-        <p:nvSpPr>
-          <p:cNvPr id="10" name="TextBox 9"/>
-          <p:cNvSpPr txBox="1"/>
-          <p:nvPr/>
-        </p:nvSpPr>
-        <p:spPr>
-          <a:xfrm>
-            <a:off x="4343400" y="1399032"/>
-            <a:ext cx="3154680" cy="365760"/>
-          </a:xfrm>
-          <a:prstGeom prst="rect">
-            <a:avLst/>
-          </a:prstGeom>
-          <a:noFill/>
-        </p:spPr>
-        <p:txBody>
-          <a:bodyPr wrap="none">
-            <a:spAutoFit/>
-          </a:bodyPr>
-          <a:lstStyle/>
-          <a:p>
-            <a:pPr>
-              <a:defRPr sz="1600" b="1">
-                <a:solidFill>
-                  <a:srgbClr val="FFFFFF"/>
-                </a:solidFill>
-              </a:defRPr>
-            </a:pPr>
-            <a:r>
-              <a:t>Fitur Utama</a:t>
-            </a:r>
-          </a:p>
-        </p:txBody>
-      </p:sp>
-      <p:sp>
-        <p:nvSpPr>
-          <p:cNvPr id="11" name="TextBox 10"/>
-          <p:cNvSpPr txBox="1"/>
-          <p:nvPr/>
-        </p:nvSpPr>
-        <p:spPr>
-          <a:xfrm>
-            <a:off x="4343400" y="1920240"/>
-            <a:ext cx="3154680" cy="3794760"/>
-          </a:xfrm>
-          <a:prstGeom prst="rect">
-            <a:avLst/>
-          </a:prstGeom>
-          <a:noFill/>
-        </p:spPr>
-        <p:txBody>
-          <a:bodyPr wrap="square">
-            <a:spAutoFit/>
-          </a:bodyPr>
-          <a:lstStyle/>
-          <a:p>
-            <a:pPr>
-              <a:spcAft>
-                <a:spcPts val="600"/>
-              </a:spcAft>
-              <a:defRPr sz="1400">
-                <a:solidFill>
-                  <a:srgbClr val="1E293B"/>
-                </a:solidFill>
-              </a:defRPr>
-            </a:pPr>
-            <a:r>
-              <a:t>Upload &amp; kelola memorandum PDF</a:t>
-            </a:r>
-          </a:p>
-          <a:p>
-            <a:pPr>
-              <a:spcAft>
-                <a:spcPts val="600"/>
-              </a:spcAft>
-              <a:defRPr sz="1400">
-                <a:solidFill>
-                  <a:srgbClr val="1E293B"/>
-                </a:solidFill>
-              </a:defRPr>
-            </a:pPr>
-            <a:r>
-              <a:t>Alur persetujuan 7 tahap</a:t>
-            </a:r>
-          </a:p>
-          <a:p>
-            <a:pPr>
-              <a:spcAft>
-                <a:spcPts val="600"/>
-              </a:spcAft>
-              <a:defRPr sz="1400">
-                <a:solidFill>
-                  <a:srgbClr val="1E293B"/>
-                </a:solidFill>
-              </a:defRPr>
-            </a:pPr>
-            <a:r>
-              <a:t>Bantuan rangkum isi memorandum</a:t>
-            </a:r>
-          </a:p>
-          <a:p>
-            <a:pPr>
-              <a:spcAft>
-                <a:spcPts val="600"/>
-              </a:spcAft>
-              <a:defRPr sz="1400">
-                <a:solidFill>
-                  <a:srgbClr val="1E293B"/>
-                </a:solidFill>
-              </a:defRPr>
-            </a:pPr>
-            <a:r>
-              <a:t>Tanda tangan digital saat approval</a:t>
-            </a:r>
-          </a:p>
-          <a:p>
-            <a:pPr>
-              <a:spcAft>
-                <a:spcPts val="600"/>
-              </a:spcAft>
-              <a:defRPr sz="1400">
-                <a:solidFill>
-                  <a:srgbClr val="1E293B"/>
-                </a:solidFill>
-              </a:defRPr>
-            </a:pPr>
-            <a:r>
-              <a:t>Agenda Direksi, rapat, media, arsip dokumen</a:t>
-            </a:r>
-          </a:p>
-          <a:p>
-            <a:pPr>
-              <a:spcAft>
-                <a:spcPts val="600"/>
-              </a:spcAft>
-              <a:defRPr sz="1400">
-                <a:solidFill>
-                  <a:srgbClr val="1E293B"/>
-                </a:solidFill>
-              </a:defRPr>
-            </a:pPr>
-            <a:r>
-              <a:t>Pemantauan SLA &amp; laporan KPI</a:t>
-            </a:r>
-          </a:p>
-        </p:txBody>
-      </p:sp>
-      <p:sp>
-        <p:nvSpPr>
-          <p:cNvPr id="12" name="Rounded Rectangle 11"/>
-          <p:cNvSpPr/>
-          <p:nvPr/>
-        </p:nvSpPr>
-        <p:spPr>
-          <a:xfrm>
-            <a:off x="7909560" y="1325880"/>
-            <a:ext cx="3520440" cy="4480560"/>
-          </a:xfrm>
-          <a:prstGeom prst="roundRect">
-            <a:avLst/>
-          </a:prstGeom>
-          <a:solidFill>
-            <a:srgbClr val="FFFFFF"/>
-          </a:solidFill>
-          <a:ln>
-            <a:solidFill>
-              <a:srgbClr val="E2E8F0"/>
-            </a:solidFill>
-          </a:ln>
-        </p:spPr>
-        <p:style>
-          <a:lnRef idx="1">
-            <a:schemeClr val="accent1"/>
-          </a:lnRef>
-          <a:fillRef idx="3">
-            <a:schemeClr val="accent1"/>
-          </a:fillRef>
-          <a:effectRef idx="2">
-            <a:schemeClr val="accent1"/>
-          </a:effectRef>
-          <a:fontRef idx="minor">
-            <a:schemeClr val="lt1"/>
-          </a:fontRef>
-        </p:style>
-        <p:txBody>
-          <a:bodyPr rtlCol="0" anchor="ctr"/>
-          <a:lstStyle/>
-          <a:p>
-            <a:pPr algn="ctr"/>
-          </a:p>
-        </p:txBody>
-      </p:sp>
-      <p:sp>
-        <p:nvSpPr>
-          <p:cNvPr id="13" name="Rectangle 12"/>
-          <p:cNvSpPr/>
-          <p:nvPr/>
-        </p:nvSpPr>
-        <p:spPr>
-          <a:xfrm>
-            <a:off x="7909560" y="1325880"/>
-            <a:ext cx="3520440" cy="475488"/>
-          </a:xfrm>
-          <a:prstGeom prst="rect">
-            <a:avLst/>
-          </a:prstGeom>
-          <a:solidFill>
-            <a:srgbClr val="0C2340"/>
-          </a:solidFill>
-          <a:ln>
-            <a:noFill/>
-          </a:ln>
-        </p:spPr>
-        <p:style>
-          <a:lnRef idx="1">
-            <a:schemeClr val="accent1"/>
-          </a:lnRef>
-          <a:fillRef idx="3">
-            <a:schemeClr val="accent1"/>
-          </a:fillRef>
-          <a:effectRef idx="2">
-            <a:schemeClr val="accent1"/>
-          </a:effectRef>
-          <a:fontRef idx="minor">
-            <a:schemeClr val="lt1"/>
-          </a:fontRef>
-        </p:style>
-        <p:txBody>
-          <a:bodyPr rtlCol="0" anchor="ctr"/>
-          <a:lstStyle/>
-          <a:p>
-            <a:pPr algn="ctr"/>
-          </a:p>
-        </p:txBody>
-      </p:sp>
-      <p:sp>
-        <p:nvSpPr>
-          <p:cNvPr id="14" name="TextBox 13"/>
-          <p:cNvSpPr txBox="1"/>
-          <p:nvPr/>
-        </p:nvSpPr>
-        <p:spPr>
-          <a:xfrm>
-            <a:off x="8092440" y="1399032"/>
-            <a:ext cx="3154680" cy="365760"/>
-          </a:xfrm>
-          <a:prstGeom prst="rect">
-            <a:avLst/>
-          </a:prstGeom>
-          <a:noFill/>
-        </p:spPr>
-        <p:txBody>
-          <a:bodyPr wrap="none">
-            <a:spAutoFit/>
-          </a:bodyPr>
-          <a:lstStyle/>
-          <a:p>
-            <a:pPr>
-              <a:defRPr sz="1600" b="1">
-                <a:solidFill>
-                  <a:srgbClr val="FFFFFF"/>
-                </a:solidFill>
-              </a:defRPr>
-            </a:pPr>
-            <a:r>
-              <a:t>Nilai Manfaat</a:t>
-            </a:r>
-          </a:p>
-        </p:txBody>
-      </p:sp>
-      <p:sp>
-        <p:nvSpPr>
-          <p:cNvPr id="15" name="TextBox 14"/>
-          <p:cNvSpPr txBox="1"/>
-          <p:nvPr/>
-        </p:nvSpPr>
-        <p:spPr>
-          <a:xfrm>
-            <a:off x="8092440" y="1920240"/>
-            <a:ext cx="3154680" cy="3794760"/>
-          </a:xfrm>
-          <a:prstGeom prst="rect">
-            <a:avLst/>
-          </a:prstGeom>
-          <a:noFill/>
-        </p:spPr>
-        <p:txBody>
-          <a:bodyPr wrap="square">
-            <a:spAutoFit/>
-          </a:bodyPr>
-          <a:lstStyle/>
-          <a:p>
-            <a:pPr>
-              <a:spcAft>
-                <a:spcPts val="600"/>
-              </a:spcAft>
-              <a:defRPr sz="1400">
-                <a:solidFill>
-                  <a:srgbClr val="1E293B"/>
-                </a:solidFill>
-              </a:defRPr>
-            </a:pPr>
-            <a:r>
-              <a:t>Proses lebih cepat &amp; terlacak</a:t>
-            </a:r>
-          </a:p>
-          <a:p>
-            <a:pPr>
-              <a:spcAft>
-                <a:spcPts val="600"/>
-              </a:spcAft>
-              <a:defRPr sz="1400">
-                <a:solidFill>
-                  <a:srgbClr val="1E293B"/>
-                </a:solidFill>
-              </a:defRPr>
-            </a:pPr>
-            <a:r>
-              <a:t>Mengurangi kertas &amp; duplikasi data</a:t>
-            </a:r>
-          </a:p>
-          <a:p>
-            <a:pPr>
-              <a:spcAft>
-                <a:spcPts val="600"/>
-              </a:spcAft>
-              <a:defRPr sz="1400">
-                <a:solidFill>
-                  <a:srgbClr val="1E293B"/>
-                </a:solidFill>
-              </a:defRPr>
-            </a:pPr>
-            <a:r>
-              <a:t>Keputusan lebih terdokumentasi</a:t>
-            </a:r>
-          </a:p>
-          <a:p>
-            <a:pPr>
-              <a:spcAft>
-                <a:spcPts val="600"/>
-              </a:spcAft>
-              <a:defRPr sz="1400">
-                <a:solidFill>
-                  <a:srgbClr val="1E293B"/>
-                </a:solidFill>
-              </a:defRPr>
-            </a:pPr>
-            <a:r>
-              <a:t>CorpSec punya dashboard terpusat</a:t>
-            </a:r>
-          </a:p>
-          <a:p>
-            <a:pPr>
-              <a:spcAft>
-                <a:spcPts val="600"/>
-              </a:spcAft>
-              <a:defRPr sz="1400">
-                <a:solidFill>
-                  <a:srgbClr val="1E293B"/>
-                </a:solidFill>
-              </a:defRPr>
-            </a:pPr>
-            <a:r>
-              <a:t>Setiap role hanya lihat tugasnya</a:t>
-            </a:r>
-          </a:p>
-          <a:p>
-            <a:pPr>
-              <a:spcAft>
-                <a:spcPts val="600"/>
-              </a:spcAft>
-              <a:defRPr sz="1400">
-                <a:solidFill>
-                  <a:srgbClr val="1E293B"/>
-                </a:solidFill>
-              </a:defRPr>
-            </a:pPr>
-            <a:r>
-              <a:t>Siap demo untuk evaluasi internal</a:t>
-            </a:r>
-          </a:p>
-        </p:txBody>
-      </p:sp>
-      <p:sp>
-        <p:nvSpPr>
-          <p:cNvPr id="16" name="Rectangle 15"/>
-          <p:cNvSpPr/>
-          <p:nvPr/>
-        </p:nvSpPr>
-        <p:spPr>
-          <a:xfrm>
-            <a:off x="0" y="6446520"/>
-            <a:ext cx="12191695" cy="411480"/>
-          </a:xfrm>
-          <a:prstGeom prst="rect">
-            <a:avLst/>
-          </a:prstGeom>
-          <a:solidFill>
-            <a:srgbClr val="0C2340"/>
-          </a:solidFill>
-          <a:ln>
-            <a:noFill/>
-          </a:ln>
-        </p:spPr>
-        <p:style>
-          <a:lnRef idx="1">
-            <a:schemeClr val="accent1"/>
-          </a:lnRef>
-          <a:fillRef idx="3">
-            <a:schemeClr val="accent1"/>
-          </a:fillRef>
-          <a:effectRef idx="2">
-            <a:schemeClr val="accent1"/>
-          </a:effectRef>
-          <a:fontRef idx="minor">
-            <a:schemeClr val="lt1"/>
-          </a:fontRef>
-        </p:style>
-        <p:txBody>
-          <a:bodyPr rtlCol="0" anchor="ctr"/>
-          <a:lstStyle/>
-          <a:p>
-            <a:pPr algn="ctr"/>
-          </a:p>
-        </p:txBody>
-      </p:sp>
-      <p:sp>
-        <p:nvSpPr>
-          <p:cNvPr id="17" name="TextBox 16"/>
-          <p:cNvSpPr txBox="1"/>
-          <p:nvPr/>
-        </p:nvSpPr>
-        <p:spPr>
-          <a:xfrm>
-            <a:off x="457200" y="6492240"/>
-            <a:ext cx="5486400" cy="320040"/>
-          </a:xfrm>
-          <a:prstGeom prst="rect">
-            <a:avLst/>
-          </a:prstGeom>
-          <a:noFill/>
-        </p:spPr>
-        <p:txBody>
-          <a:bodyPr wrap="none">
-            <a:spAutoFit/>
-          </a:bodyPr>
-          <a:lstStyle/>
-          <a:p>
-            <a:pPr>
               <a:defRPr sz="1100" b="1">
                 <a:solidFill>
                   <a:srgbClr val="F58220"/>
@@ -9372,7 +9165,7 @@
       </p:sp>
       <p:sp>
         <p:nvSpPr>
-          <p:cNvPr id="18" name="TextBox 17"/>
+          <p:cNvPr id="9" name="TextBox 8"/>
           <p:cNvSpPr txBox="1"/>
           <p:nvPr/>
         </p:nvSpPr>
@@ -9504,7 +9297,7 @@
               </a:defRPr>
             </a:pPr>
             <a:r>
-              <a:t>Mockup — Halaman Login &amp; Dashboard</a:t>
+              <a:t>Tampilan Website</a:t>
             </a:r>
           </a:p>
           <a:p>
@@ -9519,7 +9312,7 @@
               </a:defRPr>
             </a:pPr>
             <a:r>
-              <a:t>Tampilan depan dan pusat kendali CorpSec</a:t>
+              <a:t>Dashboard Corporate Secretary — ringkasan operasional harian</a:t>
             </a:r>
           </a:p>
         </p:txBody>
@@ -9532,8 +9325,8 @@
         </p:nvSpPr>
         <p:spPr>
           <a:xfrm>
-            <a:off x="365760" y="1280160"/>
-            <a:ext cx="5486400" cy="3474720"/>
+            <a:off x="356616" y="1179576"/>
+            <a:ext cx="11265407" cy="4544568"/>
           </a:xfrm>
           <a:prstGeom prst="roundRect">
             <a:avLst/>
@@ -9571,7 +9364,7 @@
       </p:sp>
       <p:pic>
         <p:nvPicPr>
-          <p:cNvPr id="5" name="Picture 4" descr="01-login.png"/>
+          <p:cNvPr id="5" name="Picture 4" descr="02-dashboard.png"/>
           <p:cNvPicPr>
             <a:picLocks noChangeAspect="1"/>
           </p:cNvPicPr>
@@ -9585,8 +9378,8 @@
         </p:blipFill>
         <p:spPr>
           <a:xfrm>
-            <a:off x="411480" y="1325880"/>
-            <a:ext cx="5394960" cy="3063240"/>
+            <a:off x="411480" y="1234440"/>
+            <a:ext cx="11155680" cy="4160520"/>
           </a:xfrm>
           <a:prstGeom prst="rect">
             <a:avLst/>
@@ -9601,8 +9394,8 @@
         </p:nvSpPr>
         <p:spPr>
           <a:xfrm>
-            <a:off x="411480" y="4434840"/>
-            <a:ext cx="5394960" cy="320040"/>
+            <a:off x="411480" y="5431536"/>
+            <a:ext cx="11155680" cy="292608"/>
           </a:xfrm>
           <a:prstGeom prst="rect">
             <a:avLst/>
@@ -9623,118 +9416,14 @@
               </a:defRPr>
             </a:pPr>
             <a:r>
-              <a:t>Halaman Login</a:t>
-            </a:r>
-          </a:p>
-        </p:txBody>
-      </p:sp>
-      <p:sp>
-        <p:nvSpPr>
-          <p:cNvPr id="7" name="Rounded Rectangle 6"/>
-          <p:cNvSpPr/>
-          <p:nvPr/>
-        </p:nvSpPr>
-        <p:spPr>
-          <a:xfrm>
-            <a:off x="6217920" y="1280160"/>
-            <a:ext cx="5486400" cy="3474720"/>
-          </a:xfrm>
-          <a:prstGeom prst="roundRect">
-            <a:avLst/>
-          </a:prstGeom>
-          <a:solidFill>
-            <a:srgbClr val="FFFFFF"/>
-          </a:solidFill>
-          <a:ln>
-            <a:solidFill>
-              <a:srgbClr val="E2E8F0"/>
-            </a:solidFill>
-          </a:ln>
-        </p:spPr>
-        <p:style>
-          <a:lnRef idx="1">
-            <a:schemeClr val="accent1"/>
-          </a:lnRef>
-          <a:fillRef idx="3">
-            <a:schemeClr val="accent1"/>
-          </a:fillRef>
-          <a:effectRef idx="2">
-            <a:schemeClr val="accent1"/>
-          </a:effectRef>
-          <a:fontRef idx="minor">
-            <a:schemeClr val="lt1"/>
-          </a:fontRef>
-        </p:style>
-        <p:txBody>
-          <a:bodyPr rtlCol="0" anchor="ctr"/>
-          <a:lstStyle/>
-          <a:p>
-            <a:pPr algn="ctr"/>
-          </a:p>
-        </p:txBody>
-      </p:sp>
-      <p:pic>
-        <p:nvPicPr>
-          <p:cNvPr id="8" name="Picture 7" descr="02-dashboard.png"/>
-          <p:cNvPicPr>
-            <a:picLocks noChangeAspect="1"/>
-          </p:cNvPicPr>
-          <p:nvPr/>
-        </p:nvPicPr>
-        <p:blipFill>
-          <a:blip r:embed="rId3"/>
-          <a:stretch>
-            <a:fillRect/>
-          </a:stretch>
-        </p:blipFill>
-        <p:spPr>
-          <a:xfrm>
-            <a:off x="6263640" y="1325880"/>
-            <a:ext cx="5394960" cy="3063240"/>
-          </a:xfrm>
-          <a:prstGeom prst="rect">
-            <a:avLst/>
-          </a:prstGeom>
-        </p:spPr>
-      </p:pic>
-      <p:sp>
-        <p:nvSpPr>
-          <p:cNvPr id="9" name="TextBox 8"/>
-          <p:cNvSpPr txBox="1"/>
-          <p:nvPr/>
-        </p:nvSpPr>
-        <p:spPr>
-          <a:xfrm>
-            <a:off x="6263640" y="4434840"/>
-            <a:ext cx="5394960" cy="320040"/>
-          </a:xfrm>
-          <a:prstGeom prst="rect">
-            <a:avLst/>
-          </a:prstGeom>
-          <a:noFill/>
-        </p:spPr>
-        <p:txBody>
-          <a:bodyPr wrap="none">
-            <a:spAutoFit/>
-          </a:bodyPr>
-          <a:lstStyle/>
-          <a:p>
-            <a:pPr algn="ctr">
-              <a:defRPr sz="1300" b="1">
-                <a:solidFill>
-                  <a:srgbClr val="0C2340"/>
-                </a:solidFill>
-              </a:defRPr>
-            </a:pPr>
-            <a:r>
-              <a:t>Dashboard Corporate Secretary</a:t>
-            </a:r>
-          </a:p>
-        </p:txBody>
-      </p:sp>
-      <p:sp>
-        <p:nvSpPr>
-          <p:cNvPr id="10" name="Rectangle 9"/>
+              <a:t>Dashboard CorpSec</a:t>
+            </a:r>
+          </a:p>
+        </p:txBody>
+      </p:sp>
+      <p:sp>
+        <p:nvSpPr>
+          <p:cNvPr id="7" name="Rectangle 6"/>
           <p:cNvSpPr/>
           <p:nvPr/>
         </p:nvSpPr>
@@ -9777,7 +9466,7 @@
       </p:sp>
       <p:sp>
         <p:nvSpPr>
-          <p:cNvPr id="11" name="TextBox 10"/>
+          <p:cNvPr id="8" name="TextBox 7"/>
           <p:cNvSpPr txBox="1"/>
           <p:nvPr/>
         </p:nvSpPr>
@@ -9812,7 +9501,7 @@
       </p:sp>
       <p:sp>
         <p:nvSpPr>
-          <p:cNvPr id="12" name="TextBox 11"/>
+          <p:cNvPr id="9" name="TextBox 8"/>
           <p:cNvSpPr txBox="1"/>
           <p:nvPr/>
         </p:nvSpPr>
@@ -9944,7 +9633,7 @@
               </a:defRPr>
             </a:pPr>
             <a:r>
-              <a:t>Mockup — Memorandum &amp; Divisi Pengusul</a:t>
+              <a:t>Tampilan Website</a:t>
             </a:r>
           </a:p>
           <a:p>
@@ -9959,7 +9648,7 @@
               </a:defRPr>
             </a:pPr>
             <a:r>
-              <a:t>Modul utama pengelolaan dokumen</a:t>
+              <a:t>Modul Memorandum &amp; Portal Divisi Pengusul</a:t>
             </a:r>
           </a:p>
         </p:txBody>
@@ -9972,8 +9661,8 @@
         </p:nvSpPr>
         <p:spPr>
           <a:xfrm>
-            <a:off x="365760" y="1280160"/>
-            <a:ext cx="5486400" cy="3474720"/>
+            <a:off x="356616" y="1179576"/>
+            <a:ext cx="5504688" cy="4544568"/>
           </a:xfrm>
           <a:prstGeom prst="roundRect">
             <a:avLst/>
@@ -10025,8 +9714,8 @@
         </p:blipFill>
         <p:spPr>
           <a:xfrm>
-            <a:off x="411480" y="1325880"/>
-            <a:ext cx="5394960" cy="3063240"/>
+            <a:off x="411480" y="1234440"/>
+            <a:ext cx="5394960" cy="4160520"/>
           </a:xfrm>
           <a:prstGeom prst="rect">
             <a:avLst/>
@@ -10041,8 +9730,8 @@
         </p:nvSpPr>
         <p:spPr>
           <a:xfrm>
-            <a:off x="411480" y="4434840"/>
-            <a:ext cx="5394960" cy="320040"/>
+            <a:off x="411480" y="5431536"/>
+            <a:ext cx="5394960" cy="292608"/>
           </a:xfrm>
           <a:prstGeom prst="rect">
             <a:avLst/>
@@ -10076,8 +9765,8 @@
         </p:nvSpPr>
         <p:spPr>
           <a:xfrm>
-            <a:off x="6217920" y="1280160"/>
-            <a:ext cx="5486400" cy="3474720"/>
+            <a:off x="6208776" y="1179576"/>
+            <a:ext cx="5504688" cy="4544568"/>
           </a:xfrm>
           <a:prstGeom prst="roundRect">
             <a:avLst/>
@@ -10129,8 +9818,8 @@
         </p:blipFill>
         <p:spPr>
           <a:xfrm>
-            <a:off x="6263640" y="1325880"/>
-            <a:ext cx="5394960" cy="3063240"/>
+            <a:off x="6263640" y="1234440"/>
+            <a:ext cx="5394960" cy="4160520"/>
           </a:xfrm>
           <a:prstGeom prst="rect">
             <a:avLst/>
@@ -10145,8 +9834,8 @@
         </p:nvSpPr>
         <p:spPr>
           <a:xfrm>
-            <a:off x="6263640" y="4434840"/>
-            <a:ext cx="5394960" cy="320040"/>
+            <a:off x="6263640" y="5431536"/>
+            <a:ext cx="5394960" cy="292608"/>
           </a:xfrm>
           <a:prstGeom prst="rect">
             <a:avLst/>
@@ -10384,7 +10073,7 @@
               </a:defRPr>
             </a:pPr>
             <a:r>
-              <a:t>Mockup — Review &amp; Agenda</a:t>
+              <a:t>Tampilan Website</a:t>
             </a:r>
           </a:p>
           <a:p>
@@ -10399,7 +10088,7 @@
               </a:defRPr>
             </a:pPr>
             <a:r>
-              <a:t>Tampilan Pemimpin Bidang dan Agenda Direksi</a:t>
+              <a:t>Review Pimpinan Bidang &amp; Agenda Direksi</a:t>
             </a:r>
           </a:p>
         </p:txBody>
@@ -10412,8 +10101,8 @@
         </p:nvSpPr>
         <p:spPr>
           <a:xfrm>
-            <a:off x="365760" y="1280160"/>
-            <a:ext cx="5486400" cy="3474720"/>
+            <a:off x="356616" y="1179576"/>
+            <a:ext cx="5504688" cy="4544568"/>
           </a:xfrm>
           <a:prstGeom prst="roundRect">
             <a:avLst/>
@@ -10465,8 +10154,8 @@
         </p:blipFill>
         <p:spPr>
           <a:xfrm>
-            <a:off x="411480" y="1325880"/>
-            <a:ext cx="5394960" cy="3063240"/>
+            <a:off x="411480" y="1234440"/>
+            <a:ext cx="5394960" cy="4160520"/>
           </a:xfrm>
           <a:prstGeom prst="rect">
             <a:avLst/>
@@ -10481,8 +10170,8 @@
         </p:nvSpPr>
         <p:spPr>
           <a:xfrm>
-            <a:off x="411480" y="4434840"/>
-            <a:ext cx="5394960" cy="320040"/>
+            <a:off x="411480" y="5431536"/>
+            <a:ext cx="5394960" cy="292608"/>
           </a:xfrm>
           <a:prstGeom prst="rect">
             <a:avLst/>
@@ -10516,8 +10205,8 @@
         </p:nvSpPr>
         <p:spPr>
           <a:xfrm>
-            <a:off x="6217920" y="1280160"/>
-            <a:ext cx="5486400" cy="3474720"/>
+            <a:off x="6208776" y="1179576"/>
+            <a:ext cx="5504688" cy="4544568"/>
           </a:xfrm>
           <a:prstGeom prst="roundRect">
             <a:avLst/>
@@ -10569,8 +10258,8 @@
         </p:blipFill>
         <p:spPr>
           <a:xfrm>
-            <a:off x="6263640" y="1325880"/>
-            <a:ext cx="5394960" cy="3063240"/>
+            <a:off x="6263640" y="1234440"/>
+            <a:ext cx="5394960" cy="4160520"/>
           </a:xfrm>
           <a:prstGeom prst="rect">
             <a:avLst/>
@@ -10585,8 +10274,8 @@
         </p:nvSpPr>
         <p:spPr>
           <a:xfrm>
-            <a:off x="6263640" y="4434840"/>
-            <a:ext cx="5394960" cy="320040"/>
+            <a:off x="6263640" y="5431536"/>
+            <a:ext cx="5394960" cy="292608"/>
           </a:xfrm>
           <a:prstGeom prst="rect">
             <a:avLst/>
@@ -10824,7 +10513,7 @@
               </a:defRPr>
             </a:pPr>
             <a:r>
-              <a:t>Modul Sistem</a:t>
+              <a:t>Fitur Utama &amp; Nilai Manfaat</a:t>
             </a:r>
           </a:p>
           <a:p>
@@ -10839,175 +10528,53 @@
               </a:defRPr>
             </a:pPr>
             <a:r>
-              <a:t>Delapan modul operasional dalam satu platform</a:t>
-            </a:r>
-          </a:p>
-        </p:txBody>
-      </p:sp>
-      <p:sp>
-        <p:nvSpPr>
-          <p:cNvPr id="4" name="TextBox 3"/>
-          <p:cNvSpPr txBox="1"/>
-          <p:nvPr/>
-        </p:nvSpPr>
-        <p:spPr>
-          <a:xfrm>
-            <a:off x="502920" y="1371600"/>
-            <a:ext cx="11155680" cy="4846320"/>
-          </a:xfrm>
-          <a:prstGeom prst="rect">
-            <a:avLst/>
-          </a:prstGeom>
-          <a:noFill/>
-        </p:spPr>
-        <p:txBody>
-          <a:bodyPr wrap="square">
-            <a:spAutoFit/>
-          </a:bodyPr>
-          <a:lstStyle/>
-          <a:p>
-            <a:pPr>
-              <a:lnSpc>
-                <a:spcPct val="120000"/>
-              </a:lnSpc>
-              <a:spcAft>
-                <a:spcPts val="1200"/>
-              </a:spcAft>
-              <a:defRPr sz="1900">
-                <a:solidFill>
-                  <a:srgbClr val="1E293B"/>
-                </a:solidFill>
-              </a:defRPr>
-            </a:pPr>
-            <a:r>
-              <a:t>Dashboard — ringkasan harian CorpSec (agenda, memo, SLA, notifikasi)</a:t>
-            </a:r>
-          </a:p>
-          <a:p>
-            <a:pPr>
-              <a:lnSpc>
-                <a:spcPct val="120000"/>
-              </a:lnSpc>
-              <a:spcAft>
-                <a:spcPts val="1200"/>
-              </a:spcAft>
-              <a:defRPr sz="1900">
-                <a:solidFill>
-                  <a:srgbClr val="1E293B"/>
-                </a:solidFill>
-              </a:defRPr>
-            </a:pPr>
-            <a:r>
-              <a:t>Memorandum — upload PDF, tinjauan, workflow 7 level, tanda tangan</a:t>
-            </a:r>
-          </a:p>
-          <a:p>
-            <a:pPr>
-              <a:lnSpc>
-                <a:spcPct val="120000"/>
-              </a:lnSpc>
-              <a:spcAft>
-                <a:spcPts val="1200"/>
-              </a:spcAft>
-              <a:defRPr sz="1900">
-                <a:solidFill>
-                  <a:srgbClr val="1E293B"/>
-                </a:solidFill>
-              </a:defRPr>
-            </a:pPr>
-            <a:r>
-              <a:t>Agenda Direksi — jadwal kegiatan &amp; catatan persiapan</a:t>
-            </a:r>
-          </a:p>
-          <a:p>
-            <a:pPr>
-              <a:lnSpc>
-                <a:spcPct val="120000"/>
-              </a:lnSpc>
-              <a:spcAft>
-                <a:spcPts val="1200"/>
-              </a:spcAft>
-              <a:defRPr sz="1900">
-                <a:solidFill>
-                  <a:srgbClr val="1E293B"/>
-                </a:solidFill>
-              </a:defRPr>
-            </a:pPr>
-            <a:r>
-              <a:t>Rapat — notulen &amp; tindak lanjut dengan penanggung jawab</a:t>
-            </a:r>
-          </a:p>
-          <a:p>
-            <a:pPr>
-              <a:lnSpc>
-                <a:spcPct val="120000"/>
-              </a:lnSpc>
-              <a:spcAft>
-                <a:spcPts val="1200"/>
-              </a:spcAft>
-              <a:defRPr sz="1900">
-                <a:solidFill>
-                  <a:srgbClr val="1E293B"/>
-                </a:solidFill>
-              </a:defRPr>
-            </a:pPr>
-            <a:r>
-              <a:t>Media Monitoring — berita Bank Sumut &amp; analisis sentimen</a:t>
-            </a:r>
-          </a:p>
-          <a:p>
-            <a:pPr>
-              <a:lnSpc>
-                <a:spcPct val="120000"/>
-              </a:lnSpc>
-              <a:spcAft>
-                <a:spcPts val="1200"/>
-              </a:spcAft>
-              <a:defRPr sz="1900">
-                <a:solidFill>
-                  <a:srgbClr val="1E293B"/>
-                </a:solidFill>
-              </a:defRPr>
-            </a:pPr>
-            <a:r>
-              <a:t>Knowledge Base — arsip SK/SE/SOP &amp; regulasi OJK/BI</a:t>
-            </a:r>
-          </a:p>
-          <a:p>
-            <a:pPr>
-              <a:lnSpc>
-                <a:spcPct val="120000"/>
-              </a:lnSpc>
-              <a:spcAft>
-                <a:spcPts val="1200"/>
-              </a:spcAft>
-              <a:defRPr sz="1900">
-                <a:solidFill>
-                  <a:srgbClr val="1E293B"/>
-                </a:solidFill>
-              </a:defRPr>
-            </a:pPr>
-            <a:r>
-              <a:t>SLA Monitoring — pantau target waktu ≥ 95%</a:t>
-            </a:r>
-          </a:p>
-          <a:p>
-            <a:pPr>
-              <a:lnSpc>
-                <a:spcPct val="120000"/>
-              </a:lnSpc>
-              <a:spcAft>
-                <a:spcPts val="1200"/>
-              </a:spcAft>
-              <a:defRPr sz="1900">
-                <a:solidFill>
-                  <a:srgbClr val="1E293B"/>
-                </a:solidFill>
-              </a:defRPr>
-            </a:pPr>
-            <a:r>
-              <a:t>Laporan — statistik &amp; KPI success metrics PRD</a:t>
-            </a:r>
+              <a:t>Ringkasan kemampuan aplikasi CorpSec Bank Sumut</a:t>
+            </a:r>
+          </a:p>
+        </p:txBody>
+      </p:sp>
+      <p:sp>
+        <p:nvSpPr>
+          <p:cNvPr id="4" name="Rounded Rectangle 3"/>
+          <p:cNvSpPr/>
+          <p:nvPr/>
+        </p:nvSpPr>
+        <p:spPr>
+          <a:xfrm>
+            <a:off x="411480" y="1325880"/>
+            <a:ext cx="5394960" cy="4572000"/>
+          </a:xfrm>
+          <a:prstGeom prst="roundRect">
+            <a:avLst/>
+          </a:prstGeom>
+          <a:solidFill>
+            <a:srgbClr val="FFFFFF"/>
+          </a:solidFill>
+          <a:ln>
+            <a:solidFill>
+              <a:srgbClr val="E2E8F0"/>
+            </a:solidFill>
+          </a:ln>
+        </p:spPr>
+        <p:style>
+          <a:lnRef idx="1">
+            <a:schemeClr val="accent1"/>
+          </a:lnRef>
+          <a:fillRef idx="3">
+            <a:schemeClr val="accent1"/>
+          </a:fillRef>
+          <a:effectRef idx="2">
+            <a:schemeClr val="accent1"/>
+          </a:effectRef>
+          <a:fontRef idx="minor">
+            <a:schemeClr val="lt1"/>
+          </a:fontRef>
+        </p:style>
+        <p:txBody>
+          <a:bodyPr rtlCol="0" anchor="ctr"/>
+          <a:lstStyle/>
+          <a:p>
+            <a:pPr algn="ctr"/>
           </a:p>
         </p:txBody>
       </p:sp>
@@ -11019,8 +10586,8 @@
         </p:nvSpPr>
         <p:spPr>
           <a:xfrm>
-            <a:off x="0" y="6446520"/>
-            <a:ext cx="12191695" cy="411480"/>
+            <a:off x="411480" y="1325880"/>
+            <a:ext cx="5394960" cy="475488"/>
           </a:xfrm>
           <a:prstGeom prst="rect">
             <a:avLst/>
@@ -11062,8 +10629,8 @@
         </p:nvSpPr>
         <p:spPr>
           <a:xfrm>
-            <a:off x="457200" y="6492240"/>
-            <a:ext cx="5486400" cy="320040"/>
+            <a:off x="594360" y="1399032"/>
+            <a:ext cx="5029200" cy="365760"/>
           </a:xfrm>
           <a:prstGeom prst="rect">
             <a:avLst/>
@@ -11077,6 +10644,433 @@
           <a:lstStyle/>
           <a:p>
             <a:pPr>
+              <a:defRPr sz="1600" b="1">
+                <a:solidFill>
+                  <a:srgbClr val="FFFFFF"/>
+                </a:solidFill>
+              </a:defRPr>
+            </a:pPr>
+            <a:r>
+              <a:t>Fitur Utama</a:t>
+            </a:r>
+          </a:p>
+        </p:txBody>
+      </p:sp>
+      <p:sp>
+        <p:nvSpPr>
+          <p:cNvPr id="7" name="TextBox 6"/>
+          <p:cNvSpPr txBox="1"/>
+          <p:nvPr/>
+        </p:nvSpPr>
+        <p:spPr>
+          <a:xfrm>
+            <a:off x="594360" y="1920240"/>
+            <a:ext cx="5029200" cy="3886200"/>
+          </a:xfrm>
+          <a:prstGeom prst="rect">
+            <a:avLst/>
+          </a:prstGeom>
+          <a:noFill/>
+        </p:spPr>
+        <p:txBody>
+          <a:bodyPr wrap="square">
+            <a:spAutoFit/>
+          </a:bodyPr>
+          <a:lstStyle/>
+          <a:p>
+            <a:pPr>
+              <a:spcAft>
+                <a:spcPts val="600"/>
+              </a:spcAft>
+              <a:defRPr sz="1400">
+                <a:solidFill>
+                  <a:srgbClr val="1E293B"/>
+                </a:solidFill>
+              </a:defRPr>
+            </a:pPr>
+            <a:r>
+              <a:t>Upload &amp; kelola memorandum PDF</a:t>
+            </a:r>
+          </a:p>
+          <a:p>
+            <a:pPr>
+              <a:spcAft>
+                <a:spcPts val="600"/>
+              </a:spcAft>
+              <a:defRPr sz="1400">
+                <a:solidFill>
+                  <a:srgbClr val="1E293B"/>
+                </a:solidFill>
+              </a:defRPr>
+            </a:pPr>
+            <a:r>
+              <a:t>Alur persetujuan 7 tahap</a:t>
+            </a:r>
+          </a:p>
+          <a:p>
+            <a:pPr>
+              <a:spcAft>
+                <a:spcPts val="600"/>
+              </a:spcAft>
+              <a:defRPr sz="1400">
+                <a:solidFill>
+                  <a:srgbClr val="1E293B"/>
+                </a:solidFill>
+              </a:defRPr>
+            </a:pPr>
+            <a:r>
+              <a:t>Bantuan rangkum isi memorandum</a:t>
+            </a:r>
+          </a:p>
+          <a:p>
+            <a:pPr>
+              <a:spcAft>
+                <a:spcPts val="600"/>
+              </a:spcAft>
+              <a:defRPr sz="1400">
+                <a:solidFill>
+                  <a:srgbClr val="1E293B"/>
+                </a:solidFill>
+              </a:defRPr>
+            </a:pPr>
+            <a:r>
+              <a:t>Tanda tangan digital saat approval</a:t>
+            </a:r>
+          </a:p>
+          <a:p>
+            <a:pPr>
+              <a:spcAft>
+                <a:spcPts val="600"/>
+              </a:spcAft>
+              <a:defRPr sz="1400">
+                <a:solidFill>
+                  <a:srgbClr val="1E293B"/>
+                </a:solidFill>
+              </a:defRPr>
+            </a:pPr>
+            <a:r>
+              <a:t>Agenda Direksi, rapat, media, arsip dokumen</a:t>
+            </a:r>
+          </a:p>
+          <a:p>
+            <a:pPr>
+              <a:spcAft>
+                <a:spcPts val="600"/>
+              </a:spcAft>
+              <a:defRPr sz="1400">
+                <a:solidFill>
+                  <a:srgbClr val="1E293B"/>
+                </a:solidFill>
+              </a:defRPr>
+            </a:pPr>
+            <a:r>
+              <a:t>Pemantauan SLA &amp; laporan KPI</a:t>
+            </a:r>
+          </a:p>
+        </p:txBody>
+      </p:sp>
+      <p:sp>
+        <p:nvSpPr>
+          <p:cNvPr id="8" name="Rounded Rectangle 7"/>
+          <p:cNvSpPr/>
+          <p:nvPr/>
+        </p:nvSpPr>
+        <p:spPr>
+          <a:xfrm>
+            <a:off x="6263640" y="1325880"/>
+            <a:ext cx="5394960" cy="4572000"/>
+          </a:xfrm>
+          <a:prstGeom prst="roundRect">
+            <a:avLst/>
+          </a:prstGeom>
+          <a:solidFill>
+            <a:srgbClr val="FFFFFF"/>
+          </a:solidFill>
+          <a:ln>
+            <a:solidFill>
+              <a:srgbClr val="E2E8F0"/>
+            </a:solidFill>
+          </a:ln>
+        </p:spPr>
+        <p:style>
+          <a:lnRef idx="1">
+            <a:schemeClr val="accent1"/>
+          </a:lnRef>
+          <a:fillRef idx="3">
+            <a:schemeClr val="accent1"/>
+          </a:fillRef>
+          <a:effectRef idx="2">
+            <a:schemeClr val="accent1"/>
+          </a:effectRef>
+          <a:fontRef idx="minor">
+            <a:schemeClr val="lt1"/>
+          </a:fontRef>
+        </p:style>
+        <p:txBody>
+          <a:bodyPr rtlCol="0" anchor="ctr"/>
+          <a:lstStyle/>
+          <a:p>
+            <a:pPr algn="ctr"/>
+          </a:p>
+        </p:txBody>
+      </p:sp>
+      <p:sp>
+        <p:nvSpPr>
+          <p:cNvPr id="9" name="Rectangle 8"/>
+          <p:cNvSpPr/>
+          <p:nvPr/>
+        </p:nvSpPr>
+        <p:spPr>
+          <a:xfrm>
+            <a:off x="6263640" y="1325880"/>
+            <a:ext cx="5394960" cy="475488"/>
+          </a:xfrm>
+          <a:prstGeom prst="rect">
+            <a:avLst/>
+          </a:prstGeom>
+          <a:solidFill>
+            <a:srgbClr val="F58220"/>
+          </a:solidFill>
+          <a:ln>
+            <a:noFill/>
+          </a:ln>
+        </p:spPr>
+        <p:style>
+          <a:lnRef idx="1">
+            <a:schemeClr val="accent1"/>
+          </a:lnRef>
+          <a:fillRef idx="3">
+            <a:schemeClr val="accent1"/>
+          </a:fillRef>
+          <a:effectRef idx="2">
+            <a:schemeClr val="accent1"/>
+          </a:effectRef>
+          <a:fontRef idx="minor">
+            <a:schemeClr val="lt1"/>
+          </a:fontRef>
+        </p:style>
+        <p:txBody>
+          <a:bodyPr rtlCol="0" anchor="ctr"/>
+          <a:lstStyle/>
+          <a:p>
+            <a:pPr algn="ctr"/>
+          </a:p>
+        </p:txBody>
+      </p:sp>
+      <p:sp>
+        <p:nvSpPr>
+          <p:cNvPr id="10" name="TextBox 9"/>
+          <p:cNvSpPr txBox="1"/>
+          <p:nvPr/>
+        </p:nvSpPr>
+        <p:spPr>
+          <a:xfrm>
+            <a:off x="6446520" y="1399032"/>
+            <a:ext cx="5029200" cy="365760"/>
+          </a:xfrm>
+          <a:prstGeom prst="rect">
+            <a:avLst/>
+          </a:prstGeom>
+          <a:noFill/>
+        </p:spPr>
+        <p:txBody>
+          <a:bodyPr wrap="none">
+            <a:spAutoFit/>
+          </a:bodyPr>
+          <a:lstStyle/>
+          <a:p>
+            <a:pPr>
+              <a:defRPr sz="1600" b="1">
+                <a:solidFill>
+                  <a:srgbClr val="FFFFFF"/>
+                </a:solidFill>
+              </a:defRPr>
+            </a:pPr>
+            <a:r>
+              <a:t>Nilai Manfaat</a:t>
+            </a:r>
+          </a:p>
+        </p:txBody>
+      </p:sp>
+      <p:sp>
+        <p:nvSpPr>
+          <p:cNvPr id="11" name="TextBox 10"/>
+          <p:cNvSpPr txBox="1"/>
+          <p:nvPr/>
+        </p:nvSpPr>
+        <p:spPr>
+          <a:xfrm>
+            <a:off x="6446520" y="1920240"/>
+            <a:ext cx="5029200" cy="3886200"/>
+          </a:xfrm>
+          <a:prstGeom prst="rect">
+            <a:avLst/>
+          </a:prstGeom>
+          <a:noFill/>
+        </p:spPr>
+        <p:txBody>
+          <a:bodyPr wrap="square">
+            <a:spAutoFit/>
+          </a:bodyPr>
+          <a:lstStyle/>
+          <a:p>
+            <a:pPr>
+              <a:spcAft>
+                <a:spcPts val="600"/>
+              </a:spcAft>
+              <a:defRPr sz="1400">
+                <a:solidFill>
+                  <a:srgbClr val="1E293B"/>
+                </a:solidFill>
+              </a:defRPr>
+            </a:pPr>
+            <a:r>
+              <a:t>Proses lebih cepat &amp; terlacak</a:t>
+            </a:r>
+          </a:p>
+          <a:p>
+            <a:pPr>
+              <a:spcAft>
+                <a:spcPts val="600"/>
+              </a:spcAft>
+              <a:defRPr sz="1400">
+                <a:solidFill>
+                  <a:srgbClr val="1E293B"/>
+                </a:solidFill>
+              </a:defRPr>
+            </a:pPr>
+            <a:r>
+              <a:t>Mengurangi kertas &amp; duplikasi data</a:t>
+            </a:r>
+          </a:p>
+          <a:p>
+            <a:pPr>
+              <a:spcAft>
+                <a:spcPts val="600"/>
+              </a:spcAft>
+              <a:defRPr sz="1400">
+                <a:solidFill>
+                  <a:srgbClr val="1E293B"/>
+                </a:solidFill>
+              </a:defRPr>
+            </a:pPr>
+            <a:r>
+              <a:t>Keputusan lebih terdokumentasi</a:t>
+            </a:r>
+          </a:p>
+          <a:p>
+            <a:pPr>
+              <a:spcAft>
+                <a:spcPts val="600"/>
+              </a:spcAft>
+              <a:defRPr sz="1400">
+                <a:solidFill>
+                  <a:srgbClr val="1E293B"/>
+                </a:solidFill>
+              </a:defRPr>
+            </a:pPr>
+            <a:r>
+              <a:t>CorpSec punya dashboard terpusat</a:t>
+            </a:r>
+          </a:p>
+          <a:p>
+            <a:pPr>
+              <a:spcAft>
+                <a:spcPts val="600"/>
+              </a:spcAft>
+              <a:defRPr sz="1400">
+                <a:solidFill>
+                  <a:srgbClr val="1E293B"/>
+                </a:solidFill>
+              </a:defRPr>
+            </a:pPr>
+            <a:r>
+              <a:t>Setiap role hanya lihat tugasnya</a:t>
+            </a:r>
+          </a:p>
+          <a:p>
+            <a:pPr>
+              <a:spcAft>
+                <a:spcPts val="600"/>
+              </a:spcAft>
+              <a:defRPr sz="1400">
+                <a:solidFill>
+                  <a:srgbClr val="1E293B"/>
+                </a:solidFill>
+              </a:defRPr>
+            </a:pPr>
+            <a:r>
+              <a:t>Siap demo untuk evaluasi internal</a:t>
+            </a:r>
+          </a:p>
+        </p:txBody>
+      </p:sp>
+      <p:sp>
+        <p:nvSpPr>
+          <p:cNvPr id="12" name="Rectangle 11"/>
+          <p:cNvSpPr/>
+          <p:nvPr/>
+        </p:nvSpPr>
+        <p:spPr>
+          <a:xfrm>
+            <a:off x="0" y="6446520"/>
+            <a:ext cx="12191695" cy="411480"/>
+          </a:xfrm>
+          <a:prstGeom prst="rect">
+            <a:avLst/>
+          </a:prstGeom>
+          <a:solidFill>
+            <a:srgbClr val="0C2340"/>
+          </a:solidFill>
+          <a:ln>
+            <a:noFill/>
+          </a:ln>
+        </p:spPr>
+        <p:style>
+          <a:lnRef idx="1">
+            <a:schemeClr val="accent1"/>
+          </a:lnRef>
+          <a:fillRef idx="3">
+            <a:schemeClr val="accent1"/>
+          </a:fillRef>
+          <a:effectRef idx="2">
+            <a:schemeClr val="accent1"/>
+          </a:effectRef>
+          <a:fontRef idx="minor">
+            <a:schemeClr val="lt1"/>
+          </a:fontRef>
+        </p:style>
+        <p:txBody>
+          <a:bodyPr rtlCol="0" anchor="ctr"/>
+          <a:lstStyle/>
+          <a:p>
+            <a:pPr algn="ctr"/>
+          </a:p>
+        </p:txBody>
+      </p:sp>
+      <p:sp>
+        <p:nvSpPr>
+          <p:cNvPr id="13" name="TextBox 12"/>
+          <p:cNvSpPr txBox="1"/>
+          <p:nvPr/>
+        </p:nvSpPr>
+        <p:spPr>
+          <a:xfrm>
+            <a:off x="457200" y="6492240"/>
+            <a:ext cx="5486400" cy="320040"/>
+          </a:xfrm>
+          <a:prstGeom prst="rect">
+            <a:avLst/>
+          </a:prstGeom>
+          <a:noFill/>
+        </p:spPr>
+        <p:txBody>
+          <a:bodyPr wrap="none">
+            <a:spAutoFit/>
+          </a:bodyPr>
+          <a:lstStyle/>
+          <a:p>
+            <a:pPr>
               <a:defRPr sz="1100" b="1">
                 <a:solidFill>
                   <a:srgbClr val="F58220"/>
@@ -11091,7 +11085,7 @@
       </p:sp>
       <p:sp>
         <p:nvSpPr>
-          <p:cNvPr id="7" name="TextBox 6"/>
+          <p:cNvPr id="14" name="TextBox 13"/>
           <p:cNvSpPr txBox="1"/>
           <p:nvPr/>
         </p:nvSpPr>
@@ -11223,7 +11217,7 @@
               </a:defRPr>
             </a:pPr>
             <a:r>
-              <a:t>Alur Kerja Memorandum</a:t>
+              <a:t>Modul Sistem</a:t>
             </a:r>
           </a:p>
           <a:p>
@@ -11238,7 +11232,7 @@
               </a:defRPr>
             </a:pPr>
             <a:r>
-              <a:t>7 tahap persetujuan sesuai PRD</a:t>
+              <a:t>Delapan modul operasional dalam satu platform</a:t>
             </a:r>
           </a:p>
         </p:txBody>
@@ -11272,14 +11266,14 @@
               <a:spcAft>
                 <a:spcPts val="1200"/>
               </a:spcAft>
-              <a:defRPr sz="2000">
+              <a:defRPr sz="1900">
                 <a:solidFill>
                   <a:srgbClr val="1E293B"/>
                 </a:solidFill>
               </a:defRPr>
             </a:pPr>
             <a:r>
-              <a:t>1. Divisi Pengusul — kirim memorandum PDF</a:t>
+              <a:t>Dashboard — ringkasan harian CorpSec (agenda, memo, SLA, notifikasi)</a:t>
             </a:r>
           </a:p>
           <a:p>
@@ -11290,14 +11284,14 @@
               <a:spcAft>
                 <a:spcPts val="1200"/>
               </a:spcAft>
-              <a:defRPr sz="2000">
+              <a:defRPr sz="1900">
                 <a:solidFill>
                   <a:srgbClr val="1E293B"/>
                 </a:solidFill>
               </a:defRPr>
             </a:pPr>
             <a:r>
-              <a:t>2. Corporate Secretary — terima, rangkum, &amp; tinjau kelengkapan</a:t>
+              <a:t>Memorandum — upload PDF, tinjauan, workflow 7 level, tanda tangan</a:t>
             </a:r>
           </a:p>
           <a:p>
@@ -11308,14 +11302,14 @@
               <a:spcAft>
                 <a:spcPts val="1200"/>
               </a:spcAft>
-              <a:defRPr sz="2000">
+              <a:defRPr sz="1900">
                 <a:solidFill>
                   <a:srgbClr val="1E293B"/>
                 </a:solidFill>
               </a:defRPr>
             </a:pPr>
             <a:r>
-              <a:t>3. Pemimpin Bidang — setujui atau tolak + tanda tangan</a:t>
+              <a:t>Agenda Direksi — jadwal kegiatan &amp; catatan persiapan</a:t>
             </a:r>
           </a:p>
           <a:p>
@@ -11326,14 +11320,14 @@
               <a:spcAft>
                 <a:spcPts val="1200"/>
               </a:spcAft>
-              <a:defRPr sz="2000">
+              <a:defRPr sz="1900">
                 <a:solidFill>
                   <a:srgbClr val="1E293B"/>
                 </a:solidFill>
               </a:defRPr>
             </a:pPr>
             <a:r>
-              <a:t>4. Sekretaris Direksi/Komisaris — teruskan ke pimpinan</a:t>
+              <a:t>Rapat — notulen &amp; tindak lanjut dengan penanggung jawab</a:t>
             </a:r>
           </a:p>
           <a:p>
@@ -11344,14 +11338,14 @@
               <a:spcAft>
                 <a:spcPts val="1200"/>
               </a:spcAft>
-              <a:defRPr sz="2000">
+              <a:defRPr sz="1900">
                 <a:solidFill>
                   <a:srgbClr val="1E293B"/>
                 </a:solidFill>
               </a:defRPr>
             </a:pPr>
             <a:r>
-              <a:t>5. Direksi / Komisaris — beri keputusan</a:t>
+              <a:t>Media Monitoring — berita Bank Sumut &amp; analisis sentimen</a:t>
             </a:r>
           </a:p>
           <a:p>
@@ -11362,14 +11356,14 @@
               <a:spcAft>
                 <a:spcPts val="1200"/>
               </a:spcAft>
-              <a:defRPr sz="2000">
+              <a:defRPr sz="1900">
                 <a:solidFill>
                   <a:srgbClr val="1E293B"/>
                 </a:solidFill>
               </a:defRPr>
             </a:pPr>
             <a:r>
-              <a:t>6. CorpSec — finalisasi sesuai keputusan board</a:t>
+              <a:t>Knowledge Base — arsip SK/SE/SOP &amp; regulasi OJK/BI</a:t>
             </a:r>
           </a:p>
           <a:p>
@@ -11380,14 +11374,32 @@
               <a:spcAft>
                 <a:spcPts val="1200"/>
               </a:spcAft>
-              <a:defRPr sz="2000">
+              <a:defRPr sz="1900">
                 <a:solidFill>
                   <a:srgbClr val="1E293B"/>
                 </a:solidFill>
               </a:defRPr>
             </a:pPr>
             <a:r>
-              <a:t>7. Kembali ke Pengusul — pemberitahuan hasil akhir</a:t>
+              <a:t>SLA Monitoring — pantau target waktu ≥ 95%</a:t>
+            </a:r>
+          </a:p>
+          <a:p>
+            <a:pPr>
+              <a:lnSpc>
+                <a:spcPct val="120000"/>
+              </a:lnSpc>
+              <a:spcAft>
+                <a:spcPts val="1200"/>
+              </a:spcAft>
+              <a:defRPr sz="1900">
+                <a:solidFill>
+                  <a:srgbClr val="1E293B"/>
+                </a:solidFill>
+              </a:defRPr>
+            </a:pPr>
+            <a:r>
+              <a:t>Laporan — statistik &amp; KPI success metrics PRD</a:t>
             </a:r>
           </a:p>
         </p:txBody>

</xml_diff>

<commit_message>
Add Bank Sumut logo to every PPT slide (header + footer)
Co-authored-by: kelompok8ai <kelompok8ai@users.noreply.github.com>
</commit_message>
<xml_diff>
--- a/CorpSec-Bank-Sumut-Presentasi.pptx
+++ b/CorpSec-Bank-Sumut-Presentasi.pptx
@@ -3269,9 +3269,68 @@
           </a:p>
         </p:txBody>
       </p:sp>
-      <p:sp>
-        <p:nvSpPr>
-          <p:cNvPr id="6" name="Rectangle 5"/>
+      <p:pic>
+        <p:nvPicPr>
+          <p:cNvPr id="6" name="Picture 5" descr="logo-banksumut.png"/>
+          <p:cNvPicPr>
+            <a:picLocks noChangeAspect="1"/>
+          </p:cNvPicPr>
+          <p:nvPr/>
+        </p:nvPicPr>
+        <p:blipFill>
+          <a:blip r:embed="rId2"/>
+          <a:stretch>
+            <a:fillRect/>
+          </a:stretch>
+        </p:blipFill>
+        <p:spPr>
+          <a:xfrm>
+            <a:off x="640080" y="502920"/>
+            <a:ext cx="685800" cy="685800"/>
+          </a:xfrm>
+          <a:prstGeom prst="rect">
+            <a:avLst/>
+          </a:prstGeom>
+        </p:spPr>
+      </p:pic>
+      <p:sp>
+        <p:nvSpPr>
+          <p:cNvPr id="7" name="TextBox 6"/>
+          <p:cNvSpPr txBox="1"/>
+          <p:nvPr/>
+        </p:nvSpPr>
+        <p:spPr>
+          <a:xfrm>
+            <a:off x="1463040" y="566928"/>
+            <a:ext cx="3657600" cy="548640"/>
+          </a:xfrm>
+          <a:prstGeom prst="rect">
+            <a:avLst/>
+          </a:prstGeom>
+          <a:noFill/>
+        </p:spPr>
+        <p:txBody>
+          <a:bodyPr wrap="none">
+            <a:spAutoFit/>
+          </a:bodyPr>
+          <a:lstStyle/>
+          <a:p>
+            <a:pPr>
+              <a:defRPr sz="1800" b="1">
+                <a:solidFill>
+                  <a:srgbClr val="FFFFFF"/>
+                </a:solidFill>
+              </a:defRPr>
+            </a:pPr>
+            <a:r>
+              <a:t>Bank Sumut</a:t>
+            </a:r>
+          </a:p>
+        </p:txBody>
+      </p:sp>
+      <p:sp>
+        <p:nvSpPr>
+          <p:cNvPr id="8" name="Rectangle 7"/>
           <p:cNvSpPr/>
           <p:nvPr/>
         </p:nvSpPr>
@@ -3312,15 +3371,39 @@
           </a:p>
         </p:txBody>
       </p:sp>
-      <p:sp>
-        <p:nvSpPr>
-          <p:cNvPr id="7" name="TextBox 6"/>
+      <p:pic>
+        <p:nvPicPr>
+          <p:cNvPr id="9" name="Picture 8" descr="logo-banksumut.png"/>
+          <p:cNvPicPr>
+            <a:picLocks noChangeAspect="1"/>
+          </p:cNvPicPr>
+          <p:nvPr/>
+        </p:nvPicPr>
+        <p:blipFill>
+          <a:blip r:embed="rId2"/>
+          <a:stretch>
+            <a:fillRect/>
+          </a:stretch>
+        </p:blipFill>
+        <p:spPr>
+          <a:xfrm>
+            <a:off x="164592" y="6455664"/>
+            <a:ext cx="310896" cy="310896"/>
+          </a:xfrm>
+          <a:prstGeom prst="rect">
+            <a:avLst/>
+          </a:prstGeom>
+        </p:spPr>
+      </p:pic>
+      <p:sp>
+        <p:nvSpPr>
+          <p:cNvPr id="10" name="TextBox 9"/>
           <p:cNvSpPr txBox="1"/>
           <p:nvPr/>
         </p:nvSpPr>
         <p:spPr>
           <a:xfrm>
-            <a:off x="457200" y="6492240"/>
+            <a:off x="530352" y="6492240"/>
             <a:ext cx="5486400" cy="320040"/>
           </a:xfrm>
           <a:prstGeom prst="rect">
@@ -3349,7 +3432,7 @@
       </p:sp>
       <p:sp>
         <p:nvSpPr>
-          <p:cNvPr id="8" name="TextBox 7"/>
+          <p:cNvPr id="11" name="TextBox 10"/>
           <p:cNvSpPr txBox="1"/>
           <p:nvPr/>
         </p:nvSpPr>
@@ -3382,6 +3465,30 @@
           </a:p>
         </p:txBody>
       </p:sp>
+      <p:pic>
+        <p:nvPicPr>
+          <p:cNvPr id="12" name="Picture 11" descr="logo-banksumut.png"/>
+          <p:cNvPicPr>
+            <a:picLocks noChangeAspect="1"/>
+          </p:cNvPicPr>
+          <p:nvPr/>
+        </p:nvPicPr>
+        <p:blipFill>
+          <a:blip r:embed="rId2"/>
+          <a:stretch>
+            <a:fillRect/>
+          </a:stretch>
+        </p:blipFill>
+        <p:spPr>
+          <a:xfrm>
+            <a:off x="11350447" y="201168"/>
+            <a:ext cx="475488" cy="475488"/>
+          </a:xfrm>
+          <a:prstGeom prst="rect">
+            <a:avLst/>
+          </a:prstGeom>
+        </p:spPr>
+      </p:pic>
     </p:spTree>
   </p:cSld>
   <p:clrMapOvr>
@@ -3693,15 +3800,39 @@
           </a:p>
         </p:txBody>
       </p:sp>
-      <p:sp>
-        <p:nvSpPr>
-          <p:cNvPr id="6" name="TextBox 5"/>
+      <p:pic>
+        <p:nvPicPr>
+          <p:cNvPr id="6" name="Picture 5" descr="logo-banksumut.png"/>
+          <p:cNvPicPr>
+            <a:picLocks noChangeAspect="1"/>
+          </p:cNvPicPr>
+          <p:nvPr/>
+        </p:nvPicPr>
+        <p:blipFill>
+          <a:blip r:embed="rId2"/>
+          <a:stretch>
+            <a:fillRect/>
+          </a:stretch>
+        </p:blipFill>
+        <p:spPr>
+          <a:xfrm>
+            <a:off x="164592" y="6455664"/>
+            <a:ext cx="310896" cy="310896"/>
+          </a:xfrm>
+          <a:prstGeom prst="rect">
+            <a:avLst/>
+          </a:prstGeom>
+        </p:spPr>
+      </p:pic>
+      <p:sp>
+        <p:nvSpPr>
+          <p:cNvPr id="7" name="TextBox 6"/>
           <p:cNvSpPr txBox="1"/>
           <p:nvPr/>
         </p:nvSpPr>
         <p:spPr>
           <a:xfrm>
-            <a:off x="457200" y="6492240"/>
+            <a:off x="530352" y="6492240"/>
             <a:ext cx="5486400" cy="320040"/>
           </a:xfrm>
           <a:prstGeom prst="rect">
@@ -3730,7 +3861,7 @@
       </p:sp>
       <p:sp>
         <p:nvSpPr>
-          <p:cNvPr id="7" name="TextBox 6"/>
+          <p:cNvPr id="8" name="TextBox 7"/>
           <p:cNvSpPr txBox="1"/>
           <p:nvPr/>
         </p:nvSpPr>
@@ -3763,6 +3894,30 @@
           </a:p>
         </p:txBody>
       </p:sp>
+      <p:pic>
+        <p:nvPicPr>
+          <p:cNvPr id="9" name="Picture 8" descr="logo-banksumut.png"/>
+          <p:cNvPicPr>
+            <a:picLocks noChangeAspect="1"/>
+          </p:cNvPicPr>
+          <p:nvPr/>
+        </p:nvPicPr>
+        <p:blipFill>
+          <a:blip r:embed="rId2"/>
+          <a:stretch>
+            <a:fillRect/>
+          </a:stretch>
+        </p:blipFill>
+        <p:spPr>
+          <a:xfrm>
+            <a:off x="11350447" y="201168"/>
+            <a:ext cx="475488" cy="475488"/>
+          </a:xfrm>
+          <a:prstGeom prst="rect">
+            <a:avLst/>
+          </a:prstGeom>
+        </p:spPr>
+      </p:pic>
     </p:spTree>
   </p:cSld>
   <p:clrMapOvr>
@@ -4457,15 +4612,39 @@
           </a:p>
         </p:txBody>
       </p:sp>
-      <p:sp>
-        <p:nvSpPr>
-          <p:cNvPr id="13" name="TextBox 12"/>
+      <p:pic>
+        <p:nvPicPr>
+          <p:cNvPr id="13" name="Picture 12" descr="logo-banksumut.png"/>
+          <p:cNvPicPr>
+            <a:picLocks noChangeAspect="1"/>
+          </p:cNvPicPr>
+          <p:nvPr/>
+        </p:nvPicPr>
+        <p:blipFill>
+          <a:blip r:embed="rId2"/>
+          <a:stretch>
+            <a:fillRect/>
+          </a:stretch>
+        </p:blipFill>
+        <p:spPr>
+          <a:xfrm>
+            <a:off x="164592" y="6455664"/>
+            <a:ext cx="310896" cy="310896"/>
+          </a:xfrm>
+          <a:prstGeom prst="rect">
+            <a:avLst/>
+          </a:prstGeom>
+        </p:spPr>
+      </p:pic>
+      <p:sp>
+        <p:nvSpPr>
+          <p:cNvPr id="14" name="TextBox 13"/>
           <p:cNvSpPr txBox="1"/>
           <p:nvPr/>
         </p:nvSpPr>
         <p:spPr>
           <a:xfrm>
-            <a:off x="457200" y="6492240"/>
+            <a:off x="530352" y="6492240"/>
             <a:ext cx="5486400" cy="320040"/>
           </a:xfrm>
           <a:prstGeom prst="rect">
@@ -4494,7 +4673,7 @@
       </p:sp>
       <p:sp>
         <p:nvSpPr>
-          <p:cNvPr id="14" name="TextBox 13"/>
+          <p:cNvPr id="15" name="TextBox 14"/>
           <p:cNvSpPr txBox="1"/>
           <p:nvPr/>
         </p:nvSpPr>
@@ -4527,6 +4706,30 @@
           </a:p>
         </p:txBody>
       </p:sp>
+      <p:pic>
+        <p:nvPicPr>
+          <p:cNvPr id="16" name="Picture 15" descr="logo-banksumut.png"/>
+          <p:cNvPicPr>
+            <a:picLocks noChangeAspect="1"/>
+          </p:cNvPicPr>
+          <p:nvPr/>
+        </p:nvPicPr>
+        <p:blipFill>
+          <a:blip r:embed="rId2"/>
+          <a:stretch>
+            <a:fillRect/>
+          </a:stretch>
+        </p:blipFill>
+        <p:spPr>
+          <a:xfrm>
+            <a:off x="11350447" y="201168"/>
+            <a:ext cx="475488" cy="475488"/>
+          </a:xfrm>
+          <a:prstGeom prst="rect">
+            <a:avLst/>
+          </a:prstGeom>
+        </p:spPr>
+      </p:pic>
     </p:spTree>
   </p:cSld>
   <p:clrMapOvr>
@@ -5191,15 +5394,39 @@
           </a:p>
         </p:txBody>
       </p:sp>
-      <p:sp>
-        <p:nvSpPr>
-          <p:cNvPr id="13" name="TextBox 12"/>
+      <p:pic>
+        <p:nvPicPr>
+          <p:cNvPr id="13" name="Picture 12" descr="logo-banksumut.png"/>
+          <p:cNvPicPr>
+            <a:picLocks noChangeAspect="1"/>
+          </p:cNvPicPr>
+          <p:nvPr/>
+        </p:nvPicPr>
+        <p:blipFill>
+          <a:blip r:embed="rId2"/>
+          <a:stretch>
+            <a:fillRect/>
+          </a:stretch>
+        </p:blipFill>
+        <p:spPr>
+          <a:xfrm>
+            <a:off x="164592" y="6455664"/>
+            <a:ext cx="310896" cy="310896"/>
+          </a:xfrm>
+          <a:prstGeom prst="rect">
+            <a:avLst/>
+          </a:prstGeom>
+        </p:spPr>
+      </p:pic>
+      <p:sp>
+        <p:nvSpPr>
+          <p:cNvPr id="14" name="TextBox 13"/>
           <p:cNvSpPr txBox="1"/>
           <p:nvPr/>
         </p:nvSpPr>
         <p:spPr>
           <a:xfrm>
-            <a:off x="457200" y="6492240"/>
+            <a:off x="530352" y="6492240"/>
             <a:ext cx="5486400" cy="320040"/>
           </a:xfrm>
           <a:prstGeom prst="rect">
@@ -5228,7 +5455,7 @@
       </p:sp>
       <p:sp>
         <p:nvSpPr>
-          <p:cNvPr id="14" name="TextBox 13"/>
+          <p:cNvPr id="15" name="TextBox 14"/>
           <p:cNvSpPr txBox="1"/>
           <p:nvPr/>
         </p:nvSpPr>
@@ -5261,6 +5488,30 @@
           </a:p>
         </p:txBody>
       </p:sp>
+      <p:pic>
+        <p:nvPicPr>
+          <p:cNvPr id="16" name="Picture 15" descr="logo-banksumut.png"/>
+          <p:cNvPicPr>
+            <a:picLocks noChangeAspect="1"/>
+          </p:cNvPicPr>
+          <p:nvPr/>
+        </p:nvPicPr>
+        <p:blipFill>
+          <a:blip r:embed="rId2"/>
+          <a:stretch>
+            <a:fillRect/>
+          </a:stretch>
+        </p:blipFill>
+        <p:spPr>
+          <a:xfrm>
+            <a:off x="11350447" y="201168"/>
+            <a:ext cx="475488" cy="475488"/>
+          </a:xfrm>
+          <a:prstGeom prst="rect">
+            <a:avLst/>
+          </a:prstGeom>
+        </p:spPr>
+      </p:pic>
     </p:spTree>
   </p:cSld>
   <p:clrMapOvr>
@@ -6041,15 +6292,39 @@
           </a:p>
         </p:txBody>
       </p:sp>
-      <p:sp>
-        <p:nvSpPr>
-          <p:cNvPr id="17" name="TextBox 16"/>
+      <p:pic>
+        <p:nvPicPr>
+          <p:cNvPr id="17" name="Picture 16" descr="logo-banksumut.png"/>
+          <p:cNvPicPr>
+            <a:picLocks noChangeAspect="1"/>
+          </p:cNvPicPr>
+          <p:nvPr/>
+        </p:nvPicPr>
+        <p:blipFill>
+          <a:blip r:embed="rId2"/>
+          <a:stretch>
+            <a:fillRect/>
+          </a:stretch>
+        </p:blipFill>
+        <p:spPr>
+          <a:xfrm>
+            <a:off x="164592" y="6455664"/>
+            <a:ext cx="310896" cy="310896"/>
+          </a:xfrm>
+          <a:prstGeom prst="rect">
+            <a:avLst/>
+          </a:prstGeom>
+        </p:spPr>
+      </p:pic>
+      <p:sp>
+        <p:nvSpPr>
+          <p:cNvPr id="18" name="TextBox 17"/>
           <p:cNvSpPr txBox="1"/>
           <p:nvPr/>
         </p:nvSpPr>
         <p:spPr>
           <a:xfrm>
-            <a:off x="457200" y="6492240"/>
+            <a:off x="530352" y="6492240"/>
             <a:ext cx="5486400" cy="320040"/>
           </a:xfrm>
           <a:prstGeom prst="rect">
@@ -6078,7 +6353,7 @@
       </p:sp>
       <p:sp>
         <p:nvSpPr>
-          <p:cNvPr id="18" name="TextBox 17"/>
+          <p:cNvPr id="19" name="TextBox 18"/>
           <p:cNvSpPr txBox="1"/>
           <p:nvPr/>
         </p:nvSpPr>
@@ -6111,6 +6386,30 @@
           </a:p>
         </p:txBody>
       </p:sp>
+      <p:pic>
+        <p:nvPicPr>
+          <p:cNvPr id="20" name="Picture 19" descr="logo-banksumut.png"/>
+          <p:cNvPicPr>
+            <a:picLocks noChangeAspect="1"/>
+          </p:cNvPicPr>
+          <p:nvPr/>
+        </p:nvPicPr>
+        <p:blipFill>
+          <a:blip r:embed="rId2"/>
+          <a:stretch>
+            <a:fillRect/>
+          </a:stretch>
+        </p:blipFill>
+        <p:spPr>
+          <a:xfrm>
+            <a:off x="11350447" y="201168"/>
+            <a:ext cx="475488" cy="475488"/>
+          </a:xfrm>
+          <a:prstGeom prst="rect">
+            <a:avLst/>
+          </a:prstGeom>
+        </p:spPr>
+      </p:pic>
     </p:spTree>
   </p:cSld>
   <p:clrMapOvr>
@@ -6285,9 +6584,68 @@
           </a:p>
         </p:txBody>
       </p:sp>
-      <p:sp>
-        <p:nvSpPr>
-          <p:cNvPr id="6" name="Rectangle 5"/>
+      <p:pic>
+        <p:nvPicPr>
+          <p:cNvPr id="6" name="Picture 5" descr="logo-banksumut.png"/>
+          <p:cNvPicPr>
+            <a:picLocks noChangeAspect="1"/>
+          </p:cNvPicPr>
+          <p:nvPr/>
+        </p:nvPicPr>
+        <p:blipFill>
+          <a:blip r:embed="rId2"/>
+          <a:stretch>
+            <a:fillRect/>
+          </a:stretch>
+        </p:blipFill>
+        <p:spPr>
+          <a:xfrm>
+            <a:off x="640080" y="502920"/>
+            <a:ext cx="685800" cy="685800"/>
+          </a:xfrm>
+          <a:prstGeom prst="rect">
+            <a:avLst/>
+          </a:prstGeom>
+        </p:spPr>
+      </p:pic>
+      <p:sp>
+        <p:nvSpPr>
+          <p:cNvPr id="7" name="TextBox 6"/>
+          <p:cNvSpPr txBox="1"/>
+          <p:nvPr/>
+        </p:nvSpPr>
+        <p:spPr>
+          <a:xfrm>
+            <a:off x="1463040" y="566928"/>
+            <a:ext cx="3657600" cy="548640"/>
+          </a:xfrm>
+          <a:prstGeom prst="rect">
+            <a:avLst/>
+          </a:prstGeom>
+          <a:noFill/>
+        </p:spPr>
+        <p:txBody>
+          <a:bodyPr wrap="none">
+            <a:spAutoFit/>
+          </a:bodyPr>
+          <a:lstStyle/>
+          <a:p>
+            <a:pPr>
+              <a:defRPr sz="1800" b="1">
+                <a:solidFill>
+                  <a:srgbClr val="FFFFFF"/>
+                </a:solidFill>
+              </a:defRPr>
+            </a:pPr>
+            <a:r>
+              <a:t>Bank Sumut</a:t>
+            </a:r>
+          </a:p>
+        </p:txBody>
+      </p:sp>
+      <p:sp>
+        <p:nvSpPr>
+          <p:cNvPr id="8" name="Rectangle 7"/>
           <p:cNvSpPr/>
           <p:nvPr/>
         </p:nvSpPr>
@@ -6328,15 +6686,39 @@
           </a:p>
         </p:txBody>
       </p:sp>
-      <p:sp>
-        <p:nvSpPr>
-          <p:cNvPr id="7" name="TextBox 6"/>
+      <p:pic>
+        <p:nvPicPr>
+          <p:cNvPr id="9" name="Picture 8" descr="logo-banksumut.png"/>
+          <p:cNvPicPr>
+            <a:picLocks noChangeAspect="1"/>
+          </p:cNvPicPr>
+          <p:nvPr/>
+        </p:nvPicPr>
+        <p:blipFill>
+          <a:blip r:embed="rId2"/>
+          <a:stretch>
+            <a:fillRect/>
+          </a:stretch>
+        </p:blipFill>
+        <p:spPr>
+          <a:xfrm>
+            <a:off x="164592" y="6455664"/>
+            <a:ext cx="310896" cy="310896"/>
+          </a:xfrm>
+          <a:prstGeom prst="rect">
+            <a:avLst/>
+          </a:prstGeom>
+        </p:spPr>
+      </p:pic>
+      <p:sp>
+        <p:nvSpPr>
+          <p:cNvPr id="10" name="TextBox 9"/>
           <p:cNvSpPr txBox="1"/>
           <p:nvPr/>
         </p:nvSpPr>
         <p:spPr>
           <a:xfrm>
-            <a:off x="457200" y="6492240"/>
+            <a:off x="530352" y="6492240"/>
             <a:ext cx="5486400" cy="320040"/>
           </a:xfrm>
           <a:prstGeom prst="rect">
@@ -6365,7 +6747,7 @@
       </p:sp>
       <p:sp>
         <p:nvSpPr>
-          <p:cNvPr id="8" name="TextBox 7"/>
+          <p:cNvPr id="11" name="TextBox 10"/>
           <p:cNvSpPr txBox="1"/>
           <p:nvPr/>
         </p:nvSpPr>
@@ -6398,6 +6780,30 @@
           </a:p>
         </p:txBody>
       </p:sp>
+      <p:pic>
+        <p:nvPicPr>
+          <p:cNvPr id="12" name="Picture 11" descr="logo-banksumut.png"/>
+          <p:cNvPicPr>
+            <a:picLocks noChangeAspect="1"/>
+          </p:cNvPicPr>
+          <p:nvPr/>
+        </p:nvPicPr>
+        <p:blipFill>
+          <a:blip r:embed="rId2"/>
+          <a:stretch>
+            <a:fillRect/>
+          </a:stretch>
+        </p:blipFill>
+        <p:spPr>
+          <a:xfrm>
+            <a:off x="11350447" y="201168"/>
+            <a:ext cx="475488" cy="475488"/>
+          </a:xfrm>
+          <a:prstGeom prst="rect">
+            <a:avLst/>
+          </a:prstGeom>
+        </p:spPr>
+      </p:pic>
     </p:spTree>
   </p:cSld>
   <p:clrMapOvr>
@@ -7706,15 +8112,39 @@
           </a:p>
         </p:txBody>
       </p:sp>
-      <p:sp>
-        <p:nvSpPr>
-          <p:cNvPr id="29" name="TextBox 28"/>
+      <p:pic>
+        <p:nvPicPr>
+          <p:cNvPr id="29" name="Picture 28" descr="logo-banksumut.png"/>
+          <p:cNvPicPr>
+            <a:picLocks noChangeAspect="1"/>
+          </p:cNvPicPr>
+          <p:nvPr/>
+        </p:nvPicPr>
+        <p:blipFill>
+          <a:blip r:embed="rId2"/>
+          <a:stretch>
+            <a:fillRect/>
+          </a:stretch>
+        </p:blipFill>
+        <p:spPr>
+          <a:xfrm>
+            <a:off x="164592" y="6455664"/>
+            <a:ext cx="310896" cy="310896"/>
+          </a:xfrm>
+          <a:prstGeom prst="rect">
+            <a:avLst/>
+          </a:prstGeom>
+        </p:spPr>
+      </p:pic>
+      <p:sp>
+        <p:nvSpPr>
+          <p:cNvPr id="30" name="TextBox 29"/>
           <p:cNvSpPr txBox="1"/>
           <p:nvPr/>
         </p:nvSpPr>
         <p:spPr>
           <a:xfrm>
-            <a:off x="457200" y="6492240"/>
+            <a:off x="530352" y="6492240"/>
             <a:ext cx="5486400" cy="320040"/>
           </a:xfrm>
           <a:prstGeom prst="rect">
@@ -7743,7 +8173,7 @@
       </p:sp>
       <p:sp>
         <p:nvSpPr>
-          <p:cNvPr id="30" name="TextBox 29"/>
+          <p:cNvPr id="31" name="TextBox 30"/>
           <p:cNvSpPr txBox="1"/>
           <p:nvPr/>
         </p:nvSpPr>
@@ -7776,6 +8206,30 @@
           </a:p>
         </p:txBody>
       </p:sp>
+      <p:pic>
+        <p:nvPicPr>
+          <p:cNvPr id="32" name="Picture 31" descr="logo-banksumut.png"/>
+          <p:cNvPicPr>
+            <a:picLocks noChangeAspect="1"/>
+          </p:cNvPicPr>
+          <p:nvPr/>
+        </p:nvPicPr>
+        <p:blipFill>
+          <a:blip r:embed="rId2"/>
+          <a:stretch>
+            <a:fillRect/>
+          </a:stretch>
+        </p:blipFill>
+        <p:spPr>
+          <a:xfrm>
+            <a:off x="11350447" y="201168"/>
+            <a:ext cx="475488" cy="475488"/>
+          </a:xfrm>
+          <a:prstGeom prst="rect">
+            <a:avLst/>
+          </a:prstGeom>
+        </p:spPr>
+      </p:pic>
     </p:spTree>
   </p:cSld>
   <p:clrMapOvr>
@@ -8792,15 +9246,39 @@
           </a:p>
         </p:txBody>
       </p:sp>
-      <p:sp>
-        <p:nvSpPr>
-          <p:cNvPr id="21" name="TextBox 20"/>
+      <p:pic>
+        <p:nvPicPr>
+          <p:cNvPr id="21" name="Picture 20" descr="logo-banksumut.png"/>
+          <p:cNvPicPr>
+            <a:picLocks noChangeAspect="1"/>
+          </p:cNvPicPr>
+          <p:nvPr/>
+        </p:nvPicPr>
+        <p:blipFill>
+          <a:blip r:embed="rId2"/>
+          <a:stretch>
+            <a:fillRect/>
+          </a:stretch>
+        </p:blipFill>
+        <p:spPr>
+          <a:xfrm>
+            <a:off x="164592" y="6455664"/>
+            <a:ext cx="310896" cy="310896"/>
+          </a:xfrm>
+          <a:prstGeom prst="rect">
+            <a:avLst/>
+          </a:prstGeom>
+        </p:spPr>
+      </p:pic>
+      <p:sp>
+        <p:nvSpPr>
+          <p:cNvPr id="22" name="TextBox 21"/>
           <p:cNvSpPr txBox="1"/>
           <p:nvPr/>
         </p:nvSpPr>
         <p:spPr>
           <a:xfrm>
-            <a:off x="457200" y="6492240"/>
+            <a:off x="530352" y="6492240"/>
             <a:ext cx="5486400" cy="320040"/>
           </a:xfrm>
           <a:prstGeom prst="rect">
@@ -8829,7 +9307,7 @@
       </p:sp>
       <p:sp>
         <p:nvSpPr>
-          <p:cNvPr id="22" name="TextBox 21"/>
+          <p:cNvPr id="23" name="TextBox 22"/>
           <p:cNvSpPr txBox="1"/>
           <p:nvPr/>
         </p:nvSpPr>
@@ -8862,6 +9340,30 @@
           </a:p>
         </p:txBody>
       </p:sp>
+      <p:pic>
+        <p:nvPicPr>
+          <p:cNvPr id="24" name="Picture 23" descr="logo-banksumut.png"/>
+          <p:cNvPicPr>
+            <a:picLocks noChangeAspect="1"/>
+          </p:cNvPicPr>
+          <p:nvPr/>
+        </p:nvPicPr>
+        <p:blipFill>
+          <a:blip r:embed="rId2"/>
+          <a:stretch>
+            <a:fillRect/>
+          </a:stretch>
+        </p:blipFill>
+        <p:spPr>
+          <a:xfrm>
+            <a:off x="11350447" y="201168"/>
+            <a:ext cx="475488" cy="475488"/>
+          </a:xfrm>
+          <a:prstGeom prst="rect">
+            <a:avLst/>
+          </a:prstGeom>
+        </p:spPr>
+      </p:pic>
     </p:spTree>
   </p:cSld>
   <p:clrMapOvr>
@@ -9128,15 +9630,39 @@
           </a:p>
         </p:txBody>
       </p:sp>
-      <p:sp>
-        <p:nvSpPr>
-          <p:cNvPr id="8" name="TextBox 7"/>
+      <p:pic>
+        <p:nvPicPr>
+          <p:cNvPr id="8" name="Picture 7" descr="logo-banksumut.png"/>
+          <p:cNvPicPr>
+            <a:picLocks noChangeAspect="1"/>
+          </p:cNvPicPr>
+          <p:nvPr/>
+        </p:nvPicPr>
+        <p:blipFill>
+          <a:blip r:embed="rId3"/>
+          <a:stretch>
+            <a:fillRect/>
+          </a:stretch>
+        </p:blipFill>
+        <p:spPr>
+          <a:xfrm>
+            <a:off x="164592" y="6455664"/>
+            <a:ext cx="310896" cy="310896"/>
+          </a:xfrm>
+          <a:prstGeom prst="rect">
+            <a:avLst/>
+          </a:prstGeom>
+        </p:spPr>
+      </p:pic>
+      <p:sp>
+        <p:nvSpPr>
+          <p:cNvPr id="9" name="TextBox 8"/>
           <p:cNvSpPr txBox="1"/>
           <p:nvPr/>
         </p:nvSpPr>
         <p:spPr>
           <a:xfrm>
-            <a:off x="457200" y="6492240"/>
+            <a:off x="530352" y="6492240"/>
             <a:ext cx="5486400" cy="320040"/>
           </a:xfrm>
           <a:prstGeom prst="rect">
@@ -9165,7 +9691,7 @@
       </p:sp>
       <p:sp>
         <p:nvSpPr>
-          <p:cNvPr id="9" name="TextBox 8"/>
+          <p:cNvPr id="10" name="TextBox 9"/>
           <p:cNvSpPr txBox="1"/>
           <p:nvPr/>
         </p:nvSpPr>
@@ -9198,6 +9724,30 @@
           </a:p>
         </p:txBody>
       </p:sp>
+      <p:pic>
+        <p:nvPicPr>
+          <p:cNvPr id="11" name="Picture 10" descr="logo-banksumut.png"/>
+          <p:cNvPicPr>
+            <a:picLocks noChangeAspect="1"/>
+          </p:cNvPicPr>
+          <p:nvPr/>
+        </p:nvPicPr>
+        <p:blipFill>
+          <a:blip r:embed="rId3"/>
+          <a:stretch>
+            <a:fillRect/>
+          </a:stretch>
+        </p:blipFill>
+        <p:spPr>
+          <a:xfrm>
+            <a:off x="11350447" y="201168"/>
+            <a:ext cx="475488" cy="475488"/>
+          </a:xfrm>
+          <a:prstGeom prst="rect">
+            <a:avLst/>
+          </a:prstGeom>
+        </p:spPr>
+      </p:pic>
     </p:spTree>
   </p:cSld>
   <p:clrMapOvr>
@@ -9464,15 +10014,39 @@
           </a:p>
         </p:txBody>
       </p:sp>
-      <p:sp>
-        <p:nvSpPr>
-          <p:cNvPr id="8" name="TextBox 7"/>
+      <p:pic>
+        <p:nvPicPr>
+          <p:cNvPr id="8" name="Picture 7" descr="logo-banksumut.png"/>
+          <p:cNvPicPr>
+            <a:picLocks noChangeAspect="1"/>
+          </p:cNvPicPr>
+          <p:nvPr/>
+        </p:nvPicPr>
+        <p:blipFill>
+          <a:blip r:embed="rId3"/>
+          <a:stretch>
+            <a:fillRect/>
+          </a:stretch>
+        </p:blipFill>
+        <p:spPr>
+          <a:xfrm>
+            <a:off x="164592" y="6455664"/>
+            <a:ext cx="310896" cy="310896"/>
+          </a:xfrm>
+          <a:prstGeom prst="rect">
+            <a:avLst/>
+          </a:prstGeom>
+        </p:spPr>
+      </p:pic>
+      <p:sp>
+        <p:nvSpPr>
+          <p:cNvPr id="9" name="TextBox 8"/>
           <p:cNvSpPr txBox="1"/>
           <p:nvPr/>
         </p:nvSpPr>
         <p:spPr>
           <a:xfrm>
-            <a:off x="457200" y="6492240"/>
+            <a:off x="530352" y="6492240"/>
             <a:ext cx="5486400" cy="320040"/>
           </a:xfrm>
           <a:prstGeom prst="rect">
@@ -9501,7 +10075,7 @@
       </p:sp>
       <p:sp>
         <p:nvSpPr>
-          <p:cNvPr id="9" name="TextBox 8"/>
+          <p:cNvPr id="10" name="TextBox 9"/>
           <p:cNvSpPr txBox="1"/>
           <p:nvPr/>
         </p:nvSpPr>
@@ -9534,6 +10108,30 @@
           </a:p>
         </p:txBody>
       </p:sp>
+      <p:pic>
+        <p:nvPicPr>
+          <p:cNvPr id="11" name="Picture 10" descr="logo-banksumut.png"/>
+          <p:cNvPicPr>
+            <a:picLocks noChangeAspect="1"/>
+          </p:cNvPicPr>
+          <p:nvPr/>
+        </p:nvPicPr>
+        <p:blipFill>
+          <a:blip r:embed="rId3"/>
+          <a:stretch>
+            <a:fillRect/>
+          </a:stretch>
+        </p:blipFill>
+        <p:spPr>
+          <a:xfrm>
+            <a:off x="11350447" y="201168"/>
+            <a:ext cx="475488" cy="475488"/>
+          </a:xfrm>
+          <a:prstGeom prst="rect">
+            <a:avLst/>
+          </a:prstGeom>
+        </p:spPr>
+      </p:pic>
     </p:spTree>
   </p:cSld>
   <p:clrMapOvr>
@@ -9904,15 +10502,39 @@
           </a:p>
         </p:txBody>
       </p:sp>
-      <p:sp>
-        <p:nvSpPr>
-          <p:cNvPr id="11" name="TextBox 10"/>
+      <p:pic>
+        <p:nvPicPr>
+          <p:cNvPr id="11" name="Picture 10" descr="logo-banksumut.png"/>
+          <p:cNvPicPr>
+            <a:picLocks noChangeAspect="1"/>
+          </p:cNvPicPr>
+          <p:nvPr/>
+        </p:nvPicPr>
+        <p:blipFill>
+          <a:blip r:embed="rId4"/>
+          <a:stretch>
+            <a:fillRect/>
+          </a:stretch>
+        </p:blipFill>
+        <p:spPr>
+          <a:xfrm>
+            <a:off x="164592" y="6455664"/>
+            <a:ext cx="310896" cy="310896"/>
+          </a:xfrm>
+          <a:prstGeom prst="rect">
+            <a:avLst/>
+          </a:prstGeom>
+        </p:spPr>
+      </p:pic>
+      <p:sp>
+        <p:nvSpPr>
+          <p:cNvPr id="12" name="TextBox 11"/>
           <p:cNvSpPr txBox="1"/>
           <p:nvPr/>
         </p:nvSpPr>
         <p:spPr>
           <a:xfrm>
-            <a:off x="457200" y="6492240"/>
+            <a:off x="530352" y="6492240"/>
             <a:ext cx="5486400" cy="320040"/>
           </a:xfrm>
           <a:prstGeom prst="rect">
@@ -9941,7 +10563,7 @@
       </p:sp>
       <p:sp>
         <p:nvSpPr>
-          <p:cNvPr id="12" name="TextBox 11"/>
+          <p:cNvPr id="13" name="TextBox 12"/>
           <p:cNvSpPr txBox="1"/>
           <p:nvPr/>
         </p:nvSpPr>
@@ -9974,6 +10596,30 @@
           </a:p>
         </p:txBody>
       </p:sp>
+      <p:pic>
+        <p:nvPicPr>
+          <p:cNvPr id="14" name="Picture 13" descr="logo-banksumut.png"/>
+          <p:cNvPicPr>
+            <a:picLocks noChangeAspect="1"/>
+          </p:cNvPicPr>
+          <p:nvPr/>
+        </p:nvPicPr>
+        <p:blipFill>
+          <a:blip r:embed="rId4"/>
+          <a:stretch>
+            <a:fillRect/>
+          </a:stretch>
+        </p:blipFill>
+        <p:spPr>
+          <a:xfrm>
+            <a:off x="11350447" y="201168"/>
+            <a:ext cx="475488" cy="475488"/>
+          </a:xfrm>
+          <a:prstGeom prst="rect">
+            <a:avLst/>
+          </a:prstGeom>
+        </p:spPr>
+      </p:pic>
     </p:spTree>
   </p:cSld>
   <p:clrMapOvr>
@@ -10344,15 +10990,39 @@
           </a:p>
         </p:txBody>
       </p:sp>
-      <p:sp>
-        <p:nvSpPr>
-          <p:cNvPr id="11" name="TextBox 10"/>
+      <p:pic>
+        <p:nvPicPr>
+          <p:cNvPr id="11" name="Picture 10" descr="logo-banksumut.png"/>
+          <p:cNvPicPr>
+            <a:picLocks noChangeAspect="1"/>
+          </p:cNvPicPr>
+          <p:nvPr/>
+        </p:nvPicPr>
+        <p:blipFill>
+          <a:blip r:embed="rId4"/>
+          <a:stretch>
+            <a:fillRect/>
+          </a:stretch>
+        </p:blipFill>
+        <p:spPr>
+          <a:xfrm>
+            <a:off x="164592" y="6455664"/>
+            <a:ext cx="310896" cy="310896"/>
+          </a:xfrm>
+          <a:prstGeom prst="rect">
+            <a:avLst/>
+          </a:prstGeom>
+        </p:spPr>
+      </p:pic>
+      <p:sp>
+        <p:nvSpPr>
+          <p:cNvPr id="12" name="TextBox 11"/>
           <p:cNvSpPr txBox="1"/>
           <p:nvPr/>
         </p:nvSpPr>
         <p:spPr>
           <a:xfrm>
-            <a:off x="457200" y="6492240"/>
+            <a:off x="530352" y="6492240"/>
             <a:ext cx="5486400" cy="320040"/>
           </a:xfrm>
           <a:prstGeom prst="rect">
@@ -10381,7 +11051,7 @@
       </p:sp>
       <p:sp>
         <p:nvSpPr>
-          <p:cNvPr id="12" name="TextBox 11"/>
+          <p:cNvPr id="13" name="TextBox 12"/>
           <p:cNvSpPr txBox="1"/>
           <p:nvPr/>
         </p:nvSpPr>
@@ -10414,6 +11084,30 @@
           </a:p>
         </p:txBody>
       </p:sp>
+      <p:pic>
+        <p:nvPicPr>
+          <p:cNvPr id="14" name="Picture 13" descr="logo-banksumut.png"/>
+          <p:cNvPicPr>
+            <a:picLocks noChangeAspect="1"/>
+          </p:cNvPicPr>
+          <p:nvPr/>
+        </p:nvPicPr>
+        <p:blipFill>
+          <a:blip r:embed="rId4"/>
+          <a:stretch>
+            <a:fillRect/>
+          </a:stretch>
+        </p:blipFill>
+        <p:spPr>
+          <a:xfrm>
+            <a:off x="11350447" y="201168"/>
+            <a:ext cx="475488" cy="475488"/>
+          </a:xfrm>
+          <a:prstGeom prst="rect">
+            <a:avLst/>
+          </a:prstGeom>
+        </p:spPr>
+      </p:pic>
     </p:spTree>
   </p:cSld>
   <p:clrMapOvr>
@@ -11048,15 +11742,39 @@
           </a:p>
         </p:txBody>
       </p:sp>
-      <p:sp>
-        <p:nvSpPr>
-          <p:cNvPr id="13" name="TextBox 12"/>
+      <p:pic>
+        <p:nvPicPr>
+          <p:cNvPr id="13" name="Picture 12" descr="logo-banksumut.png"/>
+          <p:cNvPicPr>
+            <a:picLocks noChangeAspect="1"/>
+          </p:cNvPicPr>
+          <p:nvPr/>
+        </p:nvPicPr>
+        <p:blipFill>
+          <a:blip r:embed="rId2"/>
+          <a:stretch>
+            <a:fillRect/>
+          </a:stretch>
+        </p:blipFill>
+        <p:spPr>
+          <a:xfrm>
+            <a:off x="164592" y="6455664"/>
+            <a:ext cx="310896" cy="310896"/>
+          </a:xfrm>
+          <a:prstGeom prst="rect">
+            <a:avLst/>
+          </a:prstGeom>
+        </p:spPr>
+      </p:pic>
+      <p:sp>
+        <p:nvSpPr>
+          <p:cNvPr id="14" name="TextBox 13"/>
           <p:cNvSpPr txBox="1"/>
           <p:nvPr/>
         </p:nvSpPr>
         <p:spPr>
           <a:xfrm>
-            <a:off x="457200" y="6492240"/>
+            <a:off x="530352" y="6492240"/>
             <a:ext cx="5486400" cy="320040"/>
           </a:xfrm>
           <a:prstGeom prst="rect">
@@ -11085,7 +11803,7 @@
       </p:sp>
       <p:sp>
         <p:nvSpPr>
-          <p:cNvPr id="14" name="TextBox 13"/>
+          <p:cNvPr id="15" name="TextBox 14"/>
           <p:cNvSpPr txBox="1"/>
           <p:nvPr/>
         </p:nvSpPr>
@@ -11118,6 +11836,30 @@
           </a:p>
         </p:txBody>
       </p:sp>
+      <p:pic>
+        <p:nvPicPr>
+          <p:cNvPr id="16" name="Picture 15" descr="logo-banksumut.png"/>
+          <p:cNvPicPr>
+            <a:picLocks noChangeAspect="1"/>
+          </p:cNvPicPr>
+          <p:nvPr/>
+        </p:nvPicPr>
+        <p:blipFill>
+          <a:blip r:embed="rId2"/>
+          <a:stretch>
+            <a:fillRect/>
+          </a:stretch>
+        </p:blipFill>
+        <p:spPr>
+          <a:xfrm>
+            <a:off x="11350447" y="201168"/>
+            <a:ext cx="475488" cy="475488"/>
+          </a:xfrm>
+          <a:prstGeom prst="rect">
+            <a:avLst/>
+          </a:prstGeom>
+        </p:spPr>
+      </p:pic>
     </p:spTree>
   </p:cSld>
   <p:clrMapOvr>
@@ -11447,15 +12189,39 @@
           </a:p>
         </p:txBody>
       </p:sp>
-      <p:sp>
-        <p:nvSpPr>
-          <p:cNvPr id="6" name="TextBox 5"/>
+      <p:pic>
+        <p:nvPicPr>
+          <p:cNvPr id="6" name="Picture 5" descr="logo-banksumut.png"/>
+          <p:cNvPicPr>
+            <a:picLocks noChangeAspect="1"/>
+          </p:cNvPicPr>
+          <p:nvPr/>
+        </p:nvPicPr>
+        <p:blipFill>
+          <a:blip r:embed="rId2"/>
+          <a:stretch>
+            <a:fillRect/>
+          </a:stretch>
+        </p:blipFill>
+        <p:spPr>
+          <a:xfrm>
+            <a:off x="164592" y="6455664"/>
+            <a:ext cx="310896" cy="310896"/>
+          </a:xfrm>
+          <a:prstGeom prst="rect">
+            <a:avLst/>
+          </a:prstGeom>
+        </p:spPr>
+      </p:pic>
+      <p:sp>
+        <p:nvSpPr>
+          <p:cNvPr id="7" name="TextBox 6"/>
           <p:cNvSpPr txBox="1"/>
           <p:nvPr/>
         </p:nvSpPr>
         <p:spPr>
           <a:xfrm>
-            <a:off x="457200" y="6492240"/>
+            <a:off x="530352" y="6492240"/>
             <a:ext cx="5486400" cy="320040"/>
           </a:xfrm>
           <a:prstGeom prst="rect">
@@ -11484,7 +12250,7 @@
       </p:sp>
       <p:sp>
         <p:nvSpPr>
-          <p:cNvPr id="7" name="TextBox 6"/>
+          <p:cNvPr id="8" name="TextBox 7"/>
           <p:cNvSpPr txBox="1"/>
           <p:nvPr/>
         </p:nvSpPr>
@@ -11517,6 +12283,30 @@
           </a:p>
         </p:txBody>
       </p:sp>
+      <p:pic>
+        <p:nvPicPr>
+          <p:cNvPr id="9" name="Picture 8" descr="logo-banksumut.png"/>
+          <p:cNvPicPr>
+            <a:picLocks noChangeAspect="1"/>
+          </p:cNvPicPr>
+          <p:nvPr/>
+        </p:nvPicPr>
+        <p:blipFill>
+          <a:blip r:embed="rId2"/>
+          <a:stretch>
+            <a:fillRect/>
+          </a:stretch>
+        </p:blipFill>
+        <p:spPr>
+          <a:xfrm>
+            <a:off x="11350447" y="201168"/>
+            <a:ext cx="475488" cy="475488"/>
+          </a:xfrm>
+          <a:prstGeom prst="rect">
+            <a:avLst/>
+          </a:prstGeom>
+        </p:spPr>
+      </p:pic>
     </p:spTree>
   </p:cSld>
   <p:clrMapOvr>

</xml_diff>

<commit_message>
Replace custom logo with official Bank Sumut logo in PPT (small size)
Co-authored-by: kelompok8ai <kelompok8ai@users.noreply.github.com>
</commit_message>
<xml_diff>
--- a/CorpSec-Bank-Sumut-Presentasi.pptx
+++ b/CorpSec-Bank-Sumut-Presentasi.pptx
@@ -3271,7 +3271,7 @@
       </p:sp>
       <p:pic>
         <p:nvPicPr>
-          <p:cNvPr id="6" name="Picture 5" descr="logo-banksumut.png"/>
+          <p:cNvPr id="6" name="Picture 5" descr="logo-banksumut-official.png"/>
           <p:cNvPicPr>
             <a:picLocks noChangeAspect="1"/>
           </p:cNvPicPr>
@@ -3285,8 +3285,8 @@
         </p:blipFill>
         <p:spPr>
           <a:xfrm>
-            <a:off x="640080" y="502920"/>
-            <a:ext cx="685800" cy="685800"/>
+            <a:off x="502920" y="411480"/>
+            <a:ext cx="800295" cy="292608"/>
           </a:xfrm>
           <a:prstGeom prst="rect">
             <a:avLst/>
@@ -3295,42 +3295,7 @@
       </p:pic>
       <p:sp>
         <p:nvSpPr>
-          <p:cNvPr id="7" name="TextBox 6"/>
-          <p:cNvSpPr txBox="1"/>
-          <p:nvPr/>
-        </p:nvSpPr>
-        <p:spPr>
-          <a:xfrm>
-            <a:off x="1463040" y="566928"/>
-            <a:ext cx="3657600" cy="548640"/>
-          </a:xfrm>
-          <a:prstGeom prst="rect">
-            <a:avLst/>
-          </a:prstGeom>
-          <a:noFill/>
-        </p:spPr>
-        <p:txBody>
-          <a:bodyPr wrap="none">
-            <a:spAutoFit/>
-          </a:bodyPr>
-          <a:lstStyle/>
-          <a:p>
-            <a:pPr>
-              <a:defRPr sz="1800" b="1">
-                <a:solidFill>
-                  <a:srgbClr val="FFFFFF"/>
-                </a:solidFill>
-              </a:defRPr>
-            </a:pPr>
-            <a:r>
-              <a:t>Bank Sumut</a:t>
-            </a:r>
-          </a:p>
-        </p:txBody>
-      </p:sp>
-      <p:sp>
-        <p:nvSpPr>
-          <p:cNvPr id="8" name="Rectangle 7"/>
+          <p:cNvPr id="7" name="Rectangle 6"/>
           <p:cNvSpPr/>
           <p:nvPr/>
         </p:nvSpPr>
@@ -3373,7 +3338,7 @@
       </p:sp>
       <p:pic>
         <p:nvPicPr>
-          <p:cNvPr id="9" name="Picture 8" descr="logo-banksumut.png"/>
+          <p:cNvPr id="8" name="Picture 7" descr="logo-banksumut-official.png"/>
           <p:cNvPicPr>
             <a:picLocks noChangeAspect="1"/>
           </p:cNvPicPr>
@@ -3387,8 +3352,8 @@
         </p:blipFill>
         <p:spPr>
           <a:xfrm>
-            <a:off x="164592" y="6455664"/>
-            <a:ext cx="310896" cy="310896"/>
+            <a:off x="164592" y="6483096"/>
+            <a:ext cx="550203" cy="201168"/>
           </a:xfrm>
           <a:prstGeom prst="rect">
             <a:avLst/>
@@ -3397,13 +3362,13 @@
       </p:pic>
       <p:sp>
         <p:nvSpPr>
-          <p:cNvPr id="10" name="TextBox 9"/>
+          <p:cNvPr id="9" name="TextBox 8"/>
           <p:cNvSpPr txBox="1"/>
           <p:nvPr/>
         </p:nvSpPr>
         <p:spPr>
           <a:xfrm>
-            <a:off x="530352" y="6492240"/>
+            <a:off x="868680" y="6492240"/>
             <a:ext cx="5486400" cy="320040"/>
           </a:xfrm>
           <a:prstGeom prst="rect">
@@ -3432,7 +3397,7 @@
       </p:sp>
       <p:sp>
         <p:nvSpPr>
-          <p:cNvPr id="11" name="TextBox 10"/>
+          <p:cNvPr id="10" name="TextBox 9"/>
           <p:cNvSpPr txBox="1"/>
           <p:nvPr/>
         </p:nvSpPr>
@@ -3467,7 +3432,7 @@
       </p:sp>
       <p:pic>
         <p:nvPicPr>
-          <p:cNvPr id="12" name="Picture 11" descr="logo-banksumut.png"/>
+          <p:cNvPr id="11" name="Picture 10" descr="logo-banksumut-official.png"/>
           <p:cNvPicPr>
             <a:picLocks noChangeAspect="1"/>
           </p:cNvPicPr>
@@ -3481,8 +3446,8 @@
         </p:blipFill>
         <p:spPr>
           <a:xfrm>
-            <a:off x="11350447" y="201168"/>
-            <a:ext cx="475488" cy="475488"/>
+            <a:off x="11221415" y="228600"/>
+            <a:ext cx="650240" cy="237744"/>
           </a:xfrm>
           <a:prstGeom prst="rect">
             <a:avLst/>
@@ -3802,7 +3767,7 @@
       </p:sp>
       <p:pic>
         <p:nvPicPr>
-          <p:cNvPr id="6" name="Picture 5" descr="logo-banksumut.png"/>
+          <p:cNvPr id="6" name="Picture 5" descr="logo-banksumut-official.png"/>
           <p:cNvPicPr>
             <a:picLocks noChangeAspect="1"/>
           </p:cNvPicPr>
@@ -3816,8 +3781,8 @@
         </p:blipFill>
         <p:spPr>
           <a:xfrm>
-            <a:off x="164592" y="6455664"/>
-            <a:ext cx="310896" cy="310896"/>
+            <a:off x="164592" y="6483096"/>
+            <a:ext cx="550203" cy="201168"/>
           </a:xfrm>
           <a:prstGeom prst="rect">
             <a:avLst/>
@@ -3832,7 +3797,7 @@
         </p:nvSpPr>
         <p:spPr>
           <a:xfrm>
-            <a:off x="530352" y="6492240"/>
+            <a:off x="868680" y="6492240"/>
             <a:ext cx="5486400" cy="320040"/>
           </a:xfrm>
           <a:prstGeom prst="rect">
@@ -3896,7 +3861,7 @@
       </p:sp>
       <p:pic>
         <p:nvPicPr>
-          <p:cNvPr id="9" name="Picture 8" descr="logo-banksumut.png"/>
+          <p:cNvPr id="9" name="Picture 8" descr="logo-banksumut-official.png"/>
           <p:cNvPicPr>
             <a:picLocks noChangeAspect="1"/>
           </p:cNvPicPr>
@@ -3910,8 +3875,8 @@
         </p:blipFill>
         <p:spPr>
           <a:xfrm>
-            <a:off x="11350447" y="201168"/>
-            <a:ext cx="475488" cy="475488"/>
+            <a:off x="11221415" y="228600"/>
+            <a:ext cx="650240" cy="237744"/>
           </a:xfrm>
           <a:prstGeom prst="rect">
             <a:avLst/>
@@ -4614,7 +4579,7 @@
       </p:sp>
       <p:pic>
         <p:nvPicPr>
-          <p:cNvPr id="13" name="Picture 12" descr="logo-banksumut.png"/>
+          <p:cNvPr id="13" name="Picture 12" descr="logo-banksumut-official.png"/>
           <p:cNvPicPr>
             <a:picLocks noChangeAspect="1"/>
           </p:cNvPicPr>
@@ -4628,8 +4593,8 @@
         </p:blipFill>
         <p:spPr>
           <a:xfrm>
-            <a:off x="164592" y="6455664"/>
-            <a:ext cx="310896" cy="310896"/>
+            <a:off x="164592" y="6483096"/>
+            <a:ext cx="550203" cy="201168"/>
           </a:xfrm>
           <a:prstGeom prst="rect">
             <a:avLst/>
@@ -4644,7 +4609,7 @@
         </p:nvSpPr>
         <p:spPr>
           <a:xfrm>
-            <a:off x="530352" y="6492240"/>
+            <a:off x="868680" y="6492240"/>
             <a:ext cx="5486400" cy="320040"/>
           </a:xfrm>
           <a:prstGeom prst="rect">
@@ -4708,7 +4673,7 @@
       </p:sp>
       <p:pic>
         <p:nvPicPr>
-          <p:cNvPr id="16" name="Picture 15" descr="logo-banksumut.png"/>
+          <p:cNvPr id="16" name="Picture 15" descr="logo-banksumut-official.png"/>
           <p:cNvPicPr>
             <a:picLocks noChangeAspect="1"/>
           </p:cNvPicPr>
@@ -4722,8 +4687,8 @@
         </p:blipFill>
         <p:spPr>
           <a:xfrm>
-            <a:off x="11350447" y="201168"/>
-            <a:ext cx="475488" cy="475488"/>
+            <a:off x="11221415" y="228600"/>
+            <a:ext cx="650240" cy="237744"/>
           </a:xfrm>
           <a:prstGeom prst="rect">
             <a:avLst/>
@@ -5396,7 +5361,7 @@
       </p:sp>
       <p:pic>
         <p:nvPicPr>
-          <p:cNvPr id="13" name="Picture 12" descr="logo-banksumut.png"/>
+          <p:cNvPr id="13" name="Picture 12" descr="logo-banksumut-official.png"/>
           <p:cNvPicPr>
             <a:picLocks noChangeAspect="1"/>
           </p:cNvPicPr>
@@ -5410,8 +5375,8 @@
         </p:blipFill>
         <p:spPr>
           <a:xfrm>
-            <a:off x="164592" y="6455664"/>
-            <a:ext cx="310896" cy="310896"/>
+            <a:off x="164592" y="6483096"/>
+            <a:ext cx="550203" cy="201168"/>
           </a:xfrm>
           <a:prstGeom prst="rect">
             <a:avLst/>
@@ -5426,7 +5391,7 @@
         </p:nvSpPr>
         <p:spPr>
           <a:xfrm>
-            <a:off x="530352" y="6492240"/>
+            <a:off x="868680" y="6492240"/>
             <a:ext cx="5486400" cy="320040"/>
           </a:xfrm>
           <a:prstGeom prst="rect">
@@ -5490,7 +5455,7 @@
       </p:sp>
       <p:pic>
         <p:nvPicPr>
-          <p:cNvPr id="16" name="Picture 15" descr="logo-banksumut.png"/>
+          <p:cNvPr id="16" name="Picture 15" descr="logo-banksumut-official.png"/>
           <p:cNvPicPr>
             <a:picLocks noChangeAspect="1"/>
           </p:cNvPicPr>
@@ -5504,8 +5469,8 @@
         </p:blipFill>
         <p:spPr>
           <a:xfrm>
-            <a:off x="11350447" y="201168"/>
-            <a:ext cx="475488" cy="475488"/>
+            <a:off x="11221415" y="228600"/>
+            <a:ext cx="650240" cy="237744"/>
           </a:xfrm>
           <a:prstGeom prst="rect">
             <a:avLst/>
@@ -6294,7 +6259,7 @@
       </p:sp>
       <p:pic>
         <p:nvPicPr>
-          <p:cNvPr id="17" name="Picture 16" descr="logo-banksumut.png"/>
+          <p:cNvPr id="17" name="Picture 16" descr="logo-banksumut-official.png"/>
           <p:cNvPicPr>
             <a:picLocks noChangeAspect="1"/>
           </p:cNvPicPr>
@@ -6308,8 +6273,8 @@
         </p:blipFill>
         <p:spPr>
           <a:xfrm>
-            <a:off x="164592" y="6455664"/>
-            <a:ext cx="310896" cy="310896"/>
+            <a:off x="164592" y="6483096"/>
+            <a:ext cx="550203" cy="201168"/>
           </a:xfrm>
           <a:prstGeom prst="rect">
             <a:avLst/>
@@ -6324,7 +6289,7 @@
         </p:nvSpPr>
         <p:spPr>
           <a:xfrm>
-            <a:off x="530352" y="6492240"/>
+            <a:off x="868680" y="6492240"/>
             <a:ext cx="5486400" cy="320040"/>
           </a:xfrm>
           <a:prstGeom prst="rect">
@@ -6388,7 +6353,7 @@
       </p:sp>
       <p:pic>
         <p:nvPicPr>
-          <p:cNvPr id="20" name="Picture 19" descr="logo-banksumut.png"/>
+          <p:cNvPr id="20" name="Picture 19" descr="logo-banksumut-official.png"/>
           <p:cNvPicPr>
             <a:picLocks noChangeAspect="1"/>
           </p:cNvPicPr>
@@ -6402,8 +6367,8 @@
         </p:blipFill>
         <p:spPr>
           <a:xfrm>
-            <a:off x="11350447" y="201168"/>
-            <a:ext cx="475488" cy="475488"/>
+            <a:off x="11221415" y="228600"/>
+            <a:ext cx="650240" cy="237744"/>
           </a:xfrm>
           <a:prstGeom prst="rect">
             <a:avLst/>
@@ -6586,7 +6551,7 @@
       </p:sp>
       <p:pic>
         <p:nvPicPr>
-          <p:cNvPr id="6" name="Picture 5" descr="logo-banksumut.png"/>
+          <p:cNvPr id="6" name="Picture 5" descr="logo-banksumut-official.png"/>
           <p:cNvPicPr>
             <a:picLocks noChangeAspect="1"/>
           </p:cNvPicPr>
@@ -6600,8 +6565,8 @@
         </p:blipFill>
         <p:spPr>
           <a:xfrm>
-            <a:off x="640080" y="502920"/>
-            <a:ext cx="685800" cy="685800"/>
+            <a:off x="502920" y="411480"/>
+            <a:ext cx="800295" cy="292608"/>
           </a:xfrm>
           <a:prstGeom prst="rect">
             <a:avLst/>
@@ -6610,42 +6575,7 @@
       </p:pic>
       <p:sp>
         <p:nvSpPr>
-          <p:cNvPr id="7" name="TextBox 6"/>
-          <p:cNvSpPr txBox="1"/>
-          <p:nvPr/>
-        </p:nvSpPr>
-        <p:spPr>
-          <a:xfrm>
-            <a:off x="1463040" y="566928"/>
-            <a:ext cx="3657600" cy="548640"/>
-          </a:xfrm>
-          <a:prstGeom prst="rect">
-            <a:avLst/>
-          </a:prstGeom>
-          <a:noFill/>
-        </p:spPr>
-        <p:txBody>
-          <a:bodyPr wrap="none">
-            <a:spAutoFit/>
-          </a:bodyPr>
-          <a:lstStyle/>
-          <a:p>
-            <a:pPr>
-              <a:defRPr sz="1800" b="1">
-                <a:solidFill>
-                  <a:srgbClr val="FFFFFF"/>
-                </a:solidFill>
-              </a:defRPr>
-            </a:pPr>
-            <a:r>
-              <a:t>Bank Sumut</a:t>
-            </a:r>
-          </a:p>
-        </p:txBody>
-      </p:sp>
-      <p:sp>
-        <p:nvSpPr>
-          <p:cNvPr id="8" name="Rectangle 7"/>
+          <p:cNvPr id="7" name="Rectangle 6"/>
           <p:cNvSpPr/>
           <p:nvPr/>
         </p:nvSpPr>
@@ -6688,7 +6618,7 @@
       </p:sp>
       <p:pic>
         <p:nvPicPr>
-          <p:cNvPr id="9" name="Picture 8" descr="logo-banksumut.png"/>
+          <p:cNvPr id="8" name="Picture 7" descr="logo-banksumut-official.png"/>
           <p:cNvPicPr>
             <a:picLocks noChangeAspect="1"/>
           </p:cNvPicPr>
@@ -6702,8 +6632,8 @@
         </p:blipFill>
         <p:spPr>
           <a:xfrm>
-            <a:off x="164592" y="6455664"/>
-            <a:ext cx="310896" cy="310896"/>
+            <a:off x="164592" y="6483096"/>
+            <a:ext cx="550203" cy="201168"/>
           </a:xfrm>
           <a:prstGeom prst="rect">
             <a:avLst/>
@@ -6712,13 +6642,13 @@
       </p:pic>
       <p:sp>
         <p:nvSpPr>
-          <p:cNvPr id="10" name="TextBox 9"/>
+          <p:cNvPr id="9" name="TextBox 8"/>
           <p:cNvSpPr txBox="1"/>
           <p:nvPr/>
         </p:nvSpPr>
         <p:spPr>
           <a:xfrm>
-            <a:off x="530352" y="6492240"/>
+            <a:off x="868680" y="6492240"/>
             <a:ext cx="5486400" cy="320040"/>
           </a:xfrm>
           <a:prstGeom prst="rect">
@@ -6747,7 +6677,7 @@
       </p:sp>
       <p:sp>
         <p:nvSpPr>
-          <p:cNvPr id="11" name="TextBox 10"/>
+          <p:cNvPr id="10" name="TextBox 9"/>
           <p:cNvSpPr txBox="1"/>
           <p:nvPr/>
         </p:nvSpPr>
@@ -6782,7 +6712,7 @@
       </p:sp>
       <p:pic>
         <p:nvPicPr>
-          <p:cNvPr id="12" name="Picture 11" descr="logo-banksumut.png"/>
+          <p:cNvPr id="11" name="Picture 10" descr="logo-banksumut-official.png"/>
           <p:cNvPicPr>
             <a:picLocks noChangeAspect="1"/>
           </p:cNvPicPr>
@@ -6796,8 +6726,8 @@
         </p:blipFill>
         <p:spPr>
           <a:xfrm>
-            <a:off x="11350447" y="201168"/>
-            <a:ext cx="475488" cy="475488"/>
+            <a:off x="11221415" y="228600"/>
+            <a:ext cx="650240" cy="237744"/>
           </a:xfrm>
           <a:prstGeom prst="rect">
             <a:avLst/>
@@ -8114,7 +8044,7 @@
       </p:sp>
       <p:pic>
         <p:nvPicPr>
-          <p:cNvPr id="29" name="Picture 28" descr="logo-banksumut.png"/>
+          <p:cNvPr id="29" name="Picture 28" descr="logo-banksumut-official.png"/>
           <p:cNvPicPr>
             <a:picLocks noChangeAspect="1"/>
           </p:cNvPicPr>
@@ -8128,8 +8058,8 @@
         </p:blipFill>
         <p:spPr>
           <a:xfrm>
-            <a:off x="164592" y="6455664"/>
-            <a:ext cx="310896" cy="310896"/>
+            <a:off x="164592" y="6483096"/>
+            <a:ext cx="550203" cy="201168"/>
           </a:xfrm>
           <a:prstGeom prst="rect">
             <a:avLst/>
@@ -8144,7 +8074,7 @@
         </p:nvSpPr>
         <p:spPr>
           <a:xfrm>
-            <a:off x="530352" y="6492240"/>
+            <a:off x="868680" y="6492240"/>
             <a:ext cx="5486400" cy="320040"/>
           </a:xfrm>
           <a:prstGeom prst="rect">
@@ -8208,7 +8138,7 @@
       </p:sp>
       <p:pic>
         <p:nvPicPr>
-          <p:cNvPr id="32" name="Picture 31" descr="logo-banksumut.png"/>
+          <p:cNvPr id="32" name="Picture 31" descr="logo-banksumut-official.png"/>
           <p:cNvPicPr>
             <a:picLocks noChangeAspect="1"/>
           </p:cNvPicPr>
@@ -8222,8 +8152,8 @@
         </p:blipFill>
         <p:spPr>
           <a:xfrm>
-            <a:off x="11350447" y="201168"/>
-            <a:ext cx="475488" cy="475488"/>
+            <a:off x="11221415" y="228600"/>
+            <a:ext cx="650240" cy="237744"/>
           </a:xfrm>
           <a:prstGeom prst="rect">
             <a:avLst/>
@@ -9248,7 +9178,7 @@
       </p:sp>
       <p:pic>
         <p:nvPicPr>
-          <p:cNvPr id="21" name="Picture 20" descr="logo-banksumut.png"/>
+          <p:cNvPr id="21" name="Picture 20" descr="logo-banksumut-official.png"/>
           <p:cNvPicPr>
             <a:picLocks noChangeAspect="1"/>
           </p:cNvPicPr>
@@ -9262,8 +9192,8 @@
         </p:blipFill>
         <p:spPr>
           <a:xfrm>
-            <a:off x="164592" y="6455664"/>
-            <a:ext cx="310896" cy="310896"/>
+            <a:off x="164592" y="6483096"/>
+            <a:ext cx="550203" cy="201168"/>
           </a:xfrm>
           <a:prstGeom prst="rect">
             <a:avLst/>
@@ -9278,7 +9208,7 @@
         </p:nvSpPr>
         <p:spPr>
           <a:xfrm>
-            <a:off x="530352" y="6492240"/>
+            <a:off x="868680" y="6492240"/>
             <a:ext cx="5486400" cy="320040"/>
           </a:xfrm>
           <a:prstGeom prst="rect">
@@ -9342,7 +9272,7 @@
       </p:sp>
       <p:pic>
         <p:nvPicPr>
-          <p:cNvPr id="24" name="Picture 23" descr="logo-banksumut.png"/>
+          <p:cNvPr id="24" name="Picture 23" descr="logo-banksumut-official.png"/>
           <p:cNvPicPr>
             <a:picLocks noChangeAspect="1"/>
           </p:cNvPicPr>
@@ -9356,8 +9286,8 @@
         </p:blipFill>
         <p:spPr>
           <a:xfrm>
-            <a:off x="11350447" y="201168"/>
-            <a:ext cx="475488" cy="475488"/>
+            <a:off x="11221415" y="228600"/>
+            <a:ext cx="650240" cy="237744"/>
           </a:xfrm>
           <a:prstGeom prst="rect">
             <a:avLst/>
@@ -9632,7 +9562,7 @@
       </p:sp>
       <p:pic>
         <p:nvPicPr>
-          <p:cNvPr id="8" name="Picture 7" descr="logo-banksumut.png"/>
+          <p:cNvPr id="8" name="Picture 7" descr="logo-banksumut-official.png"/>
           <p:cNvPicPr>
             <a:picLocks noChangeAspect="1"/>
           </p:cNvPicPr>
@@ -9646,8 +9576,8 @@
         </p:blipFill>
         <p:spPr>
           <a:xfrm>
-            <a:off x="164592" y="6455664"/>
-            <a:ext cx="310896" cy="310896"/>
+            <a:off x="164592" y="6483096"/>
+            <a:ext cx="550203" cy="201168"/>
           </a:xfrm>
           <a:prstGeom prst="rect">
             <a:avLst/>
@@ -9662,7 +9592,7 @@
         </p:nvSpPr>
         <p:spPr>
           <a:xfrm>
-            <a:off x="530352" y="6492240"/>
+            <a:off x="868680" y="6492240"/>
             <a:ext cx="5486400" cy="320040"/>
           </a:xfrm>
           <a:prstGeom prst="rect">
@@ -9726,7 +9656,7 @@
       </p:sp>
       <p:pic>
         <p:nvPicPr>
-          <p:cNvPr id="11" name="Picture 10" descr="logo-banksumut.png"/>
+          <p:cNvPr id="11" name="Picture 10" descr="logo-banksumut-official.png"/>
           <p:cNvPicPr>
             <a:picLocks noChangeAspect="1"/>
           </p:cNvPicPr>
@@ -9740,8 +9670,8 @@
         </p:blipFill>
         <p:spPr>
           <a:xfrm>
-            <a:off x="11350447" y="201168"/>
-            <a:ext cx="475488" cy="475488"/>
+            <a:off x="11221415" y="228600"/>
+            <a:ext cx="650240" cy="237744"/>
           </a:xfrm>
           <a:prstGeom prst="rect">
             <a:avLst/>
@@ -10016,7 +9946,7 @@
       </p:sp>
       <p:pic>
         <p:nvPicPr>
-          <p:cNvPr id="8" name="Picture 7" descr="logo-banksumut.png"/>
+          <p:cNvPr id="8" name="Picture 7" descr="logo-banksumut-official.png"/>
           <p:cNvPicPr>
             <a:picLocks noChangeAspect="1"/>
           </p:cNvPicPr>
@@ -10030,8 +9960,8 @@
         </p:blipFill>
         <p:spPr>
           <a:xfrm>
-            <a:off x="164592" y="6455664"/>
-            <a:ext cx="310896" cy="310896"/>
+            <a:off x="164592" y="6483096"/>
+            <a:ext cx="550203" cy="201168"/>
           </a:xfrm>
           <a:prstGeom prst="rect">
             <a:avLst/>
@@ -10046,7 +9976,7 @@
         </p:nvSpPr>
         <p:spPr>
           <a:xfrm>
-            <a:off x="530352" y="6492240"/>
+            <a:off x="868680" y="6492240"/>
             <a:ext cx="5486400" cy="320040"/>
           </a:xfrm>
           <a:prstGeom prst="rect">
@@ -10110,7 +10040,7 @@
       </p:sp>
       <p:pic>
         <p:nvPicPr>
-          <p:cNvPr id="11" name="Picture 10" descr="logo-banksumut.png"/>
+          <p:cNvPr id="11" name="Picture 10" descr="logo-banksumut-official.png"/>
           <p:cNvPicPr>
             <a:picLocks noChangeAspect="1"/>
           </p:cNvPicPr>
@@ -10124,8 +10054,8 @@
         </p:blipFill>
         <p:spPr>
           <a:xfrm>
-            <a:off x="11350447" y="201168"/>
-            <a:ext cx="475488" cy="475488"/>
+            <a:off x="11221415" y="228600"/>
+            <a:ext cx="650240" cy="237744"/>
           </a:xfrm>
           <a:prstGeom prst="rect">
             <a:avLst/>
@@ -10504,7 +10434,7 @@
       </p:sp>
       <p:pic>
         <p:nvPicPr>
-          <p:cNvPr id="11" name="Picture 10" descr="logo-banksumut.png"/>
+          <p:cNvPr id="11" name="Picture 10" descr="logo-banksumut-official.png"/>
           <p:cNvPicPr>
             <a:picLocks noChangeAspect="1"/>
           </p:cNvPicPr>
@@ -10518,8 +10448,8 @@
         </p:blipFill>
         <p:spPr>
           <a:xfrm>
-            <a:off x="164592" y="6455664"/>
-            <a:ext cx="310896" cy="310896"/>
+            <a:off x="164592" y="6483096"/>
+            <a:ext cx="550203" cy="201168"/>
           </a:xfrm>
           <a:prstGeom prst="rect">
             <a:avLst/>
@@ -10534,7 +10464,7 @@
         </p:nvSpPr>
         <p:spPr>
           <a:xfrm>
-            <a:off x="530352" y="6492240"/>
+            <a:off x="868680" y="6492240"/>
             <a:ext cx="5486400" cy="320040"/>
           </a:xfrm>
           <a:prstGeom prst="rect">
@@ -10598,7 +10528,7 @@
       </p:sp>
       <p:pic>
         <p:nvPicPr>
-          <p:cNvPr id="14" name="Picture 13" descr="logo-banksumut.png"/>
+          <p:cNvPr id="14" name="Picture 13" descr="logo-banksumut-official.png"/>
           <p:cNvPicPr>
             <a:picLocks noChangeAspect="1"/>
           </p:cNvPicPr>
@@ -10612,8 +10542,8 @@
         </p:blipFill>
         <p:spPr>
           <a:xfrm>
-            <a:off x="11350447" y="201168"/>
-            <a:ext cx="475488" cy="475488"/>
+            <a:off x="11221415" y="228600"/>
+            <a:ext cx="650240" cy="237744"/>
           </a:xfrm>
           <a:prstGeom prst="rect">
             <a:avLst/>
@@ -10992,7 +10922,7 @@
       </p:sp>
       <p:pic>
         <p:nvPicPr>
-          <p:cNvPr id="11" name="Picture 10" descr="logo-banksumut.png"/>
+          <p:cNvPr id="11" name="Picture 10" descr="logo-banksumut-official.png"/>
           <p:cNvPicPr>
             <a:picLocks noChangeAspect="1"/>
           </p:cNvPicPr>
@@ -11006,8 +10936,8 @@
         </p:blipFill>
         <p:spPr>
           <a:xfrm>
-            <a:off x="164592" y="6455664"/>
-            <a:ext cx="310896" cy="310896"/>
+            <a:off x="164592" y="6483096"/>
+            <a:ext cx="550203" cy="201168"/>
           </a:xfrm>
           <a:prstGeom prst="rect">
             <a:avLst/>
@@ -11022,7 +10952,7 @@
         </p:nvSpPr>
         <p:spPr>
           <a:xfrm>
-            <a:off x="530352" y="6492240"/>
+            <a:off x="868680" y="6492240"/>
             <a:ext cx="5486400" cy="320040"/>
           </a:xfrm>
           <a:prstGeom prst="rect">
@@ -11086,7 +11016,7 @@
       </p:sp>
       <p:pic>
         <p:nvPicPr>
-          <p:cNvPr id="14" name="Picture 13" descr="logo-banksumut.png"/>
+          <p:cNvPr id="14" name="Picture 13" descr="logo-banksumut-official.png"/>
           <p:cNvPicPr>
             <a:picLocks noChangeAspect="1"/>
           </p:cNvPicPr>
@@ -11100,8 +11030,8 @@
         </p:blipFill>
         <p:spPr>
           <a:xfrm>
-            <a:off x="11350447" y="201168"/>
-            <a:ext cx="475488" cy="475488"/>
+            <a:off x="11221415" y="228600"/>
+            <a:ext cx="650240" cy="237744"/>
           </a:xfrm>
           <a:prstGeom prst="rect">
             <a:avLst/>
@@ -11744,7 +11674,7 @@
       </p:sp>
       <p:pic>
         <p:nvPicPr>
-          <p:cNvPr id="13" name="Picture 12" descr="logo-banksumut.png"/>
+          <p:cNvPr id="13" name="Picture 12" descr="logo-banksumut-official.png"/>
           <p:cNvPicPr>
             <a:picLocks noChangeAspect="1"/>
           </p:cNvPicPr>
@@ -11758,8 +11688,8 @@
         </p:blipFill>
         <p:spPr>
           <a:xfrm>
-            <a:off x="164592" y="6455664"/>
-            <a:ext cx="310896" cy="310896"/>
+            <a:off x="164592" y="6483096"/>
+            <a:ext cx="550203" cy="201168"/>
           </a:xfrm>
           <a:prstGeom prst="rect">
             <a:avLst/>
@@ -11774,7 +11704,7 @@
         </p:nvSpPr>
         <p:spPr>
           <a:xfrm>
-            <a:off x="530352" y="6492240"/>
+            <a:off x="868680" y="6492240"/>
             <a:ext cx="5486400" cy="320040"/>
           </a:xfrm>
           <a:prstGeom prst="rect">
@@ -11838,7 +11768,7 @@
       </p:sp>
       <p:pic>
         <p:nvPicPr>
-          <p:cNvPr id="16" name="Picture 15" descr="logo-banksumut.png"/>
+          <p:cNvPr id="16" name="Picture 15" descr="logo-banksumut-official.png"/>
           <p:cNvPicPr>
             <a:picLocks noChangeAspect="1"/>
           </p:cNvPicPr>
@@ -11852,8 +11782,8 @@
         </p:blipFill>
         <p:spPr>
           <a:xfrm>
-            <a:off x="11350447" y="201168"/>
-            <a:ext cx="475488" cy="475488"/>
+            <a:off x="11221415" y="228600"/>
+            <a:ext cx="650240" cy="237744"/>
           </a:xfrm>
           <a:prstGeom prst="rect">
             <a:avLst/>
@@ -12191,7 +12121,7 @@
       </p:sp>
       <p:pic>
         <p:nvPicPr>
-          <p:cNvPr id="6" name="Picture 5" descr="logo-banksumut.png"/>
+          <p:cNvPr id="6" name="Picture 5" descr="logo-banksumut-official.png"/>
           <p:cNvPicPr>
             <a:picLocks noChangeAspect="1"/>
           </p:cNvPicPr>
@@ -12205,8 +12135,8 @@
         </p:blipFill>
         <p:spPr>
           <a:xfrm>
-            <a:off x="164592" y="6455664"/>
-            <a:ext cx="310896" cy="310896"/>
+            <a:off x="164592" y="6483096"/>
+            <a:ext cx="550203" cy="201168"/>
           </a:xfrm>
           <a:prstGeom prst="rect">
             <a:avLst/>
@@ -12221,7 +12151,7 @@
         </p:nvSpPr>
         <p:spPr>
           <a:xfrm>
-            <a:off x="530352" y="6492240"/>
+            <a:off x="868680" y="6492240"/>
             <a:ext cx="5486400" cy="320040"/>
           </a:xfrm>
           <a:prstGeom prst="rect">
@@ -12285,7 +12215,7 @@
       </p:sp>
       <p:pic>
         <p:nvPicPr>
-          <p:cNvPr id="9" name="Picture 8" descr="logo-banksumut.png"/>
+          <p:cNvPr id="9" name="Picture 8" descr="logo-banksumut-official.png"/>
           <p:cNvPicPr>
             <a:picLocks noChangeAspect="1"/>
           </p:cNvPicPr>
@@ -12299,8 +12229,8 @@
         </p:blipFill>
         <p:spPr>
           <a:xfrm>
-            <a:off x="11350447" y="201168"/>
-            <a:ext cx="475488" cy="475488"/>
+            <a:off x="11221415" y="228600"/>
+            <a:ext cx="650240" cy="237744"/>
           </a:xfrm>
           <a:prstGeom prst="rect">
             <a:avLst/>

</xml_diff>

<commit_message>
Fix PPT logo: use actual Bank Sumut logo (orange Bank + navy SUMUT)
Co-authored-by: kelompok8ai <kelompok8ai@users.noreply.github.com>
</commit_message>
<xml_diff>
--- a/CorpSec-Bank-Sumut-Presentasi.pptx
+++ b/CorpSec-Bank-Sumut-Presentasi.pptx
@@ -3271,7 +3271,7 @@
       </p:sp>
       <p:pic>
         <p:nvPicPr>
-          <p:cNvPr id="6" name="Picture 5" descr="logo-banksumut-official.png"/>
+          <p:cNvPr id="6" name="Picture 5" descr="logo-banksumut-light.png"/>
           <p:cNvPicPr>
             <a:picLocks noChangeAspect="1"/>
           </p:cNvPicPr>
@@ -3286,7 +3286,7 @@
         <p:spPr>
           <a:xfrm>
             <a:off x="502920" y="411480"/>
-            <a:ext cx="800295" cy="292608"/>
+            <a:ext cx="1041167" cy="292608"/>
           </a:xfrm>
           <a:prstGeom prst="rect">
             <a:avLst/>
@@ -3338,7 +3338,7 @@
       </p:sp>
       <p:pic>
         <p:nvPicPr>
-          <p:cNvPr id="8" name="Picture 7" descr="logo-banksumut-official.png"/>
+          <p:cNvPr id="8" name="Picture 7" descr="logo-banksumut-light.png"/>
           <p:cNvPicPr>
             <a:picLocks noChangeAspect="1"/>
           </p:cNvPicPr>
@@ -3353,7 +3353,7 @@
         <p:spPr>
           <a:xfrm>
             <a:off x="164592" y="6483096"/>
-            <a:ext cx="550203" cy="201168"/>
+            <a:ext cx="715802" cy="201168"/>
           </a:xfrm>
           <a:prstGeom prst="rect">
             <a:avLst/>
@@ -3432,7 +3432,7 @@
       </p:sp>
       <p:pic>
         <p:nvPicPr>
-          <p:cNvPr id="11" name="Picture 10" descr="logo-banksumut-official.png"/>
+          <p:cNvPr id="11" name="Picture 10" descr="logo-banksumut-light.png"/>
           <p:cNvPicPr>
             <a:picLocks noChangeAspect="1"/>
           </p:cNvPicPr>
@@ -3446,8 +3446,8 @@
         </p:blipFill>
         <p:spPr>
           <a:xfrm>
-            <a:off x="11221415" y="228600"/>
-            <a:ext cx="650240" cy="237744"/>
+            <a:off x="11025706" y="228600"/>
+            <a:ext cx="845948" cy="237744"/>
           </a:xfrm>
           <a:prstGeom prst="rect">
             <a:avLst/>
@@ -3767,7 +3767,7 @@
       </p:sp>
       <p:pic>
         <p:nvPicPr>
-          <p:cNvPr id="6" name="Picture 5" descr="logo-banksumut-official.png"/>
+          <p:cNvPr id="6" name="Picture 5" descr="logo-banksumut-light.png"/>
           <p:cNvPicPr>
             <a:picLocks noChangeAspect="1"/>
           </p:cNvPicPr>
@@ -3782,7 +3782,7 @@
         <p:spPr>
           <a:xfrm>
             <a:off x="164592" y="6483096"/>
-            <a:ext cx="550203" cy="201168"/>
+            <a:ext cx="715802" cy="201168"/>
           </a:xfrm>
           <a:prstGeom prst="rect">
             <a:avLst/>
@@ -3861,7 +3861,7 @@
       </p:sp>
       <p:pic>
         <p:nvPicPr>
-          <p:cNvPr id="9" name="Picture 8" descr="logo-banksumut-official.png"/>
+          <p:cNvPr id="9" name="Picture 8" descr="logo-banksumut-light.png"/>
           <p:cNvPicPr>
             <a:picLocks noChangeAspect="1"/>
           </p:cNvPicPr>
@@ -3875,8 +3875,8 @@
         </p:blipFill>
         <p:spPr>
           <a:xfrm>
-            <a:off x="11221415" y="228600"/>
-            <a:ext cx="650240" cy="237744"/>
+            <a:off x="11025706" y="228600"/>
+            <a:ext cx="845948" cy="237744"/>
           </a:xfrm>
           <a:prstGeom prst="rect">
             <a:avLst/>
@@ -4579,7 +4579,7 @@
       </p:sp>
       <p:pic>
         <p:nvPicPr>
-          <p:cNvPr id="13" name="Picture 12" descr="logo-banksumut-official.png"/>
+          <p:cNvPr id="13" name="Picture 12" descr="logo-banksumut-light.png"/>
           <p:cNvPicPr>
             <a:picLocks noChangeAspect="1"/>
           </p:cNvPicPr>
@@ -4594,7 +4594,7 @@
         <p:spPr>
           <a:xfrm>
             <a:off x="164592" y="6483096"/>
-            <a:ext cx="550203" cy="201168"/>
+            <a:ext cx="715802" cy="201168"/>
           </a:xfrm>
           <a:prstGeom prst="rect">
             <a:avLst/>
@@ -4673,7 +4673,7 @@
       </p:sp>
       <p:pic>
         <p:nvPicPr>
-          <p:cNvPr id="16" name="Picture 15" descr="logo-banksumut-official.png"/>
+          <p:cNvPr id="16" name="Picture 15" descr="logo-banksumut-light.png"/>
           <p:cNvPicPr>
             <a:picLocks noChangeAspect="1"/>
           </p:cNvPicPr>
@@ -4687,8 +4687,8 @@
         </p:blipFill>
         <p:spPr>
           <a:xfrm>
-            <a:off x="11221415" y="228600"/>
-            <a:ext cx="650240" cy="237744"/>
+            <a:off x="11025706" y="228600"/>
+            <a:ext cx="845948" cy="237744"/>
           </a:xfrm>
           <a:prstGeom prst="rect">
             <a:avLst/>
@@ -5361,7 +5361,7 @@
       </p:sp>
       <p:pic>
         <p:nvPicPr>
-          <p:cNvPr id="13" name="Picture 12" descr="logo-banksumut-official.png"/>
+          <p:cNvPr id="13" name="Picture 12" descr="logo-banksumut-light.png"/>
           <p:cNvPicPr>
             <a:picLocks noChangeAspect="1"/>
           </p:cNvPicPr>
@@ -5376,7 +5376,7 @@
         <p:spPr>
           <a:xfrm>
             <a:off x="164592" y="6483096"/>
-            <a:ext cx="550203" cy="201168"/>
+            <a:ext cx="715802" cy="201168"/>
           </a:xfrm>
           <a:prstGeom prst="rect">
             <a:avLst/>
@@ -5455,7 +5455,7 @@
       </p:sp>
       <p:pic>
         <p:nvPicPr>
-          <p:cNvPr id="16" name="Picture 15" descr="logo-banksumut-official.png"/>
+          <p:cNvPr id="16" name="Picture 15" descr="logo-banksumut-light.png"/>
           <p:cNvPicPr>
             <a:picLocks noChangeAspect="1"/>
           </p:cNvPicPr>
@@ -5469,8 +5469,8 @@
         </p:blipFill>
         <p:spPr>
           <a:xfrm>
-            <a:off x="11221415" y="228600"/>
-            <a:ext cx="650240" cy="237744"/>
+            <a:off x="11025706" y="228600"/>
+            <a:ext cx="845948" cy="237744"/>
           </a:xfrm>
           <a:prstGeom prst="rect">
             <a:avLst/>
@@ -6259,7 +6259,7 @@
       </p:sp>
       <p:pic>
         <p:nvPicPr>
-          <p:cNvPr id="17" name="Picture 16" descr="logo-banksumut-official.png"/>
+          <p:cNvPr id="17" name="Picture 16" descr="logo-banksumut-light.png"/>
           <p:cNvPicPr>
             <a:picLocks noChangeAspect="1"/>
           </p:cNvPicPr>
@@ -6274,7 +6274,7 @@
         <p:spPr>
           <a:xfrm>
             <a:off x="164592" y="6483096"/>
-            <a:ext cx="550203" cy="201168"/>
+            <a:ext cx="715802" cy="201168"/>
           </a:xfrm>
           <a:prstGeom prst="rect">
             <a:avLst/>
@@ -6353,7 +6353,7 @@
       </p:sp>
       <p:pic>
         <p:nvPicPr>
-          <p:cNvPr id="20" name="Picture 19" descr="logo-banksumut-official.png"/>
+          <p:cNvPr id="20" name="Picture 19" descr="logo-banksumut-light.png"/>
           <p:cNvPicPr>
             <a:picLocks noChangeAspect="1"/>
           </p:cNvPicPr>
@@ -6367,8 +6367,8 @@
         </p:blipFill>
         <p:spPr>
           <a:xfrm>
-            <a:off x="11221415" y="228600"/>
-            <a:ext cx="650240" cy="237744"/>
+            <a:off x="11025706" y="228600"/>
+            <a:ext cx="845948" cy="237744"/>
           </a:xfrm>
           <a:prstGeom prst="rect">
             <a:avLst/>
@@ -6551,7 +6551,7 @@
       </p:sp>
       <p:pic>
         <p:nvPicPr>
-          <p:cNvPr id="6" name="Picture 5" descr="logo-banksumut-official.png"/>
+          <p:cNvPr id="6" name="Picture 5" descr="logo-banksumut-light.png"/>
           <p:cNvPicPr>
             <a:picLocks noChangeAspect="1"/>
           </p:cNvPicPr>
@@ -6566,7 +6566,7 @@
         <p:spPr>
           <a:xfrm>
             <a:off x="502920" y="411480"/>
-            <a:ext cx="800295" cy="292608"/>
+            <a:ext cx="1041167" cy="292608"/>
           </a:xfrm>
           <a:prstGeom prst="rect">
             <a:avLst/>
@@ -6618,7 +6618,7 @@
       </p:sp>
       <p:pic>
         <p:nvPicPr>
-          <p:cNvPr id="8" name="Picture 7" descr="logo-banksumut-official.png"/>
+          <p:cNvPr id="8" name="Picture 7" descr="logo-banksumut-light.png"/>
           <p:cNvPicPr>
             <a:picLocks noChangeAspect="1"/>
           </p:cNvPicPr>
@@ -6633,7 +6633,7 @@
         <p:spPr>
           <a:xfrm>
             <a:off x="164592" y="6483096"/>
-            <a:ext cx="550203" cy="201168"/>
+            <a:ext cx="715802" cy="201168"/>
           </a:xfrm>
           <a:prstGeom prst="rect">
             <a:avLst/>
@@ -6712,7 +6712,7 @@
       </p:sp>
       <p:pic>
         <p:nvPicPr>
-          <p:cNvPr id="11" name="Picture 10" descr="logo-banksumut-official.png"/>
+          <p:cNvPr id="11" name="Picture 10" descr="logo-banksumut-light.png"/>
           <p:cNvPicPr>
             <a:picLocks noChangeAspect="1"/>
           </p:cNvPicPr>
@@ -6726,8 +6726,8 @@
         </p:blipFill>
         <p:spPr>
           <a:xfrm>
-            <a:off x="11221415" y="228600"/>
-            <a:ext cx="650240" cy="237744"/>
+            <a:off x="11025706" y="228600"/>
+            <a:ext cx="845948" cy="237744"/>
           </a:xfrm>
           <a:prstGeom prst="rect">
             <a:avLst/>
@@ -8044,7 +8044,7 @@
       </p:sp>
       <p:pic>
         <p:nvPicPr>
-          <p:cNvPr id="29" name="Picture 28" descr="logo-banksumut-official.png"/>
+          <p:cNvPr id="29" name="Picture 28" descr="logo-banksumut-light.png"/>
           <p:cNvPicPr>
             <a:picLocks noChangeAspect="1"/>
           </p:cNvPicPr>
@@ -8059,7 +8059,7 @@
         <p:spPr>
           <a:xfrm>
             <a:off x="164592" y="6483096"/>
-            <a:ext cx="550203" cy="201168"/>
+            <a:ext cx="715802" cy="201168"/>
           </a:xfrm>
           <a:prstGeom prst="rect">
             <a:avLst/>
@@ -8138,7 +8138,7 @@
       </p:sp>
       <p:pic>
         <p:nvPicPr>
-          <p:cNvPr id="32" name="Picture 31" descr="logo-banksumut-official.png"/>
+          <p:cNvPr id="32" name="Picture 31" descr="logo-banksumut-light.png"/>
           <p:cNvPicPr>
             <a:picLocks noChangeAspect="1"/>
           </p:cNvPicPr>
@@ -8152,8 +8152,8 @@
         </p:blipFill>
         <p:spPr>
           <a:xfrm>
-            <a:off x="11221415" y="228600"/>
-            <a:ext cx="650240" cy="237744"/>
+            <a:off x="11025706" y="228600"/>
+            <a:ext cx="845948" cy="237744"/>
           </a:xfrm>
           <a:prstGeom prst="rect">
             <a:avLst/>
@@ -9178,7 +9178,7 @@
       </p:sp>
       <p:pic>
         <p:nvPicPr>
-          <p:cNvPr id="21" name="Picture 20" descr="logo-banksumut-official.png"/>
+          <p:cNvPr id="21" name="Picture 20" descr="logo-banksumut-light.png"/>
           <p:cNvPicPr>
             <a:picLocks noChangeAspect="1"/>
           </p:cNvPicPr>
@@ -9193,7 +9193,7 @@
         <p:spPr>
           <a:xfrm>
             <a:off x="164592" y="6483096"/>
-            <a:ext cx="550203" cy="201168"/>
+            <a:ext cx="715802" cy="201168"/>
           </a:xfrm>
           <a:prstGeom prst="rect">
             <a:avLst/>
@@ -9272,7 +9272,7 @@
       </p:sp>
       <p:pic>
         <p:nvPicPr>
-          <p:cNvPr id="24" name="Picture 23" descr="logo-banksumut-official.png"/>
+          <p:cNvPr id="24" name="Picture 23" descr="logo-banksumut-light.png"/>
           <p:cNvPicPr>
             <a:picLocks noChangeAspect="1"/>
           </p:cNvPicPr>
@@ -9286,8 +9286,8 @@
         </p:blipFill>
         <p:spPr>
           <a:xfrm>
-            <a:off x="11221415" y="228600"/>
-            <a:ext cx="650240" cy="237744"/>
+            <a:off x="11025706" y="228600"/>
+            <a:ext cx="845948" cy="237744"/>
           </a:xfrm>
           <a:prstGeom prst="rect">
             <a:avLst/>
@@ -9562,7 +9562,7 @@
       </p:sp>
       <p:pic>
         <p:nvPicPr>
-          <p:cNvPr id="8" name="Picture 7" descr="logo-banksumut-official.png"/>
+          <p:cNvPr id="8" name="Picture 7" descr="logo-banksumut-light.png"/>
           <p:cNvPicPr>
             <a:picLocks noChangeAspect="1"/>
           </p:cNvPicPr>
@@ -9577,7 +9577,7 @@
         <p:spPr>
           <a:xfrm>
             <a:off x="164592" y="6483096"/>
-            <a:ext cx="550203" cy="201168"/>
+            <a:ext cx="715802" cy="201168"/>
           </a:xfrm>
           <a:prstGeom prst="rect">
             <a:avLst/>
@@ -9656,7 +9656,7 @@
       </p:sp>
       <p:pic>
         <p:nvPicPr>
-          <p:cNvPr id="11" name="Picture 10" descr="logo-banksumut-official.png"/>
+          <p:cNvPr id="11" name="Picture 10" descr="logo-banksumut-light.png"/>
           <p:cNvPicPr>
             <a:picLocks noChangeAspect="1"/>
           </p:cNvPicPr>
@@ -9670,8 +9670,8 @@
         </p:blipFill>
         <p:spPr>
           <a:xfrm>
-            <a:off x="11221415" y="228600"/>
-            <a:ext cx="650240" cy="237744"/>
+            <a:off x="11025706" y="228600"/>
+            <a:ext cx="845948" cy="237744"/>
           </a:xfrm>
           <a:prstGeom prst="rect">
             <a:avLst/>
@@ -9946,7 +9946,7 @@
       </p:sp>
       <p:pic>
         <p:nvPicPr>
-          <p:cNvPr id="8" name="Picture 7" descr="logo-banksumut-official.png"/>
+          <p:cNvPr id="8" name="Picture 7" descr="logo-banksumut-light.png"/>
           <p:cNvPicPr>
             <a:picLocks noChangeAspect="1"/>
           </p:cNvPicPr>
@@ -9961,7 +9961,7 @@
         <p:spPr>
           <a:xfrm>
             <a:off x="164592" y="6483096"/>
-            <a:ext cx="550203" cy="201168"/>
+            <a:ext cx="715802" cy="201168"/>
           </a:xfrm>
           <a:prstGeom prst="rect">
             <a:avLst/>
@@ -10040,7 +10040,7 @@
       </p:sp>
       <p:pic>
         <p:nvPicPr>
-          <p:cNvPr id="11" name="Picture 10" descr="logo-banksumut-official.png"/>
+          <p:cNvPr id="11" name="Picture 10" descr="logo-banksumut-light.png"/>
           <p:cNvPicPr>
             <a:picLocks noChangeAspect="1"/>
           </p:cNvPicPr>
@@ -10054,8 +10054,8 @@
         </p:blipFill>
         <p:spPr>
           <a:xfrm>
-            <a:off x="11221415" y="228600"/>
-            <a:ext cx="650240" cy="237744"/>
+            <a:off x="11025706" y="228600"/>
+            <a:ext cx="845948" cy="237744"/>
           </a:xfrm>
           <a:prstGeom prst="rect">
             <a:avLst/>
@@ -10434,7 +10434,7 @@
       </p:sp>
       <p:pic>
         <p:nvPicPr>
-          <p:cNvPr id="11" name="Picture 10" descr="logo-banksumut-official.png"/>
+          <p:cNvPr id="11" name="Picture 10" descr="logo-banksumut-light.png"/>
           <p:cNvPicPr>
             <a:picLocks noChangeAspect="1"/>
           </p:cNvPicPr>
@@ -10449,7 +10449,7 @@
         <p:spPr>
           <a:xfrm>
             <a:off x="164592" y="6483096"/>
-            <a:ext cx="550203" cy="201168"/>
+            <a:ext cx="715802" cy="201168"/>
           </a:xfrm>
           <a:prstGeom prst="rect">
             <a:avLst/>
@@ -10528,7 +10528,7 @@
       </p:sp>
       <p:pic>
         <p:nvPicPr>
-          <p:cNvPr id="14" name="Picture 13" descr="logo-banksumut-official.png"/>
+          <p:cNvPr id="14" name="Picture 13" descr="logo-banksumut-light.png"/>
           <p:cNvPicPr>
             <a:picLocks noChangeAspect="1"/>
           </p:cNvPicPr>
@@ -10542,8 +10542,8 @@
         </p:blipFill>
         <p:spPr>
           <a:xfrm>
-            <a:off x="11221415" y="228600"/>
-            <a:ext cx="650240" cy="237744"/>
+            <a:off x="11025706" y="228600"/>
+            <a:ext cx="845948" cy="237744"/>
           </a:xfrm>
           <a:prstGeom prst="rect">
             <a:avLst/>
@@ -10922,7 +10922,7 @@
       </p:sp>
       <p:pic>
         <p:nvPicPr>
-          <p:cNvPr id="11" name="Picture 10" descr="logo-banksumut-official.png"/>
+          <p:cNvPr id="11" name="Picture 10" descr="logo-banksumut-light.png"/>
           <p:cNvPicPr>
             <a:picLocks noChangeAspect="1"/>
           </p:cNvPicPr>
@@ -10937,7 +10937,7 @@
         <p:spPr>
           <a:xfrm>
             <a:off x="164592" y="6483096"/>
-            <a:ext cx="550203" cy="201168"/>
+            <a:ext cx="715802" cy="201168"/>
           </a:xfrm>
           <a:prstGeom prst="rect">
             <a:avLst/>
@@ -11016,7 +11016,7 @@
       </p:sp>
       <p:pic>
         <p:nvPicPr>
-          <p:cNvPr id="14" name="Picture 13" descr="logo-banksumut-official.png"/>
+          <p:cNvPr id="14" name="Picture 13" descr="logo-banksumut-light.png"/>
           <p:cNvPicPr>
             <a:picLocks noChangeAspect="1"/>
           </p:cNvPicPr>
@@ -11030,8 +11030,8 @@
         </p:blipFill>
         <p:spPr>
           <a:xfrm>
-            <a:off x="11221415" y="228600"/>
-            <a:ext cx="650240" cy="237744"/>
+            <a:off x="11025706" y="228600"/>
+            <a:ext cx="845948" cy="237744"/>
           </a:xfrm>
           <a:prstGeom prst="rect">
             <a:avLst/>
@@ -11674,7 +11674,7 @@
       </p:sp>
       <p:pic>
         <p:nvPicPr>
-          <p:cNvPr id="13" name="Picture 12" descr="logo-banksumut-official.png"/>
+          <p:cNvPr id="13" name="Picture 12" descr="logo-banksumut-light.png"/>
           <p:cNvPicPr>
             <a:picLocks noChangeAspect="1"/>
           </p:cNvPicPr>
@@ -11689,7 +11689,7 @@
         <p:spPr>
           <a:xfrm>
             <a:off x="164592" y="6483096"/>
-            <a:ext cx="550203" cy="201168"/>
+            <a:ext cx="715802" cy="201168"/>
           </a:xfrm>
           <a:prstGeom prst="rect">
             <a:avLst/>
@@ -11768,7 +11768,7 @@
       </p:sp>
       <p:pic>
         <p:nvPicPr>
-          <p:cNvPr id="16" name="Picture 15" descr="logo-banksumut-official.png"/>
+          <p:cNvPr id="16" name="Picture 15" descr="logo-banksumut-light.png"/>
           <p:cNvPicPr>
             <a:picLocks noChangeAspect="1"/>
           </p:cNvPicPr>
@@ -11782,8 +11782,8 @@
         </p:blipFill>
         <p:spPr>
           <a:xfrm>
-            <a:off x="11221415" y="228600"/>
-            <a:ext cx="650240" cy="237744"/>
+            <a:off x="11025706" y="228600"/>
+            <a:ext cx="845948" cy="237744"/>
           </a:xfrm>
           <a:prstGeom prst="rect">
             <a:avLst/>
@@ -12121,7 +12121,7 @@
       </p:sp>
       <p:pic>
         <p:nvPicPr>
-          <p:cNvPr id="6" name="Picture 5" descr="logo-banksumut-official.png"/>
+          <p:cNvPr id="6" name="Picture 5" descr="logo-banksumut-light.png"/>
           <p:cNvPicPr>
             <a:picLocks noChangeAspect="1"/>
           </p:cNvPicPr>
@@ -12136,7 +12136,7 @@
         <p:spPr>
           <a:xfrm>
             <a:off x="164592" y="6483096"/>
-            <a:ext cx="550203" cy="201168"/>
+            <a:ext cx="715802" cy="201168"/>
           </a:xfrm>
           <a:prstGeom prst="rect">
             <a:avLst/>
@@ -12215,7 +12215,7 @@
       </p:sp>
       <p:pic>
         <p:nvPicPr>
-          <p:cNvPr id="9" name="Picture 8" descr="logo-banksumut-official.png"/>
+          <p:cNvPr id="9" name="Picture 8" descr="logo-banksumut-light.png"/>
           <p:cNvPicPr>
             <a:picLocks noChangeAspect="1"/>
           </p:cNvPicPr>
@@ -12229,8 +12229,8 @@
         </p:blipFill>
         <p:spPr>
           <a:xfrm>
-            <a:off x="11221415" y="228600"/>
-            <a:ext cx="650240" cy="237744"/>
+            <a:off x="11025706" y="228600"/>
+            <a:ext cx="845948" cy="237744"/>
           </a:xfrm>
           <a:prstGeom prst="rect">
             <a:avLst/>

</xml_diff>